<commit_message>
Add Azure SSO setup to all guides (Markdown, Word, PowerPoint)
Co-authored-by: factory-droid[bot] <138933559+factory-droid[bot]@users.noreply.github.com>
</commit_message>
<xml_diff>
--- a/Factory_AI_Dashboard_Guide.pptx
+++ b/Factory_AI_Dashboard_Guide.pptx
@@ -18,6 +18,13 @@
     <p:sldId id="266" r:id="rId17"/>
     <p:sldId id="267" r:id="rId18"/>
     <p:sldId id="268" r:id="rId19"/>
+    <p:sldId id="269" r:id="rId20"/>
+    <p:sldId id="270" r:id="rId21"/>
+    <p:sldId id="271" r:id="rId22"/>
+    <p:sldId id="272" r:id="rId23"/>
+    <p:sldId id="273" r:id="rId24"/>
+    <p:sldId id="274" r:id="rId25"/>
+    <p:sldId id="275" r:id="rId26"/>
   </p:sldIdLst>
   <p:sldSz cx="12191695" cy="6858000" type="screen4x3"/>
   <p:notesSz cx="6858000" cy="9144000"/>
@@ -3569,7 +3576,7 @@
               </a:defRPr>
             </a:pPr>
             <a:r>
-              <a:t>Troubleshooting</a:t>
+              <a:t>Step 8: Secure with Microsoft SSO</a:t>
             </a:r>
           </a:p>
         </p:txBody>
@@ -3610,79 +3617,109 @@
               </a:defRPr>
             </a:pPr>
             <a:r>
-              <a:t>ModuleNotFoundError  →  "Add [package] to requirements.txt and push"</a:t>
-            </a:r>
-          </a:p>
-          <a:p>
-            <a:pPr>
-              <a:spcBef>
-                <a:spcPts val="1000"/>
-              </a:spcBef>
-              <a:spcAft>
-                <a:spcPts val="400"/>
-              </a:spcAft>
-              <a:defRPr sz="2000">
-                <a:solidFill>
-                  <a:srgbClr val="FFFFFF"/>
-                </a:solidFill>
-              </a:defRPr>
-            </a:pPr>
-            <a:r>
-              <a:t>Excel file not found  →  "Copy Excel into data folder and push"</a:t>
-            </a:r>
-          </a:p>
-          <a:p>
-            <a:pPr>
-              <a:spcBef>
-                <a:spcPts val="1000"/>
-              </a:spcBef>
-              <a:spcAft>
-                <a:spcPts val="400"/>
-              </a:spcAft>
-              <a:defRPr sz="2000">
-                <a:solidFill>
-                  <a:srgbClr val="FFFFFF"/>
-                </a:solidFill>
-              </a:defRPr>
-            </a:pPr>
-            <a:r>
-              <a:t>Dashboard broken  →  Paste error, say "fix this", then push</a:t>
-            </a:r>
-          </a:p>
-          <a:p>
-            <a:pPr>
-              <a:spcBef>
-                <a:spcPts val="1000"/>
-              </a:spcBef>
-              <a:spcAft>
-                <a:spcPts val="400"/>
-              </a:spcAft>
-              <a:defRPr sz="2000">
-                <a:solidFill>
-                  <a:srgbClr val="FFFFFF"/>
-                </a:solidFill>
-              </a:defRPr>
-            </a:pPr>
-            <a:r>
-              <a:t>Wrong data  →  Check Excel for blank rows or text in number columns</a:t>
-            </a:r>
-          </a:p>
-          <a:p>
-            <a:pPr>
-              <a:spcBef>
-                <a:spcPts val="1000"/>
-              </a:spcBef>
-              <a:spcAft>
-                <a:spcPts val="400"/>
-              </a:spcAft>
-              <a:defRPr sz="2000">
-                <a:solidFill>
-                  <a:srgbClr val="FFFFFF"/>
-                </a:solidFill>
-              </a:defRPr>
-            </a:pPr>
-            <a:r>
-              <a:t>Can't access Streamlit  →  Use same GitHub account that owns the repo</a:t>
+              <a:t>Without SSO, anyone can type any @ey.com email — no verification.</a:t>
+            </a:r>
+          </a:p>
+          <a:p>
+            <a:pPr>
+              <a:spcBef>
+                <a:spcPts val="1000"/>
+              </a:spcBef>
+              <a:spcAft>
+                <a:spcPts val="400"/>
+              </a:spcAft>
+              <a:defRPr sz="2000">
+                <a:solidFill>
+                  <a:srgbClr val="FFFFFF"/>
+                </a:solidFill>
+              </a:defRPr>
+            </a:pPr>
+            <a:r>
+              <a:t>With SSO, users sign in with their real EY Microsoft account.</a:t>
+            </a:r>
+          </a:p>
+          <a:p>
+            <a:pPr>
+              <a:spcBef>
+                <a:spcPts val="1000"/>
+              </a:spcBef>
+              <a:spcAft>
+                <a:spcPts val="400"/>
+              </a:spcAft>
+              <a:defRPr sz="2000">
+                <a:solidFill>
+                  <a:srgbClr val="FFFFFF"/>
+                </a:solidFill>
+              </a:defRPr>
+            </a:pPr>
+          </a:p>
+          <a:p>
+            <a:pPr>
+              <a:spcBef>
+                <a:spcPts val="1000"/>
+              </a:spcBef>
+              <a:spcAft>
+                <a:spcPts val="400"/>
+              </a:spcAft>
+              <a:defRPr sz="2000">
+                <a:solidFill>
+                  <a:srgbClr val="FFFFFF"/>
+                </a:solidFill>
+              </a:defRPr>
+            </a:pPr>
+            <a:r>
+              <a:t>IMPORTANT: Required if your dashboard has sensitive data.</a:t>
+            </a:r>
+          </a:p>
+          <a:p>
+            <a:pPr>
+              <a:spcBef>
+                <a:spcPts val="1000"/>
+              </a:spcBef>
+              <a:spcAft>
+                <a:spcPts val="400"/>
+              </a:spcAft>
+              <a:defRPr sz="2000">
+                <a:solidFill>
+                  <a:srgbClr val="FFFFFF"/>
+                </a:solidFill>
+              </a:defRPr>
+            </a:pPr>
+          </a:p>
+          <a:p>
+            <a:pPr>
+              <a:spcBef>
+                <a:spcPts val="1000"/>
+              </a:spcBef>
+              <a:spcAft>
+                <a:spcPts val="400"/>
+              </a:spcAft>
+              <a:defRPr sz="2000">
+                <a:solidFill>
+                  <a:srgbClr val="FFFFFF"/>
+                </a:solidFill>
+              </a:defRPr>
+            </a:pPr>
+            <a:r>
+              <a:t>Good news: The code already supports SSO.</a:t>
+            </a:r>
+          </a:p>
+          <a:p>
+            <a:pPr>
+              <a:spcBef>
+                <a:spcPts val="1000"/>
+              </a:spcBef>
+              <a:spcAft>
+                <a:spcPts val="400"/>
+              </a:spcAft>
+              <a:defRPr sz="2000">
+                <a:solidFill>
+                  <a:srgbClr val="FFFFFF"/>
+                </a:solidFill>
+              </a:defRPr>
+            </a:pPr>
+            <a:r>
+              <a:t>You only need to paste 3 values — zero code changes.</a:t>
             </a:r>
           </a:p>
         </p:txBody>
@@ -3786,7 +3823,7 @@
               </a:defRPr>
             </a:pPr>
             <a:r>
-              <a:t>Quick Reference: What to Tell Factory.AI</a:t>
+              <a:t>Step 8a: Register an App in Azure</a:t>
             </a:r>
           </a:p>
         </p:txBody>
@@ -3827,79 +3864,130 @@
               </a:defRPr>
             </a:pPr>
             <a:r>
-              <a:t>Build a dashboard     →  "Create a Streamlit dashboard using [file]"</a:t>
-            </a:r>
-          </a:p>
-          <a:p>
-            <a:pPr>
-              <a:spcBef>
-                <a:spcPts val="1000"/>
-              </a:spcBef>
-              <a:spcAft>
-                <a:spcPts val="400"/>
-              </a:spcAft>
-              <a:defRPr sz="2000">
-                <a:solidFill>
-                  <a:srgbClr val="FFFFFF"/>
-                </a:solidFill>
-              </a:defRPr>
-            </a:pPr>
-            <a:r>
-              <a:t>Change a chart          →  "Change the bar chart to a line chart"</a:t>
-            </a:r>
-          </a:p>
-          <a:p>
-            <a:pPr>
-              <a:spcBef>
-                <a:spcPts val="1000"/>
-              </a:spcBef>
-              <a:spcAft>
-                <a:spcPts val="400"/>
-              </a:spcAft>
-              <a:defRPr sz="2000">
-                <a:solidFill>
-                  <a:srgbClr val="FFFFFF"/>
-                </a:solidFill>
-              </a:defRPr>
-            </a:pPr>
-            <a:r>
-              <a:t>Add a filter                 →  "Add a filter for [column name]"</a:t>
-            </a:r>
-          </a:p>
-          <a:p>
-            <a:pPr>
-              <a:spcBef>
-                <a:spcPts val="1000"/>
-              </a:spcBef>
-              <a:spcAft>
-                <a:spcPts val="400"/>
-              </a:spcAft>
-              <a:defRPr sz="2000">
-                <a:solidFill>
-                  <a:srgbClr val="FFFFFF"/>
-                </a:solidFill>
-              </a:defRPr>
-            </a:pPr>
-            <a:r>
-              <a:t>Fix an error                →  Paste the error, say "fix this"</a:t>
-            </a:r>
-          </a:p>
-          <a:p>
-            <a:pPr>
-              <a:spcBef>
-                <a:spcPts val="1000"/>
-              </a:spcBef>
-              <a:spcAft>
-                <a:spcPts val="400"/>
-              </a:spcAft>
-              <a:defRPr sz="2000">
-                <a:solidFill>
-                  <a:srgbClr val="FFFFFF"/>
-                </a:solidFill>
-              </a:defRPr>
-            </a:pPr>
-            <a:r>
-              <a:t>Push to GitHub          →  "Push the changes to GitHub"</a:t>
+              <a:t>You need someone with Azure AD admin access (typically IT).</a:t>
+            </a:r>
+          </a:p>
+          <a:p>
+            <a:pPr>
+              <a:spcBef>
+                <a:spcPts val="1000"/>
+              </a:spcBef>
+              <a:spcAft>
+                <a:spcPts val="400"/>
+              </a:spcAft>
+              <a:defRPr sz="2000">
+                <a:solidFill>
+                  <a:srgbClr val="FFFFFF"/>
+                </a:solidFill>
+              </a:defRPr>
+            </a:pPr>
+          </a:p>
+          <a:p>
+            <a:pPr>
+              <a:spcBef>
+                <a:spcPts val="1000"/>
+              </a:spcBef>
+              <a:spcAft>
+                <a:spcPts val="400"/>
+              </a:spcAft>
+              <a:defRPr sz="2000">
+                <a:solidFill>
+                  <a:srgbClr val="FFFFFF"/>
+                </a:solidFill>
+              </a:defRPr>
+            </a:pPr>
+            <a:r>
+              <a:t>1.  Go to portal.azure.com &gt; search 'App registrations'</a:t>
+            </a:r>
+          </a:p>
+          <a:p>
+            <a:pPr>
+              <a:spcBef>
+                <a:spcPts val="1000"/>
+              </a:spcBef>
+              <a:spcAft>
+                <a:spcPts val="400"/>
+              </a:spcAft>
+              <a:defRPr sz="2000">
+                <a:solidFill>
+                  <a:srgbClr val="FFFFFF"/>
+                </a:solidFill>
+              </a:defRPr>
+            </a:pPr>
+            <a:r>
+              <a:t>2.  Click '+ New registration'</a:t>
+            </a:r>
+          </a:p>
+          <a:p>
+            <a:pPr>
+              <a:spcBef>
+                <a:spcPts val="1000"/>
+              </a:spcBef>
+              <a:spcAft>
+                <a:spcPts val="400"/>
+              </a:spcAft>
+              <a:defRPr sz="2000">
+                <a:solidFill>
+                  <a:srgbClr val="FFFFFF"/>
+                </a:solidFill>
+              </a:defRPr>
+            </a:pPr>
+            <a:r>
+              <a:t>3.  Name: 'Factory AI Dashboard'</a:t>
+            </a:r>
+          </a:p>
+          <a:p>
+            <a:pPr>
+              <a:spcBef>
+                <a:spcPts val="1000"/>
+              </a:spcBef>
+              <a:spcAft>
+                <a:spcPts val="400"/>
+              </a:spcAft>
+              <a:defRPr sz="2000">
+                <a:solidFill>
+                  <a:srgbClr val="FFFFFF"/>
+                </a:solidFill>
+              </a:defRPr>
+            </a:pPr>
+            <a:r>
+              <a:t>4.  Account type: 'This organizational directory only' (EY only)</a:t>
+            </a:r>
+          </a:p>
+          <a:p>
+            <a:pPr>
+              <a:spcBef>
+                <a:spcPts val="1000"/>
+              </a:spcBef>
+              <a:spcAft>
+                <a:spcPts val="400"/>
+              </a:spcAft>
+              <a:defRPr sz="2000">
+                <a:solidFill>
+                  <a:srgbClr val="FFFFFF"/>
+                </a:solidFill>
+              </a:defRPr>
+            </a:pPr>
+            <a:r>
+              <a:t>5.  Redirect URI: Web &gt; your Streamlit Cloud URL</a:t>
+            </a:r>
+          </a:p>
+          <a:p>
+            <a:pPr>
+              <a:spcBef>
+                <a:spcPts val="1000"/>
+              </a:spcBef>
+              <a:spcAft>
+                <a:spcPts val="400"/>
+              </a:spcAft>
+              <a:defRPr sz="2000">
+                <a:solidFill>
+                  <a:srgbClr val="FFFFFF"/>
+                </a:solidFill>
+              </a:defRPr>
+            </a:pPr>
+            <a:r>
+              <a:t>6.  Click 'Register'</a:t>
             </a:r>
           </a:p>
         </p:txBody>
@@ -3981,8 +4069,8 @@
         </p:nvSpPr>
         <p:spPr>
           <a:xfrm>
-            <a:off x="914400" y="2011680"/>
-            <a:ext cx="10362895" cy="1828800"/>
+            <a:off x="731520" y="320040"/>
+            <a:ext cx="10728655" cy="822960"/>
           </a:xfrm>
           <a:prstGeom prst="rect">
             <a:avLst/>
@@ -3995,30 +4083,176 @@
           </a:bodyPr>
           <a:lstStyle/>
           <a:p>
-            <a:pPr algn="ctr">
-              <a:defRPr sz="4000" b="1">
-                <a:solidFill>
-                  <a:srgbClr val="FFFFFF"/>
-                </a:solidFill>
-              </a:defRPr>
-            </a:pPr>
-            <a:r>
-              <a:t>Start Building Today</a:t>
-            </a:r>
-          </a:p>
-          <a:p>
-            <a:pPr algn="ctr">
-              <a:spcBef>
-                <a:spcPts val="1600"/>
-              </a:spcBef>
-              <a:defRPr sz="2200">
+            <a:pPr>
+              <a:defRPr sz="3000" b="1">
                 <a:solidFill>
                   <a:srgbClr val="FFE600"/>
                 </a:solidFill>
               </a:defRPr>
             </a:pPr>
             <a:r>
-              <a:t>factory.ai</a:t>
+              <a:t>Step 8b-c: Get Your Three Values</a:t>
+            </a:r>
+          </a:p>
+        </p:txBody>
+      </p:sp>
+      <p:sp>
+        <p:nvSpPr>
+          <p:cNvPr id="4" name="TextBox 3"/>
+          <p:cNvSpPr txBox="1"/>
+          <p:nvPr/>
+        </p:nvSpPr>
+        <p:spPr>
+          <a:xfrm>
+            <a:off x="914400" y="1371600"/>
+            <a:ext cx="10362895" cy="5029200"/>
+          </a:xfrm>
+          <a:prstGeom prst="rect">
+            <a:avLst/>
+          </a:prstGeom>
+          <a:noFill/>
+        </p:spPr>
+        <p:txBody>
+          <a:bodyPr wrap="square">
+            <a:spAutoFit/>
+          </a:bodyPr>
+          <a:lstStyle/>
+          <a:p>
+            <a:pPr>
+              <a:spcBef>
+                <a:spcPts val="1000"/>
+              </a:spcBef>
+              <a:spcAft>
+                <a:spcPts val="400"/>
+              </a:spcAft>
+              <a:defRPr sz="2000">
+                <a:solidFill>
+                  <a:srgbClr val="FFFFFF"/>
+                </a:solidFill>
+              </a:defRPr>
+            </a:pPr>
+            <a:r>
+              <a:t>From the app Overview page, copy:</a:t>
+            </a:r>
+          </a:p>
+          <a:p>
+            <a:pPr>
+              <a:spcBef>
+                <a:spcPts val="1000"/>
+              </a:spcBef>
+              <a:spcAft>
+                <a:spcPts val="400"/>
+              </a:spcAft>
+              <a:defRPr sz="2000">
+                <a:solidFill>
+                  <a:srgbClr val="FFFFFF"/>
+                </a:solidFill>
+              </a:defRPr>
+            </a:pPr>
+            <a:r>
+              <a:t>   1.  Application (client) ID  →  your client_id</a:t>
+            </a:r>
+          </a:p>
+          <a:p>
+            <a:pPr>
+              <a:spcBef>
+                <a:spcPts val="1000"/>
+              </a:spcBef>
+              <a:spcAft>
+                <a:spcPts val="400"/>
+              </a:spcAft>
+              <a:defRPr sz="2000">
+                <a:solidFill>
+                  <a:srgbClr val="FFFFFF"/>
+                </a:solidFill>
+              </a:defRPr>
+            </a:pPr>
+            <a:r>
+              <a:t>   2.  Directory (tenant) ID    →  your tenant_id</a:t>
+            </a:r>
+          </a:p>
+          <a:p>
+            <a:pPr>
+              <a:spcBef>
+                <a:spcPts val="1000"/>
+              </a:spcBef>
+              <a:spcAft>
+                <a:spcPts val="400"/>
+              </a:spcAft>
+              <a:defRPr sz="2000">
+                <a:solidFill>
+                  <a:srgbClr val="FFFFFF"/>
+                </a:solidFill>
+              </a:defRPr>
+            </a:pPr>
+          </a:p>
+          <a:p>
+            <a:pPr>
+              <a:spcBef>
+                <a:spcPts val="1000"/>
+              </a:spcBef>
+              <a:spcAft>
+                <a:spcPts val="400"/>
+              </a:spcAft>
+              <a:defRPr sz="2000">
+                <a:solidFill>
+                  <a:srgbClr val="FFFFFF"/>
+                </a:solidFill>
+              </a:defRPr>
+            </a:pPr>
+            <a:r>
+              <a:t>Then go to Certificates &amp; secrets:</a:t>
+            </a:r>
+          </a:p>
+          <a:p>
+            <a:pPr>
+              <a:spcBef>
+                <a:spcPts val="1000"/>
+              </a:spcBef>
+              <a:spcAft>
+                <a:spcPts val="400"/>
+              </a:spcAft>
+              <a:defRPr sz="2000">
+                <a:solidFill>
+                  <a:srgbClr val="FFFFFF"/>
+                </a:solidFill>
+              </a:defRPr>
+            </a:pPr>
+            <a:r>
+              <a:t>   3.  Click '+ New client secret' &gt; copy the Value  →  your client_secret</a:t>
+            </a:r>
+          </a:p>
+          <a:p>
+            <a:pPr>
+              <a:spcBef>
+                <a:spcPts val="1000"/>
+              </a:spcBef>
+              <a:spcAft>
+                <a:spcPts val="400"/>
+              </a:spcAft>
+              <a:defRPr sz="2000">
+                <a:solidFill>
+                  <a:srgbClr val="FFFFFF"/>
+                </a:solidFill>
+              </a:defRPr>
+            </a:pPr>
+          </a:p>
+          <a:p>
+            <a:pPr>
+              <a:spcBef>
+                <a:spcPts val="1000"/>
+              </a:spcBef>
+              <a:spcAft>
+                <a:spcPts val="400"/>
+              </a:spcAft>
+              <a:defRPr sz="2000">
+                <a:solidFill>
+                  <a:srgbClr val="FFFFFF"/>
+                </a:solidFill>
+              </a:defRPr>
+            </a:pPr>
+            <a:r>
+              <a:t>IMPORTANT: The secret is only shown once — copy it immediately.</a:t>
             </a:r>
           </a:p>
         </p:txBody>
@@ -4031,7 +4265,7 @@
 </p:sld>
 </file>
 
-<file path=ppt/slides/slide2.xml><?xml version="1.0" encoding="utf-8"?>
+<file path=ppt/slides/slide14.xml><?xml version="1.0" encoding="utf-8"?>
 <p:sld xmlns:a="http://schemas.openxmlformats.org/drawingml/2006/main" xmlns:p="http://schemas.openxmlformats.org/presentationml/2006/main" xmlns:r="http://schemas.openxmlformats.org/officeDocument/2006/relationships">
   <p:cSld>
     <p:bg>
@@ -4122,7 +4356,7 @@
               </a:defRPr>
             </a:pPr>
             <a:r>
-              <a:t>What You Will Build</a:t>
+              <a:t>Step 8d: Add API Permissions</a:t>
             </a:r>
           </a:p>
         </p:txBody>
@@ -4163,6 +4397,1545 @@
               </a:defRPr>
             </a:pPr>
             <a:r>
+              <a:t>1.  Go to API permissions &gt; '+ Add a permission'</a:t>
+            </a:r>
+          </a:p>
+          <a:p>
+            <a:pPr>
+              <a:spcBef>
+                <a:spcPts val="1000"/>
+              </a:spcBef>
+              <a:spcAft>
+                <a:spcPts val="400"/>
+              </a:spcAft>
+              <a:defRPr sz="2000">
+                <a:solidFill>
+                  <a:srgbClr val="FFFFFF"/>
+                </a:solidFill>
+              </a:defRPr>
+            </a:pPr>
+            <a:r>
+              <a:t>2.  Select 'Microsoft Graph' &gt; 'Delegated permissions'</a:t>
+            </a:r>
+          </a:p>
+          <a:p>
+            <a:pPr>
+              <a:spcBef>
+                <a:spcPts val="1000"/>
+              </a:spcBef>
+              <a:spcAft>
+                <a:spcPts val="400"/>
+              </a:spcAft>
+              <a:defRPr sz="2000">
+                <a:solidFill>
+                  <a:srgbClr val="FFFFFF"/>
+                </a:solidFill>
+              </a:defRPr>
+            </a:pPr>
+            <a:r>
+              <a:t>3.  Search for 'User.Read' and check it</a:t>
+            </a:r>
+          </a:p>
+          <a:p>
+            <a:pPr>
+              <a:spcBef>
+                <a:spcPts val="1000"/>
+              </a:spcBef>
+              <a:spcAft>
+                <a:spcPts val="400"/>
+              </a:spcAft>
+              <a:defRPr sz="2000">
+                <a:solidFill>
+                  <a:srgbClr val="FFFFFF"/>
+                </a:solidFill>
+              </a:defRPr>
+            </a:pPr>
+            <a:r>
+              <a:t>4.  Click 'Add permissions'</a:t>
+            </a:r>
+          </a:p>
+          <a:p>
+            <a:pPr>
+              <a:spcBef>
+                <a:spcPts val="1000"/>
+              </a:spcBef>
+              <a:spcAft>
+                <a:spcPts val="400"/>
+              </a:spcAft>
+              <a:defRPr sz="2000">
+                <a:solidFill>
+                  <a:srgbClr val="FFFFFF"/>
+                </a:solidFill>
+              </a:defRPr>
+            </a:pPr>
+            <a:r>
+              <a:t>5.  Click 'Grant admin consent for EY'</a:t>
+            </a:r>
+          </a:p>
+          <a:p>
+            <a:pPr>
+              <a:spcBef>
+                <a:spcPts val="1000"/>
+              </a:spcBef>
+              <a:spcAft>
+                <a:spcPts val="400"/>
+              </a:spcAft>
+              <a:defRPr sz="2000">
+                <a:solidFill>
+                  <a:srgbClr val="FFFFFF"/>
+                </a:solidFill>
+              </a:defRPr>
+            </a:pPr>
+          </a:p>
+          <a:p>
+            <a:pPr>
+              <a:spcBef>
+                <a:spcPts val="1000"/>
+              </a:spcBef>
+              <a:spcAft>
+                <a:spcPts val="400"/>
+              </a:spcAft>
+              <a:defRPr sz="2000">
+                <a:solidFill>
+                  <a:srgbClr val="FFFFFF"/>
+                </a:solidFill>
+              </a:defRPr>
+            </a:pPr>
+            <a:r>
+              <a:t>If you don't see the consent button, ask a Global Admin to do it.</a:t>
+            </a:r>
+          </a:p>
+        </p:txBody>
+      </p:sp>
+    </p:spTree>
+  </p:cSld>
+  <p:clrMapOvr>
+    <a:masterClrMapping/>
+  </p:clrMapOvr>
+</p:sld>
+</file>
+
+<file path=ppt/slides/slide15.xml><?xml version="1.0" encoding="utf-8"?>
+<p:sld xmlns:a="http://schemas.openxmlformats.org/drawingml/2006/main" xmlns:p="http://schemas.openxmlformats.org/presentationml/2006/main" xmlns:r="http://schemas.openxmlformats.org/officeDocument/2006/relationships">
+  <p:cSld>
+    <p:bg>
+      <p:bgPr>
+        <a:solidFill>
+          <a:srgbClr val="2E2E38"/>
+        </a:solidFill>
+        <a:effectLst/>
+      </p:bgPr>
+    </p:bg>
+    <p:spTree>
+      <p:nvGrpSpPr>
+        <p:cNvPr id="1" name=""/>
+        <p:cNvGrpSpPr/>
+        <p:nvPr/>
+      </p:nvGrpSpPr>
+      <p:grpSpPr/>
+      <p:sp>
+        <p:nvSpPr>
+          <p:cNvPr id="2" name="Rectangle 1"/>
+          <p:cNvSpPr/>
+          <p:nvPr/>
+        </p:nvSpPr>
+        <p:spPr>
+          <a:xfrm>
+            <a:off x="0" y="0"/>
+            <a:ext cx="12191695" cy="73152"/>
+          </a:xfrm>
+          <a:prstGeom prst="rect">
+            <a:avLst/>
+          </a:prstGeom>
+          <a:solidFill>
+            <a:srgbClr val="FFE600"/>
+          </a:solidFill>
+          <a:ln>
+            <a:noFill/>
+          </a:ln>
+        </p:spPr>
+        <p:style>
+          <a:lnRef idx="1">
+            <a:schemeClr val="accent1"/>
+          </a:lnRef>
+          <a:fillRef idx="3">
+            <a:schemeClr val="accent1"/>
+          </a:fillRef>
+          <a:effectRef idx="2">
+            <a:schemeClr val="accent1"/>
+          </a:effectRef>
+          <a:fontRef idx="minor">
+            <a:schemeClr val="lt1"/>
+          </a:fontRef>
+        </p:style>
+        <p:txBody>
+          <a:bodyPr rtlCol="0" anchor="ctr"/>
+          <a:lstStyle/>
+          <a:p>
+            <a:pPr algn="ctr"/>
+          </a:p>
+        </p:txBody>
+      </p:sp>
+      <p:sp>
+        <p:nvSpPr>
+          <p:cNvPr id="3" name="TextBox 2"/>
+          <p:cNvSpPr txBox="1"/>
+          <p:nvPr/>
+        </p:nvSpPr>
+        <p:spPr>
+          <a:xfrm>
+            <a:off x="731520" y="320040"/>
+            <a:ext cx="10728655" cy="822960"/>
+          </a:xfrm>
+          <a:prstGeom prst="rect">
+            <a:avLst/>
+          </a:prstGeom>
+          <a:noFill/>
+        </p:spPr>
+        <p:txBody>
+          <a:bodyPr wrap="square">
+            <a:spAutoFit/>
+          </a:bodyPr>
+          <a:lstStyle/>
+          <a:p>
+            <a:pPr>
+              <a:defRPr sz="3000" b="1">
+                <a:solidFill>
+                  <a:srgbClr val="FFE600"/>
+                </a:solidFill>
+              </a:defRPr>
+            </a:pPr>
+            <a:r>
+              <a:t>Step 8e: Paste Values into Streamlit Cloud</a:t>
+            </a:r>
+          </a:p>
+        </p:txBody>
+      </p:sp>
+      <p:sp>
+        <p:nvSpPr>
+          <p:cNvPr id="4" name="TextBox 3"/>
+          <p:cNvSpPr txBox="1"/>
+          <p:nvPr/>
+        </p:nvSpPr>
+        <p:spPr>
+          <a:xfrm>
+            <a:off x="914400" y="1371600"/>
+            <a:ext cx="10362895" cy="5029200"/>
+          </a:xfrm>
+          <a:prstGeom prst="rect">
+            <a:avLst/>
+          </a:prstGeom>
+          <a:noFill/>
+        </p:spPr>
+        <p:txBody>
+          <a:bodyPr wrap="square">
+            <a:spAutoFit/>
+          </a:bodyPr>
+          <a:lstStyle/>
+          <a:p>
+            <a:pPr>
+              <a:spcBef>
+                <a:spcPts val="1000"/>
+              </a:spcBef>
+              <a:spcAft>
+                <a:spcPts val="400"/>
+              </a:spcAft>
+              <a:defRPr sz="2000">
+                <a:solidFill>
+                  <a:srgbClr val="FFFFFF"/>
+                </a:solidFill>
+              </a:defRPr>
+            </a:pPr>
+            <a:r>
+              <a:t>1.  Go to share.streamlit.io &gt; your app &gt; Settings &gt; Secrets</a:t>
+            </a:r>
+          </a:p>
+          <a:p>
+            <a:pPr>
+              <a:spcBef>
+                <a:spcPts val="1000"/>
+              </a:spcBef>
+              <a:spcAft>
+                <a:spcPts val="400"/>
+              </a:spcAft>
+              <a:defRPr sz="2000">
+                <a:solidFill>
+                  <a:srgbClr val="FFFFFF"/>
+                </a:solidFill>
+              </a:defRPr>
+            </a:pPr>
+            <a:r>
+              <a:t>2.  Paste:</a:t>
+            </a:r>
+          </a:p>
+          <a:p>
+            <a:pPr>
+              <a:spcBef>
+                <a:spcPts val="1000"/>
+              </a:spcBef>
+              <a:spcAft>
+                <a:spcPts val="400"/>
+              </a:spcAft>
+              <a:defRPr sz="2000">
+                <a:solidFill>
+                  <a:srgbClr val="FFFFFF"/>
+                </a:solidFill>
+              </a:defRPr>
+            </a:pPr>
+          </a:p>
+          <a:p>
+            <a:pPr>
+              <a:spcBef>
+                <a:spcPts val="1000"/>
+              </a:spcBef>
+              <a:spcAft>
+                <a:spcPts val="400"/>
+              </a:spcAft>
+              <a:defRPr sz="2000">
+                <a:solidFill>
+                  <a:srgbClr val="FFFFFF"/>
+                </a:solidFill>
+              </a:defRPr>
+            </a:pPr>
+            <a:r>
+              <a:t>     [azure]</a:t>
+            </a:r>
+          </a:p>
+          <a:p>
+            <a:pPr>
+              <a:spcBef>
+                <a:spcPts val="1000"/>
+              </a:spcBef>
+              <a:spcAft>
+                <a:spcPts val="400"/>
+              </a:spcAft>
+              <a:defRPr sz="2000">
+                <a:solidFill>
+                  <a:srgbClr val="FFFFFF"/>
+                </a:solidFill>
+              </a:defRPr>
+            </a:pPr>
+            <a:r>
+              <a:t>     client_id = "your-client-id"</a:t>
+            </a:r>
+          </a:p>
+          <a:p>
+            <a:pPr>
+              <a:spcBef>
+                <a:spcPts val="1000"/>
+              </a:spcBef>
+              <a:spcAft>
+                <a:spcPts val="400"/>
+              </a:spcAft>
+              <a:defRPr sz="2000">
+                <a:solidFill>
+                  <a:srgbClr val="FFFFFF"/>
+                </a:solidFill>
+              </a:defRPr>
+            </a:pPr>
+            <a:r>
+              <a:t>     client_secret = "your-client-secret"</a:t>
+            </a:r>
+          </a:p>
+          <a:p>
+            <a:pPr>
+              <a:spcBef>
+                <a:spcPts val="1000"/>
+              </a:spcBef>
+              <a:spcAft>
+                <a:spcPts val="400"/>
+              </a:spcAft>
+              <a:defRPr sz="2000">
+                <a:solidFill>
+                  <a:srgbClr val="FFFFFF"/>
+                </a:solidFill>
+              </a:defRPr>
+            </a:pPr>
+            <a:r>
+              <a:t>     tenant_id = "your-tenant-id"</a:t>
+            </a:r>
+          </a:p>
+          <a:p>
+            <a:pPr>
+              <a:spcBef>
+                <a:spcPts val="1000"/>
+              </a:spcBef>
+              <a:spcAft>
+                <a:spcPts val="400"/>
+              </a:spcAft>
+              <a:defRPr sz="2000">
+                <a:solidFill>
+                  <a:srgbClr val="FFFFFF"/>
+                </a:solidFill>
+              </a:defRPr>
+            </a:pPr>
+            <a:r>
+              <a:t>     redirect_uri = "https://your-app.streamlit.app"</a:t>
+            </a:r>
+          </a:p>
+          <a:p>
+            <a:pPr>
+              <a:spcBef>
+                <a:spcPts val="1000"/>
+              </a:spcBef>
+              <a:spcAft>
+                <a:spcPts val="400"/>
+              </a:spcAft>
+              <a:defRPr sz="2000">
+                <a:solidFill>
+                  <a:srgbClr val="FFFFFF"/>
+                </a:solidFill>
+              </a:defRPr>
+            </a:pPr>
+          </a:p>
+          <a:p>
+            <a:pPr>
+              <a:spcBef>
+                <a:spcPts val="1000"/>
+              </a:spcBef>
+              <a:spcAft>
+                <a:spcPts val="400"/>
+              </a:spcAft>
+              <a:defRPr sz="2000">
+                <a:solidFill>
+                  <a:srgbClr val="FFFFFF"/>
+                </a:solidFill>
+              </a:defRPr>
+            </a:pPr>
+            <a:r>
+              <a:t>3.  Click Save &gt; Reboot app. That's it — SSO is live.</a:t>
+            </a:r>
+          </a:p>
+        </p:txBody>
+      </p:sp>
+    </p:spTree>
+  </p:cSld>
+  <p:clrMapOvr>
+    <a:masterClrMapping/>
+  </p:clrMapOvr>
+</p:sld>
+</file>
+
+<file path=ppt/slides/slide16.xml><?xml version="1.0" encoding="utf-8"?>
+<p:sld xmlns:a="http://schemas.openxmlformats.org/drawingml/2006/main" xmlns:p="http://schemas.openxmlformats.org/presentationml/2006/main" xmlns:r="http://schemas.openxmlformats.org/officeDocument/2006/relationships">
+  <p:cSld>
+    <p:bg>
+      <p:bgPr>
+        <a:solidFill>
+          <a:srgbClr val="2E2E38"/>
+        </a:solidFill>
+        <a:effectLst/>
+      </p:bgPr>
+    </p:bg>
+    <p:spTree>
+      <p:nvGrpSpPr>
+        <p:cNvPr id="1" name=""/>
+        <p:cNvGrpSpPr/>
+        <p:nvPr/>
+      </p:nvGrpSpPr>
+      <p:grpSpPr/>
+      <p:sp>
+        <p:nvSpPr>
+          <p:cNvPr id="2" name="Rectangle 1"/>
+          <p:cNvSpPr/>
+          <p:nvPr/>
+        </p:nvSpPr>
+        <p:spPr>
+          <a:xfrm>
+            <a:off x="0" y="0"/>
+            <a:ext cx="12191695" cy="73152"/>
+          </a:xfrm>
+          <a:prstGeom prst="rect">
+            <a:avLst/>
+          </a:prstGeom>
+          <a:solidFill>
+            <a:srgbClr val="FFE600"/>
+          </a:solidFill>
+          <a:ln>
+            <a:noFill/>
+          </a:ln>
+        </p:spPr>
+        <p:style>
+          <a:lnRef idx="1">
+            <a:schemeClr val="accent1"/>
+          </a:lnRef>
+          <a:fillRef idx="3">
+            <a:schemeClr val="accent1"/>
+          </a:fillRef>
+          <a:effectRef idx="2">
+            <a:schemeClr val="accent1"/>
+          </a:effectRef>
+          <a:fontRef idx="minor">
+            <a:schemeClr val="lt1"/>
+          </a:fontRef>
+        </p:style>
+        <p:txBody>
+          <a:bodyPr rtlCol="0" anchor="ctr"/>
+          <a:lstStyle/>
+          <a:p>
+            <a:pPr algn="ctr"/>
+          </a:p>
+        </p:txBody>
+      </p:sp>
+      <p:sp>
+        <p:nvSpPr>
+          <p:cNvPr id="3" name="TextBox 2"/>
+          <p:cNvSpPr txBox="1"/>
+          <p:nvPr/>
+        </p:nvSpPr>
+        <p:spPr>
+          <a:xfrm>
+            <a:off x="731520" y="320040"/>
+            <a:ext cx="10728655" cy="822960"/>
+          </a:xfrm>
+          <a:prstGeom prst="rect">
+            <a:avLst/>
+          </a:prstGeom>
+          <a:noFill/>
+        </p:spPr>
+        <p:txBody>
+          <a:bodyPr wrap="square">
+            <a:spAutoFit/>
+          </a:bodyPr>
+          <a:lstStyle/>
+          <a:p>
+            <a:pPr>
+              <a:defRPr sz="3000" b="1">
+                <a:solidFill>
+                  <a:srgbClr val="FFE600"/>
+                </a:solidFill>
+              </a:defRPr>
+            </a:pPr>
+            <a:r>
+              <a:t>What Changes After SSO</a:t>
+            </a:r>
+          </a:p>
+        </p:txBody>
+      </p:sp>
+      <p:sp>
+        <p:nvSpPr>
+          <p:cNvPr id="4" name="TextBox 3"/>
+          <p:cNvSpPr txBox="1"/>
+          <p:nvPr/>
+        </p:nvSpPr>
+        <p:spPr>
+          <a:xfrm>
+            <a:off x="914400" y="1371600"/>
+            <a:ext cx="10362895" cy="5029200"/>
+          </a:xfrm>
+          <a:prstGeom prst="rect">
+            <a:avLst/>
+          </a:prstGeom>
+          <a:noFill/>
+        </p:spPr>
+        <p:txBody>
+          <a:bodyPr wrap="square">
+            <a:spAutoFit/>
+          </a:bodyPr>
+          <a:lstStyle/>
+          <a:p>
+            <a:pPr>
+              <a:spcBef>
+                <a:spcPts val="1000"/>
+              </a:spcBef>
+              <a:spcAft>
+                <a:spcPts val="400"/>
+              </a:spcAft>
+              <a:defRPr sz="2000">
+                <a:solidFill>
+                  <a:srgbClr val="FFFFFF"/>
+                </a:solidFill>
+              </a:defRPr>
+            </a:pPr>
+            <a:r>
+              <a:t>BEFORE:                                    AFTER:</a:t>
+            </a:r>
+          </a:p>
+          <a:p>
+            <a:pPr>
+              <a:spcBef>
+                <a:spcPts val="1000"/>
+              </a:spcBef>
+              <a:spcAft>
+                <a:spcPts val="400"/>
+              </a:spcAft>
+              <a:defRPr sz="2000">
+                <a:solidFill>
+                  <a:srgbClr val="FFFFFF"/>
+                </a:solidFill>
+              </a:defRPr>
+            </a:pPr>
+            <a:r>
+              <a:t>  Users type email in a text box              Users click 'Sign in with Microsoft'</a:t>
+            </a:r>
+          </a:p>
+          <a:p>
+            <a:pPr>
+              <a:spcBef>
+                <a:spcPts val="1000"/>
+              </a:spcBef>
+              <a:spcAft>
+                <a:spcPts val="400"/>
+              </a:spcAft>
+              <a:defRPr sz="2000">
+                <a:solidFill>
+                  <a:srgbClr val="FFFFFF"/>
+                </a:solidFill>
+              </a:defRPr>
+            </a:pPr>
+            <a:r>
+              <a:t>  No verification at all                           Microsoft verifies their identity</a:t>
+            </a:r>
+          </a:p>
+          <a:p>
+            <a:pPr>
+              <a:spcBef>
+                <a:spcPts val="1000"/>
+              </a:spcBef>
+              <a:spcAft>
+                <a:spcPts val="400"/>
+              </a:spcAft>
+              <a:defRPr sz="2000">
+                <a:solidFill>
+                  <a:srgbClr val="FFFFFF"/>
+                </a:solidFill>
+              </a:defRPr>
+            </a:pPr>
+            <a:r>
+              <a:t>  Not safe for sensitive data                  Enterprise-grade security</a:t>
+            </a:r>
+          </a:p>
+          <a:p>
+            <a:pPr>
+              <a:spcBef>
+                <a:spcPts val="1000"/>
+              </a:spcBef>
+              <a:spcAft>
+                <a:spcPts val="400"/>
+              </a:spcAft>
+              <a:defRPr sz="2000">
+                <a:solidFill>
+                  <a:srgbClr val="FFFFFF"/>
+                </a:solidFill>
+              </a:defRPr>
+            </a:pPr>
+            <a:r>
+              <a:t>  No audit trail                                      Microsoft logs all sign-ins</a:t>
+            </a:r>
+          </a:p>
+          <a:p>
+            <a:pPr>
+              <a:spcBef>
+                <a:spcPts val="1000"/>
+              </a:spcBef>
+              <a:spcAft>
+                <a:spcPts val="400"/>
+              </a:spcAft>
+              <a:defRPr sz="2000">
+                <a:solidFill>
+                  <a:srgbClr val="FFFFFF"/>
+                </a:solidFill>
+              </a:defRPr>
+            </a:pPr>
+          </a:p>
+          <a:p>
+            <a:pPr>
+              <a:spcBef>
+                <a:spcPts val="1000"/>
+              </a:spcBef>
+              <a:spcAft>
+                <a:spcPts val="400"/>
+              </a:spcAft>
+              <a:defRPr sz="2000">
+                <a:solidFill>
+                  <a:srgbClr val="FFFFFF"/>
+                </a:solidFill>
+              </a:defRPr>
+            </a:pPr>
+            <a:r>
+              <a:t>The app switches automatically — no code changes needed.</a:t>
+            </a:r>
+          </a:p>
+        </p:txBody>
+      </p:sp>
+    </p:spTree>
+  </p:cSld>
+  <p:clrMapOvr>
+    <a:masterClrMapping/>
+  </p:clrMapOvr>
+</p:sld>
+</file>
+
+<file path=ppt/slides/slide17.xml><?xml version="1.0" encoding="utf-8"?>
+<p:sld xmlns:a="http://schemas.openxmlformats.org/drawingml/2006/main" xmlns:p="http://schemas.openxmlformats.org/presentationml/2006/main" xmlns:r="http://schemas.openxmlformats.org/officeDocument/2006/relationships">
+  <p:cSld>
+    <p:bg>
+      <p:bgPr>
+        <a:solidFill>
+          <a:srgbClr val="2E2E38"/>
+        </a:solidFill>
+        <a:effectLst/>
+      </p:bgPr>
+    </p:bg>
+    <p:spTree>
+      <p:nvGrpSpPr>
+        <p:cNvPr id="1" name=""/>
+        <p:cNvGrpSpPr/>
+        <p:nvPr/>
+      </p:nvGrpSpPr>
+      <p:grpSpPr/>
+      <p:sp>
+        <p:nvSpPr>
+          <p:cNvPr id="2" name="Rectangle 1"/>
+          <p:cNvSpPr/>
+          <p:nvPr/>
+        </p:nvSpPr>
+        <p:spPr>
+          <a:xfrm>
+            <a:off x="0" y="0"/>
+            <a:ext cx="12191695" cy="73152"/>
+          </a:xfrm>
+          <a:prstGeom prst="rect">
+            <a:avLst/>
+          </a:prstGeom>
+          <a:solidFill>
+            <a:srgbClr val="FFE600"/>
+          </a:solidFill>
+          <a:ln>
+            <a:noFill/>
+          </a:ln>
+        </p:spPr>
+        <p:style>
+          <a:lnRef idx="1">
+            <a:schemeClr val="accent1"/>
+          </a:lnRef>
+          <a:fillRef idx="3">
+            <a:schemeClr val="accent1"/>
+          </a:fillRef>
+          <a:effectRef idx="2">
+            <a:schemeClr val="accent1"/>
+          </a:effectRef>
+          <a:fontRef idx="minor">
+            <a:schemeClr val="lt1"/>
+          </a:fontRef>
+        </p:style>
+        <p:txBody>
+          <a:bodyPr rtlCol="0" anchor="ctr"/>
+          <a:lstStyle/>
+          <a:p>
+            <a:pPr algn="ctr"/>
+          </a:p>
+        </p:txBody>
+      </p:sp>
+      <p:sp>
+        <p:nvSpPr>
+          <p:cNvPr id="3" name="TextBox 2"/>
+          <p:cNvSpPr txBox="1"/>
+          <p:nvPr/>
+        </p:nvSpPr>
+        <p:spPr>
+          <a:xfrm>
+            <a:off x="731520" y="320040"/>
+            <a:ext cx="10728655" cy="822960"/>
+          </a:xfrm>
+          <a:prstGeom prst="rect">
+            <a:avLst/>
+          </a:prstGeom>
+          <a:noFill/>
+        </p:spPr>
+        <p:txBody>
+          <a:bodyPr wrap="square">
+            <a:spAutoFit/>
+          </a:bodyPr>
+          <a:lstStyle/>
+          <a:p>
+            <a:pPr>
+              <a:defRPr sz="3000" b="1">
+                <a:solidFill>
+                  <a:srgbClr val="FFE600"/>
+                </a:solidFill>
+              </a:defRPr>
+            </a:pPr>
+            <a:r>
+              <a:t>Email Template for Your IT Team</a:t>
+            </a:r>
+          </a:p>
+        </p:txBody>
+      </p:sp>
+      <p:sp>
+        <p:nvSpPr>
+          <p:cNvPr id="4" name="TextBox 3"/>
+          <p:cNvSpPr txBox="1"/>
+          <p:nvPr/>
+        </p:nvSpPr>
+        <p:spPr>
+          <a:xfrm>
+            <a:off x="914400" y="1371600"/>
+            <a:ext cx="10362895" cy="5029200"/>
+          </a:xfrm>
+          <a:prstGeom prst="rect">
+            <a:avLst/>
+          </a:prstGeom>
+          <a:noFill/>
+        </p:spPr>
+        <p:txBody>
+          <a:bodyPr wrap="square">
+            <a:spAutoFit/>
+          </a:bodyPr>
+          <a:lstStyle/>
+          <a:p>
+            <a:pPr>
+              <a:spcBef>
+                <a:spcPts val="1000"/>
+              </a:spcBef>
+              <a:spcAft>
+                <a:spcPts val="400"/>
+              </a:spcAft>
+              <a:defRPr sz="2000">
+                <a:solidFill>
+                  <a:srgbClr val="FFFFFF"/>
+                </a:solidFill>
+              </a:defRPr>
+            </a:pPr>
+            <a:r>
+              <a:t>"Hi, I need an Azure AD app registration for a Streamlit dashboard."</a:t>
+            </a:r>
+          </a:p>
+          <a:p>
+            <a:pPr>
+              <a:spcBef>
+                <a:spcPts val="1000"/>
+              </a:spcBef>
+              <a:spcAft>
+                <a:spcPts val="400"/>
+              </a:spcAft>
+              <a:defRPr sz="2000">
+                <a:solidFill>
+                  <a:srgbClr val="FFFFFF"/>
+                </a:solidFill>
+              </a:defRPr>
+            </a:pPr>
+          </a:p>
+          <a:p>
+            <a:pPr>
+              <a:spcBef>
+                <a:spcPts val="1000"/>
+              </a:spcBef>
+              <a:spcAft>
+                <a:spcPts val="400"/>
+              </a:spcAft>
+              <a:defRPr sz="2000">
+                <a:solidFill>
+                  <a:srgbClr val="FFFFFF"/>
+                </a:solidFill>
+              </a:defRPr>
+            </a:pPr>
+            <a:r>
+              <a:t>Ask them to:</a:t>
+            </a:r>
+          </a:p>
+          <a:p>
+            <a:pPr>
+              <a:spcBef>
+                <a:spcPts val="1000"/>
+              </a:spcBef>
+              <a:spcAft>
+                <a:spcPts val="400"/>
+              </a:spcAft>
+              <a:defRPr sz="2000">
+                <a:solidFill>
+                  <a:srgbClr val="FFFFFF"/>
+                </a:solidFill>
+              </a:defRPr>
+            </a:pPr>
+            <a:r>
+              <a:t>  1.  Register app named "Factory AI Dashboard"</a:t>
+            </a:r>
+          </a:p>
+          <a:p>
+            <a:pPr>
+              <a:spcBef>
+                <a:spcPts val="1000"/>
+              </a:spcBef>
+              <a:spcAft>
+                <a:spcPts val="400"/>
+              </a:spcAft>
+              <a:defRPr sz="2000">
+                <a:solidFill>
+                  <a:srgbClr val="FFFFFF"/>
+                </a:solidFill>
+              </a:defRPr>
+            </a:pPr>
+            <a:r>
+              <a:t>  2.  Set to EY tenant only</a:t>
+            </a:r>
+          </a:p>
+          <a:p>
+            <a:pPr>
+              <a:spcBef>
+                <a:spcPts val="1000"/>
+              </a:spcBef>
+              <a:spcAft>
+                <a:spcPts val="400"/>
+              </a:spcAft>
+              <a:defRPr sz="2000">
+                <a:solidFill>
+                  <a:srgbClr val="FFFFFF"/>
+                </a:solidFill>
+              </a:defRPr>
+            </a:pPr>
+            <a:r>
+              <a:t>  3.  Add Web redirect URI: [your Streamlit URL]</a:t>
+            </a:r>
+          </a:p>
+          <a:p>
+            <a:pPr>
+              <a:spcBef>
+                <a:spcPts val="1000"/>
+              </a:spcBef>
+              <a:spcAft>
+                <a:spcPts val="400"/>
+              </a:spcAft>
+              <a:defRPr sz="2000">
+                <a:solidFill>
+                  <a:srgbClr val="FFFFFF"/>
+                </a:solidFill>
+              </a:defRPr>
+            </a:pPr>
+            <a:r>
+              <a:t>  4.  Create a client secret</a:t>
+            </a:r>
+          </a:p>
+          <a:p>
+            <a:pPr>
+              <a:spcBef>
+                <a:spcPts val="1000"/>
+              </a:spcBef>
+              <a:spcAft>
+                <a:spcPts val="400"/>
+              </a:spcAft>
+              <a:defRPr sz="2000">
+                <a:solidFill>
+                  <a:srgbClr val="FFFFFF"/>
+                </a:solidFill>
+              </a:defRPr>
+            </a:pPr>
+            <a:r>
+              <a:t>  5.  Add User.Read permission + grant admin consent</a:t>
+            </a:r>
+          </a:p>
+          <a:p>
+            <a:pPr>
+              <a:spcBef>
+                <a:spcPts val="1000"/>
+              </a:spcBef>
+              <a:spcAft>
+                <a:spcPts val="400"/>
+              </a:spcAft>
+              <a:defRPr sz="2000">
+                <a:solidFill>
+                  <a:srgbClr val="FFFFFF"/>
+                </a:solidFill>
+              </a:defRPr>
+            </a:pPr>
+            <a:r>
+              <a:t>  6.  Send you the client_id, tenant_id, and client_secret</a:t>
+            </a:r>
+          </a:p>
+        </p:txBody>
+      </p:sp>
+    </p:spTree>
+  </p:cSld>
+  <p:clrMapOvr>
+    <a:masterClrMapping/>
+  </p:clrMapOvr>
+</p:sld>
+</file>
+
+<file path=ppt/slides/slide18.xml><?xml version="1.0" encoding="utf-8"?>
+<p:sld xmlns:a="http://schemas.openxmlformats.org/drawingml/2006/main" xmlns:p="http://schemas.openxmlformats.org/presentationml/2006/main" xmlns:r="http://schemas.openxmlformats.org/officeDocument/2006/relationships">
+  <p:cSld>
+    <p:bg>
+      <p:bgPr>
+        <a:solidFill>
+          <a:srgbClr val="2E2E38"/>
+        </a:solidFill>
+        <a:effectLst/>
+      </p:bgPr>
+    </p:bg>
+    <p:spTree>
+      <p:nvGrpSpPr>
+        <p:cNvPr id="1" name=""/>
+        <p:cNvGrpSpPr/>
+        <p:nvPr/>
+      </p:nvGrpSpPr>
+      <p:grpSpPr/>
+      <p:sp>
+        <p:nvSpPr>
+          <p:cNvPr id="2" name="Rectangle 1"/>
+          <p:cNvSpPr/>
+          <p:nvPr/>
+        </p:nvSpPr>
+        <p:spPr>
+          <a:xfrm>
+            <a:off x="0" y="0"/>
+            <a:ext cx="12191695" cy="73152"/>
+          </a:xfrm>
+          <a:prstGeom prst="rect">
+            <a:avLst/>
+          </a:prstGeom>
+          <a:solidFill>
+            <a:srgbClr val="FFE600"/>
+          </a:solidFill>
+          <a:ln>
+            <a:noFill/>
+          </a:ln>
+        </p:spPr>
+        <p:style>
+          <a:lnRef idx="1">
+            <a:schemeClr val="accent1"/>
+          </a:lnRef>
+          <a:fillRef idx="3">
+            <a:schemeClr val="accent1"/>
+          </a:fillRef>
+          <a:effectRef idx="2">
+            <a:schemeClr val="accent1"/>
+          </a:effectRef>
+          <a:fontRef idx="minor">
+            <a:schemeClr val="lt1"/>
+          </a:fontRef>
+        </p:style>
+        <p:txBody>
+          <a:bodyPr rtlCol="0" anchor="ctr"/>
+          <a:lstStyle/>
+          <a:p>
+            <a:pPr algn="ctr"/>
+          </a:p>
+        </p:txBody>
+      </p:sp>
+      <p:sp>
+        <p:nvSpPr>
+          <p:cNvPr id="3" name="TextBox 2"/>
+          <p:cNvSpPr txBox="1"/>
+          <p:nvPr/>
+        </p:nvSpPr>
+        <p:spPr>
+          <a:xfrm>
+            <a:off x="731520" y="320040"/>
+            <a:ext cx="10728655" cy="822960"/>
+          </a:xfrm>
+          <a:prstGeom prst="rect">
+            <a:avLst/>
+          </a:prstGeom>
+          <a:noFill/>
+        </p:spPr>
+        <p:txBody>
+          <a:bodyPr wrap="square">
+            <a:spAutoFit/>
+          </a:bodyPr>
+          <a:lstStyle/>
+          <a:p>
+            <a:pPr>
+              <a:defRPr sz="3000" b="1">
+                <a:solidFill>
+                  <a:srgbClr val="FFE600"/>
+                </a:solidFill>
+              </a:defRPr>
+            </a:pPr>
+            <a:r>
+              <a:t>Troubleshooting</a:t>
+            </a:r>
+          </a:p>
+        </p:txBody>
+      </p:sp>
+      <p:sp>
+        <p:nvSpPr>
+          <p:cNvPr id="4" name="TextBox 3"/>
+          <p:cNvSpPr txBox="1"/>
+          <p:nvPr/>
+        </p:nvSpPr>
+        <p:spPr>
+          <a:xfrm>
+            <a:off x="914400" y="1371600"/>
+            <a:ext cx="10362895" cy="5029200"/>
+          </a:xfrm>
+          <a:prstGeom prst="rect">
+            <a:avLst/>
+          </a:prstGeom>
+          <a:noFill/>
+        </p:spPr>
+        <p:txBody>
+          <a:bodyPr wrap="square">
+            <a:spAutoFit/>
+          </a:bodyPr>
+          <a:lstStyle/>
+          <a:p>
+            <a:pPr>
+              <a:spcBef>
+                <a:spcPts val="1000"/>
+              </a:spcBef>
+              <a:spcAft>
+                <a:spcPts val="400"/>
+              </a:spcAft>
+              <a:defRPr sz="2000">
+                <a:solidFill>
+                  <a:srgbClr val="FFFFFF"/>
+                </a:solidFill>
+              </a:defRPr>
+            </a:pPr>
+            <a:r>
+              <a:t>ModuleNotFoundError  →  "Add [package] to requirements.txt and push"</a:t>
+            </a:r>
+          </a:p>
+          <a:p>
+            <a:pPr>
+              <a:spcBef>
+                <a:spcPts val="1000"/>
+              </a:spcBef>
+              <a:spcAft>
+                <a:spcPts val="400"/>
+              </a:spcAft>
+              <a:defRPr sz="2000">
+                <a:solidFill>
+                  <a:srgbClr val="FFFFFF"/>
+                </a:solidFill>
+              </a:defRPr>
+            </a:pPr>
+            <a:r>
+              <a:t>Excel file not found  →  "Copy Excel into data folder and push"</a:t>
+            </a:r>
+          </a:p>
+          <a:p>
+            <a:pPr>
+              <a:spcBef>
+                <a:spcPts val="1000"/>
+              </a:spcBef>
+              <a:spcAft>
+                <a:spcPts val="400"/>
+              </a:spcAft>
+              <a:defRPr sz="2000">
+                <a:solidFill>
+                  <a:srgbClr val="FFFFFF"/>
+                </a:solidFill>
+              </a:defRPr>
+            </a:pPr>
+            <a:r>
+              <a:t>Dashboard broken  →  Paste error, say "fix this", then push</a:t>
+            </a:r>
+          </a:p>
+          <a:p>
+            <a:pPr>
+              <a:spcBef>
+                <a:spcPts val="1000"/>
+              </a:spcBef>
+              <a:spcAft>
+                <a:spcPts val="400"/>
+              </a:spcAft>
+              <a:defRPr sz="2000">
+                <a:solidFill>
+                  <a:srgbClr val="FFFFFF"/>
+                </a:solidFill>
+              </a:defRPr>
+            </a:pPr>
+            <a:r>
+              <a:t>Wrong data  →  Check Excel for blank rows or text in number columns</a:t>
+            </a:r>
+          </a:p>
+          <a:p>
+            <a:pPr>
+              <a:spcBef>
+                <a:spcPts val="1000"/>
+              </a:spcBef>
+              <a:spcAft>
+                <a:spcPts val="400"/>
+              </a:spcAft>
+              <a:defRPr sz="2000">
+                <a:solidFill>
+                  <a:srgbClr val="FFFFFF"/>
+                </a:solidFill>
+              </a:defRPr>
+            </a:pPr>
+            <a:r>
+              <a:t>SSO redirect error  →  Verify redirect URI matches exactly in Azure</a:t>
+            </a:r>
+          </a:p>
+          <a:p>
+            <a:pPr>
+              <a:spcBef>
+                <a:spcPts val="1000"/>
+              </a:spcBef>
+              <a:spcAft>
+                <a:spcPts val="400"/>
+              </a:spcAft>
+              <a:defRPr sz="2000">
+                <a:solidFill>
+                  <a:srgbClr val="FFFFFF"/>
+                </a:solidFill>
+              </a:defRPr>
+            </a:pPr>
+            <a:r>
+              <a:t>SSO auth failed  →  Client secret may have expired; create a new one</a:t>
+            </a:r>
+          </a:p>
+        </p:txBody>
+      </p:sp>
+    </p:spTree>
+  </p:cSld>
+  <p:clrMapOvr>
+    <a:masterClrMapping/>
+  </p:clrMapOvr>
+</p:sld>
+</file>
+
+<file path=ppt/slides/slide19.xml><?xml version="1.0" encoding="utf-8"?>
+<p:sld xmlns:a="http://schemas.openxmlformats.org/drawingml/2006/main" xmlns:p="http://schemas.openxmlformats.org/presentationml/2006/main" xmlns:r="http://schemas.openxmlformats.org/officeDocument/2006/relationships">
+  <p:cSld>
+    <p:bg>
+      <p:bgPr>
+        <a:solidFill>
+          <a:srgbClr val="2E2E38"/>
+        </a:solidFill>
+        <a:effectLst/>
+      </p:bgPr>
+    </p:bg>
+    <p:spTree>
+      <p:nvGrpSpPr>
+        <p:cNvPr id="1" name=""/>
+        <p:cNvGrpSpPr/>
+        <p:nvPr/>
+      </p:nvGrpSpPr>
+      <p:grpSpPr/>
+      <p:sp>
+        <p:nvSpPr>
+          <p:cNvPr id="2" name="Rectangle 1"/>
+          <p:cNvSpPr/>
+          <p:nvPr/>
+        </p:nvSpPr>
+        <p:spPr>
+          <a:xfrm>
+            <a:off x="0" y="0"/>
+            <a:ext cx="12191695" cy="73152"/>
+          </a:xfrm>
+          <a:prstGeom prst="rect">
+            <a:avLst/>
+          </a:prstGeom>
+          <a:solidFill>
+            <a:srgbClr val="FFE600"/>
+          </a:solidFill>
+          <a:ln>
+            <a:noFill/>
+          </a:ln>
+        </p:spPr>
+        <p:style>
+          <a:lnRef idx="1">
+            <a:schemeClr val="accent1"/>
+          </a:lnRef>
+          <a:fillRef idx="3">
+            <a:schemeClr val="accent1"/>
+          </a:fillRef>
+          <a:effectRef idx="2">
+            <a:schemeClr val="accent1"/>
+          </a:effectRef>
+          <a:fontRef idx="minor">
+            <a:schemeClr val="lt1"/>
+          </a:fontRef>
+        </p:style>
+        <p:txBody>
+          <a:bodyPr rtlCol="0" anchor="ctr"/>
+          <a:lstStyle/>
+          <a:p>
+            <a:pPr algn="ctr"/>
+          </a:p>
+        </p:txBody>
+      </p:sp>
+      <p:sp>
+        <p:nvSpPr>
+          <p:cNvPr id="3" name="TextBox 2"/>
+          <p:cNvSpPr txBox="1"/>
+          <p:nvPr/>
+        </p:nvSpPr>
+        <p:spPr>
+          <a:xfrm>
+            <a:off x="731520" y="320040"/>
+            <a:ext cx="10728655" cy="822960"/>
+          </a:xfrm>
+          <a:prstGeom prst="rect">
+            <a:avLst/>
+          </a:prstGeom>
+          <a:noFill/>
+        </p:spPr>
+        <p:txBody>
+          <a:bodyPr wrap="square">
+            <a:spAutoFit/>
+          </a:bodyPr>
+          <a:lstStyle/>
+          <a:p>
+            <a:pPr>
+              <a:defRPr sz="3000" b="1">
+                <a:solidFill>
+                  <a:srgbClr val="FFE600"/>
+                </a:solidFill>
+              </a:defRPr>
+            </a:pPr>
+            <a:r>
+              <a:t>Quick Reference: What to Tell Factory.AI</a:t>
+            </a:r>
+          </a:p>
+        </p:txBody>
+      </p:sp>
+      <p:sp>
+        <p:nvSpPr>
+          <p:cNvPr id="4" name="TextBox 3"/>
+          <p:cNvSpPr txBox="1"/>
+          <p:nvPr/>
+        </p:nvSpPr>
+        <p:spPr>
+          <a:xfrm>
+            <a:off x="914400" y="1371600"/>
+            <a:ext cx="10362895" cy="5029200"/>
+          </a:xfrm>
+          <a:prstGeom prst="rect">
+            <a:avLst/>
+          </a:prstGeom>
+          <a:noFill/>
+        </p:spPr>
+        <p:txBody>
+          <a:bodyPr wrap="square">
+            <a:spAutoFit/>
+          </a:bodyPr>
+          <a:lstStyle/>
+          <a:p>
+            <a:pPr>
+              <a:spcBef>
+                <a:spcPts val="1000"/>
+              </a:spcBef>
+              <a:spcAft>
+                <a:spcPts val="400"/>
+              </a:spcAft>
+              <a:defRPr sz="2000">
+                <a:solidFill>
+                  <a:srgbClr val="FFFFFF"/>
+                </a:solidFill>
+              </a:defRPr>
+            </a:pPr>
+            <a:r>
+              <a:t>Build a dashboard     →  "Create a Streamlit dashboard using [file]"</a:t>
+            </a:r>
+          </a:p>
+          <a:p>
+            <a:pPr>
+              <a:spcBef>
+                <a:spcPts val="1000"/>
+              </a:spcBef>
+              <a:spcAft>
+                <a:spcPts val="400"/>
+              </a:spcAft>
+              <a:defRPr sz="2000">
+                <a:solidFill>
+                  <a:srgbClr val="FFFFFF"/>
+                </a:solidFill>
+              </a:defRPr>
+            </a:pPr>
+            <a:r>
+              <a:t>Change a chart          →  "Change the bar chart to a line chart"</a:t>
+            </a:r>
+          </a:p>
+          <a:p>
+            <a:pPr>
+              <a:spcBef>
+                <a:spcPts val="1000"/>
+              </a:spcBef>
+              <a:spcAft>
+                <a:spcPts val="400"/>
+              </a:spcAft>
+              <a:defRPr sz="2000">
+                <a:solidFill>
+                  <a:srgbClr val="FFFFFF"/>
+                </a:solidFill>
+              </a:defRPr>
+            </a:pPr>
+            <a:r>
+              <a:t>Add a filter                 →  "Add a filter for [column name]"</a:t>
+            </a:r>
+          </a:p>
+          <a:p>
+            <a:pPr>
+              <a:spcBef>
+                <a:spcPts val="1000"/>
+              </a:spcBef>
+              <a:spcAft>
+                <a:spcPts val="400"/>
+              </a:spcAft>
+              <a:defRPr sz="2000">
+                <a:solidFill>
+                  <a:srgbClr val="FFFFFF"/>
+                </a:solidFill>
+              </a:defRPr>
+            </a:pPr>
+            <a:r>
+              <a:t>Fix an error                →  Paste the error, say "fix this"</a:t>
+            </a:r>
+          </a:p>
+          <a:p>
+            <a:pPr>
+              <a:spcBef>
+                <a:spcPts val="1000"/>
+              </a:spcBef>
+              <a:spcAft>
+                <a:spcPts val="400"/>
+              </a:spcAft>
+              <a:defRPr sz="2000">
+                <a:solidFill>
+                  <a:srgbClr val="FFFFFF"/>
+                </a:solidFill>
+              </a:defRPr>
+            </a:pPr>
+            <a:r>
+              <a:t>Push to GitHub          →  "Push the changes to GitHub"</a:t>
+            </a:r>
+          </a:p>
+        </p:txBody>
+      </p:sp>
+    </p:spTree>
+  </p:cSld>
+  <p:clrMapOvr>
+    <a:masterClrMapping/>
+  </p:clrMapOvr>
+</p:sld>
+</file>
+
+<file path=ppt/slides/slide2.xml><?xml version="1.0" encoding="utf-8"?>
+<p:sld xmlns:a="http://schemas.openxmlformats.org/drawingml/2006/main" xmlns:p="http://schemas.openxmlformats.org/presentationml/2006/main" xmlns:r="http://schemas.openxmlformats.org/officeDocument/2006/relationships">
+  <p:cSld>
+    <p:bg>
+      <p:bgPr>
+        <a:solidFill>
+          <a:srgbClr val="2E2E38"/>
+        </a:solidFill>
+        <a:effectLst/>
+      </p:bgPr>
+    </p:bg>
+    <p:spTree>
+      <p:nvGrpSpPr>
+        <p:cNvPr id="1" name=""/>
+        <p:cNvGrpSpPr/>
+        <p:nvPr/>
+      </p:nvGrpSpPr>
+      <p:grpSpPr/>
+      <p:sp>
+        <p:nvSpPr>
+          <p:cNvPr id="2" name="Rectangle 1"/>
+          <p:cNvSpPr/>
+          <p:nvPr/>
+        </p:nvSpPr>
+        <p:spPr>
+          <a:xfrm>
+            <a:off x="0" y="0"/>
+            <a:ext cx="12191695" cy="73152"/>
+          </a:xfrm>
+          <a:prstGeom prst="rect">
+            <a:avLst/>
+          </a:prstGeom>
+          <a:solidFill>
+            <a:srgbClr val="FFE600"/>
+          </a:solidFill>
+          <a:ln>
+            <a:noFill/>
+          </a:ln>
+        </p:spPr>
+        <p:style>
+          <a:lnRef idx="1">
+            <a:schemeClr val="accent1"/>
+          </a:lnRef>
+          <a:fillRef idx="3">
+            <a:schemeClr val="accent1"/>
+          </a:fillRef>
+          <a:effectRef idx="2">
+            <a:schemeClr val="accent1"/>
+          </a:effectRef>
+          <a:fontRef idx="minor">
+            <a:schemeClr val="lt1"/>
+          </a:fontRef>
+        </p:style>
+        <p:txBody>
+          <a:bodyPr rtlCol="0" anchor="ctr"/>
+          <a:lstStyle/>
+          <a:p>
+            <a:pPr algn="ctr"/>
+          </a:p>
+        </p:txBody>
+      </p:sp>
+      <p:sp>
+        <p:nvSpPr>
+          <p:cNvPr id="3" name="TextBox 2"/>
+          <p:cNvSpPr txBox="1"/>
+          <p:nvPr/>
+        </p:nvSpPr>
+        <p:spPr>
+          <a:xfrm>
+            <a:off x="731520" y="320040"/>
+            <a:ext cx="10728655" cy="822960"/>
+          </a:xfrm>
+          <a:prstGeom prst="rect">
+            <a:avLst/>
+          </a:prstGeom>
+          <a:noFill/>
+        </p:spPr>
+        <p:txBody>
+          <a:bodyPr wrap="square">
+            <a:spAutoFit/>
+          </a:bodyPr>
+          <a:lstStyle/>
+          <a:p>
+            <a:pPr>
+              <a:defRPr sz="3000" b="1">
+                <a:solidFill>
+                  <a:srgbClr val="FFE600"/>
+                </a:solidFill>
+              </a:defRPr>
+            </a:pPr>
+            <a:r>
+              <a:t>What You Will Build</a:t>
+            </a:r>
+          </a:p>
+        </p:txBody>
+      </p:sp>
+      <p:sp>
+        <p:nvSpPr>
+          <p:cNvPr id="4" name="TextBox 3"/>
+          <p:cNvSpPr txBox="1"/>
+          <p:nvPr/>
+        </p:nvSpPr>
+        <p:spPr>
+          <a:xfrm>
+            <a:off x="914400" y="1371600"/>
+            <a:ext cx="10362895" cy="5029200"/>
+          </a:xfrm>
+          <a:prstGeom prst="rect">
+            <a:avLst/>
+          </a:prstGeom>
+          <a:noFill/>
+        </p:spPr>
+        <p:txBody>
+          <a:bodyPr wrap="square">
+            <a:spAutoFit/>
+          </a:bodyPr>
+          <a:lstStyle/>
+          <a:p>
+            <a:pPr>
+              <a:spcBef>
+                <a:spcPts val="1000"/>
+              </a:spcBef>
+              <a:spcAft>
+                <a:spcPts val="400"/>
+              </a:spcAft>
+              <a:defRPr sz="2000">
+                <a:solidFill>
+                  <a:srgbClr val="FFFFFF"/>
+                </a:solidFill>
+              </a:defRPr>
+            </a:pPr>
+            <a:r>
               <a:t>A live, interactive dashboard from your Excel data</a:t>
             </a:r>
           </a:p>
@@ -4251,6 +6024,125 @@
             </a:pPr>
             <a:r>
               <a:t>Time: ~20 minutes  |  Technical experience: None</a:t>
+            </a:r>
+          </a:p>
+        </p:txBody>
+      </p:sp>
+    </p:spTree>
+  </p:cSld>
+  <p:clrMapOvr>
+    <a:masterClrMapping/>
+  </p:clrMapOvr>
+</p:sld>
+</file>
+
+<file path=ppt/slides/slide20.xml><?xml version="1.0" encoding="utf-8"?>
+<p:sld xmlns:a="http://schemas.openxmlformats.org/drawingml/2006/main" xmlns:p="http://schemas.openxmlformats.org/presentationml/2006/main" xmlns:r="http://schemas.openxmlformats.org/officeDocument/2006/relationships">
+  <p:cSld>
+    <p:bg>
+      <p:bgPr>
+        <a:solidFill>
+          <a:srgbClr val="2E2E38"/>
+        </a:solidFill>
+        <a:effectLst/>
+      </p:bgPr>
+    </p:bg>
+    <p:spTree>
+      <p:nvGrpSpPr>
+        <p:cNvPr id="1" name=""/>
+        <p:cNvGrpSpPr/>
+        <p:nvPr/>
+      </p:nvGrpSpPr>
+      <p:grpSpPr/>
+      <p:sp>
+        <p:nvSpPr>
+          <p:cNvPr id="2" name="Rectangle 1"/>
+          <p:cNvSpPr/>
+          <p:nvPr/>
+        </p:nvSpPr>
+        <p:spPr>
+          <a:xfrm>
+            <a:off x="0" y="0"/>
+            <a:ext cx="12191695" cy="73152"/>
+          </a:xfrm>
+          <a:prstGeom prst="rect">
+            <a:avLst/>
+          </a:prstGeom>
+          <a:solidFill>
+            <a:srgbClr val="FFE600"/>
+          </a:solidFill>
+          <a:ln>
+            <a:noFill/>
+          </a:ln>
+        </p:spPr>
+        <p:style>
+          <a:lnRef idx="1">
+            <a:schemeClr val="accent1"/>
+          </a:lnRef>
+          <a:fillRef idx="3">
+            <a:schemeClr val="accent1"/>
+          </a:fillRef>
+          <a:effectRef idx="2">
+            <a:schemeClr val="accent1"/>
+          </a:effectRef>
+          <a:fontRef idx="minor">
+            <a:schemeClr val="lt1"/>
+          </a:fontRef>
+        </p:style>
+        <p:txBody>
+          <a:bodyPr rtlCol="0" anchor="ctr"/>
+          <a:lstStyle/>
+          <a:p>
+            <a:pPr algn="ctr"/>
+          </a:p>
+        </p:txBody>
+      </p:sp>
+      <p:sp>
+        <p:nvSpPr>
+          <p:cNvPr id="3" name="TextBox 2"/>
+          <p:cNvSpPr txBox="1"/>
+          <p:nvPr/>
+        </p:nvSpPr>
+        <p:spPr>
+          <a:xfrm>
+            <a:off x="914400" y="2011680"/>
+            <a:ext cx="10362895" cy="1828800"/>
+          </a:xfrm>
+          <a:prstGeom prst="rect">
+            <a:avLst/>
+          </a:prstGeom>
+          <a:noFill/>
+        </p:spPr>
+        <p:txBody>
+          <a:bodyPr wrap="square">
+            <a:spAutoFit/>
+          </a:bodyPr>
+          <a:lstStyle/>
+          <a:p>
+            <a:pPr algn="ctr">
+              <a:defRPr sz="4000" b="1">
+                <a:solidFill>
+                  <a:srgbClr val="FFFFFF"/>
+                </a:solidFill>
+              </a:defRPr>
+            </a:pPr>
+            <a:r>
+              <a:t>Start Building Today</a:t>
+            </a:r>
+          </a:p>
+          <a:p>
+            <a:pPr algn="ctr">
+              <a:spcBef>
+                <a:spcPts val="1600"/>
+              </a:spcBef>
+              <a:defRPr sz="2200">
+                <a:solidFill>
+                  <a:srgbClr val="FFE600"/>
+                </a:solidFill>
+              </a:defRPr>
+            </a:pPr>
+            <a:r>
+              <a:t>factory.ai</a:t>
             </a:r>
           </a:p>
         </p:txBody>

</xml_diff>

<commit_message>
Integrate SSO as core part of guide from the start, not optional add-on
Co-authored-by: factory-droid[bot] <138933559+factory-droid[bot]@users.noreply.github.com>
</commit_message>
<xml_diff>
--- a/Factory_AI_Dashboard_Guide.pptx
+++ b/Factory_AI_Dashboard_Guide.pptx
@@ -25,6 +25,7 @@
     <p:sldId id="273" r:id="rId24"/>
     <p:sldId id="274" r:id="rId25"/>
     <p:sldId id="275" r:id="rId26"/>
+    <p:sldId id="276" r:id="rId27"/>
   </p:sldIdLst>
   <p:sldSz cx="12191695" cy="6858000" type="screen4x3"/>
   <p:notesSz cx="6858000" cy="9144000"/>
@@ -3311,7 +3312,7 @@
               </a:defRPr>
             </a:pPr>
             <a:r>
-              <a:t>Step 7: Keep It Updated</a:t>
+              <a:t>Step 6: Share With Your Team</a:t>
             </a:r>
           </a:p>
         </p:txBody>
@@ -3352,127 +3353,145 @@
               </a:defRPr>
             </a:pPr>
             <a:r>
-              <a:t>To update data:</a:t>
-            </a:r>
-          </a:p>
-          <a:p>
-            <a:pPr>
-              <a:spcBef>
-                <a:spcPts val="1000"/>
-              </a:spcBef>
-              <a:spcAft>
-                <a:spcPts val="400"/>
-              </a:spcAft>
-              <a:defRPr sz="2000">
-                <a:solidFill>
-                  <a:srgbClr val="FFFFFF"/>
-                </a:solidFill>
-              </a:defRPr>
-            </a:pPr>
-            <a:r>
-              <a:t>   Tell Factory.AI: "Copy latest Excel into data folder</a:t>
-            </a:r>
-          </a:p>
-          <a:p>
-            <a:pPr>
-              <a:spcBef>
-                <a:spcPts val="1000"/>
-              </a:spcBef>
-              <a:spcAft>
-                <a:spcPts val="400"/>
-              </a:spcAft>
-              <a:defRPr sz="2000">
-                <a:solidFill>
-                  <a:srgbClr val="FFFFFF"/>
-                </a:solidFill>
-              </a:defRPr>
-            </a:pPr>
-            <a:r>
-              <a:t>   and push to GitHub"</a:t>
-            </a:r>
-          </a:p>
-          <a:p>
-            <a:pPr>
-              <a:spcBef>
-                <a:spcPts val="1000"/>
-              </a:spcBef>
-              <a:spcAft>
-                <a:spcPts val="400"/>
-              </a:spcAft>
-              <a:defRPr sz="2000">
-                <a:solidFill>
-                  <a:srgbClr val="FFFFFF"/>
-                </a:solidFill>
-              </a:defRPr>
-            </a:pPr>
-          </a:p>
-          <a:p>
-            <a:pPr>
-              <a:spcBef>
-                <a:spcPts val="1000"/>
-              </a:spcBef>
-              <a:spcAft>
-                <a:spcPts val="400"/>
-              </a:spcAft>
-              <a:defRPr sz="2000">
-                <a:solidFill>
-                  <a:srgbClr val="FFFFFF"/>
-                </a:solidFill>
-              </a:defRPr>
-            </a:pPr>
-            <a:r>
-              <a:t>To change the dashboard:</a:t>
-            </a:r>
-          </a:p>
-          <a:p>
-            <a:pPr>
-              <a:spcBef>
-                <a:spcPts val="1000"/>
-              </a:spcBef>
-              <a:spcAft>
-                <a:spcPts val="400"/>
-              </a:spcAft>
-              <a:defRPr sz="2000">
-                <a:solidFill>
-                  <a:srgbClr val="FFFFFF"/>
-                </a:solidFill>
-              </a:defRPr>
-            </a:pPr>
-            <a:r>
-              <a:t>   Describe what you want → "push changes to GitHub"</a:t>
-            </a:r>
-          </a:p>
-          <a:p>
-            <a:pPr>
-              <a:spcBef>
-                <a:spcPts val="1000"/>
-              </a:spcBef>
-              <a:spcAft>
-                <a:spcPts val="400"/>
-              </a:spcAft>
-              <a:defRPr sz="2000">
-                <a:solidFill>
-                  <a:srgbClr val="FFFFFF"/>
-                </a:solidFill>
-              </a:defRPr>
-            </a:pPr>
-          </a:p>
-          <a:p>
-            <a:pPr>
-              <a:spcBef>
-                <a:spcPts val="1000"/>
-              </a:spcBef>
-              <a:spcAft>
-                <a:spcPts val="400"/>
-              </a:spcAft>
-              <a:defRPr sz="2000">
-                <a:solidFill>
-                  <a:srgbClr val="FFFFFF"/>
-                </a:solidFill>
-              </a:defRPr>
-            </a:pPr>
-            <a:r>
-              <a:t>Streamlit Cloud redeploys automatically (~1 minute).</a:t>
+              <a:t>Share the Streamlit URL to start testing.</a:t>
+            </a:r>
+          </a:p>
+          <a:p>
+            <a:pPr>
+              <a:spcBef>
+                <a:spcPts val="1000"/>
+              </a:spcBef>
+              <a:spcAft>
+                <a:spcPts val="400"/>
+              </a:spcAft>
+              <a:defRPr sz="2000">
+                <a:solidFill>
+                  <a:srgbClr val="FFFFFF"/>
+                </a:solidFill>
+              </a:defRPr>
+            </a:pPr>
+            <a:r>
+              <a:t>For sensitive data, complete Step 8 (SSO) before sharing broadly.</a:t>
+            </a:r>
+          </a:p>
+          <a:p>
+            <a:pPr>
+              <a:spcBef>
+                <a:spcPts val="1000"/>
+              </a:spcBef>
+              <a:spcAft>
+                <a:spcPts val="400"/>
+              </a:spcAft>
+              <a:defRPr sz="2000">
+                <a:solidFill>
+                  <a:srgbClr val="FFFFFF"/>
+                </a:solidFill>
+              </a:defRPr>
+            </a:pPr>
+          </a:p>
+          <a:p>
+            <a:pPr>
+              <a:spcBef>
+                <a:spcPts val="1000"/>
+              </a:spcBef>
+              <a:spcAft>
+                <a:spcPts val="400"/>
+              </a:spcAft>
+              <a:defRPr sz="2000">
+                <a:solidFill>
+                  <a:srgbClr val="FFFFFF"/>
+                </a:solidFill>
+              </a:defRPr>
+            </a:pPr>
+            <a:r>
+              <a:t>Access model:</a:t>
+            </a:r>
+          </a:p>
+          <a:p>
+            <a:pPr>
+              <a:spcBef>
+                <a:spcPts val="1000"/>
+              </a:spcBef>
+              <a:spcAft>
+                <a:spcPts val="400"/>
+              </a:spcAft>
+              <a:defRPr sz="2000">
+                <a:solidFill>
+                  <a:srgbClr val="FFFFFF"/>
+                </a:solidFill>
+              </a:defRPr>
+            </a:pPr>
+            <a:r>
+              <a:t>   Any @ey.com email  →  View dashboard (read-only)</a:t>
+            </a:r>
+          </a:p>
+          <a:p>
+            <a:pPr>
+              <a:spcBef>
+                <a:spcPts val="1000"/>
+              </a:spcBef>
+              <a:spcAft>
+                <a:spcPts val="400"/>
+              </a:spcAft>
+              <a:defRPr sz="2000">
+                <a:solidFill>
+                  <a:srgbClr val="FFFFFF"/>
+                </a:solidFill>
+              </a:defRPr>
+            </a:pPr>
+            <a:r>
+              <a:t>   Admins you configure  →  Edit data, manage access</a:t>
+            </a:r>
+          </a:p>
+          <a:p>
+            <a:pPr>
+              <a:spcBef>
+                <a:spcPts val="1000"/>
+              </a:spcBef>
+              <a:spcAft>
+                <a:spcPts val="400"/>
+              </a:spcAft>
+              <a:defRPr sz="2000">
+                <a:solidFill>
+                  <a:srgbClr val="FFFFFF"/>
+                </a:solidFill>
+              </a:defRPr>
+            </a:pPr>
+          </a:p>
+          <a:p>
+            <a:pPr>
+              <a:spcBef>
+                <a:spcPts val="1000"/>
+              </a:spcBef>
+              <a:spcAft>
+                <a:spcPts val="400"/>
+              </a:spcAft>
+              <a:defRPr sz="2000">
+                <a:solidFill>
+                  <a:srgbClr val="FFFFFF"/>
+                </a:solidFill>
+              </a:defRPr>
+            </a:pPr>
+            <a:r>
+              <a:t>To add an admin: scroll to bottom of dashboard</a:t>
+            </a:r>
+          </a:p>
+          <a:p>
+            <a:pPr>
+              <a:spcBef>
+                <a:spcPts val="1000"/>
+              </a:spcBef>
+              <a:spcAft>
+                <a:spcPts val="400"/>
+              </a:spcAft>
+              <a:defRPr sz="2000">
+                <a:solidFill>
+                  <a:srgbClr val="FFFFFF"/>
+                </a:solidFill>
+              </a:defRPr>
+            </a:pPr>
+            <a:r>
+              <a:t>   → "Admin: Manage Admins" → enter their @ey.com email</a:t>
             </a:r>
           </a:p>
         </p:txBody>
@@ -3576,7 +3595,7 @@
               </a:defRPr>
             </a:pPr>
             <a:r>
-              <a:t>Step 8: Secure with Microsoft SSO</a:t>
+              <a:t>Step 7: Keep It Updated</a:t>
             </a:r>
           </a:p>
         </p:txBody>
@@ -3617,109 +3636,127 @@
               </a:defRPr>
             </a:pPr>
             <a:r>
-              <a:t>Without SSO, anyone can type any @ey.com email — no verification.</a:t>
-            </a:r>
-          </a:p>
-          <a:p>
-            <a:pPr>
-              <a:spcBef>
-                <a:spcPts val="1000"/>
-              </a:spcBef>
-              <a:spcAft>
-                <a:spcPts val="400"/>
-              </a:spcAft>
-              <a:defRPr sz="2000">
-                <a:solidFill>
-                  <a:srgbClr val="FFFFFF"/>
-                </a:solidFill>
-              </a:defRPr>
-            </a:pPr>
-            <a:r>
-              <a:t>With SSO, users sign in with their real EY Microsoft account.</a:t>
-            </a:r>
-          </a:p>
-          <a:p>
-            <a:pPr>
-              <a:spcBef>
-                <a:spcPts val="1000"/>
-              </a:spcBef>
-              <a:spcAft>
-                <a:spcPts val="400"/>
-              </a:spcAft>
-              <a:defRPr sz="2000">
-                <a:solidFill>
-                  <a:srgbClr val="FFFFFF"/>
-                </a:solidFill>
-              </a:defRPr>
-            </a:pPr>
-          </a:p>
-          <a:p>
-            <a:pPr>
-              <a:spcBef>
-                <a:spcPts val="1000"/>
-              </a:spcBef>
-              <a:spcAft>
-                <a:spcPts val="400"/>
-              </a:spcAft>
-              <a:defRPr sz="2000">
-                <a:solidFill>
-                  <a:srgbClr val="FFFFFF"/>
-                </a:solidFill>
-              </a:defRPr>
-            </a:pPr>
-            <a:r>
-              <a:t>IMPORTANT: Required if your dashboard has sensitive data.</a:t>
-            </a:r>
-          </a:p>
-          <a:p>
-            <a:pPr>
-              <a:spcBef>
-                <a:spcPts val="1000"/>
-              </a:spcBef>
-              <a:spcAft>
-                <a:spcPts val="400"/>
-              </a:spcAft>
-              <a:defRPr sz="2000">
-                <a:solidFill>
-                  <a:srgbClr val="FFFFFF"/>
-                </a:solidFill>
-              </a:defRPr>
-            </a:pPr>
-          </a:p>
-          <a:p>
-            <a:pPr>
-              <a:spcBef>
-                <a:spcPts val="1000"/>
-              </a:spcBef>
-              <a:spcAft>
-                <a:spcPts val="400"/>
-              </a:spcAft>
-              <a:defRPr sz="2000">
-                <a:solidFill>
-                  <a:srgbClr val="FFFFFF"/>
-                </a:solidFill>
-              </a:defRPr>
-            </a:pPr>
-            <a:r>
-              <a:t>Good news: The code already supports SSO.</a:t>
-            </a:r>
-          </a:p>
-          <a:p>
-            <a:pPr>
-              <a:spcBef>
-                <a:spcPts val="1000"/>
-              </a:spcBef>
-              <a:spcAft>
-                <a:spcPts val="400"/>
-              </a:spcAft>
-              <a:defRPr sz="2000">
-                <a:solidFill>
-                  <a:srgbClr val="FFFFFF"/>
-                </a:solidFill>
-              </a:defRPr>
-            </a:pPr>
-            <a:r>
-              <a:t>You only need to paste 3 values — zero code changes.</a:t>
+              <a:t>To update data:</a:t>
+            </a:r>
+          </a:p>
+          <a:p>
+            <a:pPr>
+              <a:spcBef>
+                <a:spcPts val="1000"/>
+              </a:spcBef>
+              <a:spcAft>
+                <a:spcPts val="400"/>
+              </a:spcAft>
+              <a:defRPr sz="2000">
+                <a:solidFill>
+                  <a:srgbClr val="FFFFFF"/>
+                </a:solidFill>
+              </a:defRPr>
+            </a:pPr>
+            <a:r>
+              <a:t>   Tell Factory.AI: "Copy latest Excel into data folder</a:t>
+            </a:r>
+          </a:p>
+          <a:p>
+            <a:pPr>
+              <a:spcBef>
+                <a:spcPts val="1000"/>
+              </a:spcBef>
+              <a:spcAft>
+                <a:spcPts val="400"/>
+              </a:spcAft>
+              <a:defRPr sz="2000">
+                <a:solidFill>
+                  <a:srgbClr val="FFFFFF"/>
+                </a:solidFill>
+              </a:defRPr>
+            </a:pPr>
+            <a:r>
+              <a:t>   and push to GitHub"</a:t>
+            </a:r>
+          </a:p>
+          <a:p>
+            <a:pPr>
+              <a:spcBef>
+                <a:spcPts val="1000"/>
+              </a:spcBef>
+              <a:spcAft>
+                <a:spcPts val="400"/>
+              </a:spcAft>
+              <a:defRPr sz="2000">
+                <a:solidFill>
+                  <a:srgbClr val="FFFFFF"/>
+                </a:solidFill>
+              </a:defRPr>
+            </a:pPr>
+          </a:p>
+          <a:p>
+            <a:pPr>
+              <a:spcBef>
+                <a:spcPts val="1000"/>
+              </a:spcBef>
+              <a:spcAft>
+                <a:spcPts val="400"/>
+              </a:spcAft>
+              <a:defRPr sz="2000">
+                <a:solidFill>
+                  <a:srgbClr val="FFFFFF"/>
+                </a:solidFill>
+              </a:defRPr>
+            </a:pPr>
+            <a:r>
+              <a:t>To change the dashboard:</a:t>
+            </a:r>
+          </a:p>
+          <a:p>
+            <a:pPr>
+              <a:spcBef>
+                <a:spcPts val="1000"/>
+              </a:spcBef>
+              <a:spcAft>
+                <a:spcPts val="400"/>
+              </a:spcAft>
+              <a:defRPr sz="2000">
+                <a:solidFill>
+                  <a:srgbClr val="FFFFFF"/>
+                </a:solidFill>
+              </a:defRPr>
+            </a:pPr>
+            <a:r>
+              <a:t>   Describe what you want → "push changes to GitHub"</a:t>
+            </a:r>
+          </a:p>
+          <a:p>
+            <a:pPr>
+              <a:spcBef>
+                <a:spcPts val="1000"/>
+              </a:spcBef>
+              <a:spcAft>
+                <a:spcPts val="400"/>
+              </a:spcAft>
+              <a:defRPr sz="2000">
+                <a:solidFill>
+                  <a:srgbClr val="FFFFFF"/>
+                </a:solidFill>
+              </a:defRPr>
+            </a:pPr>
+          </a:p>
+          <a:p>
+            <a:pPr>
+              <a:spcBef>
+                <a:spcPts val="1000"/>
+              </a:spcBef>
+              <a:spcAft>
+                <a:spcPts val="400"/>
+              </a:spcAft>
+              <a:defRPr sz="2000">
+                <a:solidFill>
+                  <a:srgbClr val="FFFFFF"/>
+                </a:solidFill>
+              </a:defRPr>
+            </a:pPr>
+            <a:r>
+              <a:t>Streamlit Cloud redeploys automatically (~1 minute).</a:t>
             </a:r>
           </a:p>
         </p:txBody>
@@ -3823,7 +3860,7 @@
               </a:defRPr>
             </a:pPr>
             <a:r>
-              <a:t>Step 8a: Register an App in Azure</a:t>
+              <a:t>Step 8: Activate Microsoft SSO</a:t>
             </a:r>
           </a:p>
         </p:txBody>
@@ -3864,130 +3901,109 @@
               </a:defRPr>
             </a:pPr>
             <a:r>
-              <a:t>You need someone with Azure AD admin access (typically IT).</a:t>
-            </a:r>
-          </a:p>
-          <a:p>
-            <a:pPr>
-              <a:spcBef>
-                <a:spcPts val="1000"/>
-              </a:spcBef>
-              <a:spcAft>
-                <a:spcPts val="400"/>
-              </a:spcAft>
-              <a:defRPr sz="2000">
-                <a:solidFill>
-                  <a:srgbClr val="FFFFFF"/>
-                </a:solidFill>
-              </a:defRPr>
-            </a:pPr>
-          </a:p>
-          <a:p>
-            <a:pPr>
-              <a:spcBef>
-                <a:spcPts val="1000"/>
-              </a:spcBef>
-              <a:spcAft>
-                <a:spcPts val="400"/>
-              </a:spcAft>
-              <a:defRPr sz="2000">
-                <a:solidFill>
-                  <a:srgbClr val="FFFFFF"/>
-                </a:solidFill>
-              </a:defRPr>
-            </a:pPr>
-            <a:r>
-              <a:t>1.  Go to portal.azure.com &gt; search 'App registrations'</a:t>
-            </a:r>
-          </a:p>
-          <a:p>
-            <a:pPr>
-              <a:spcBef>
-                <a:spcPts val="1000"/>
-              </a:spcBef>
-              <a:spcAft>
-                <a:spcPts val="400"/>
-              </a:spcAft>
-              <a:defRPr sz="2000">
-                <a:solidFill>
-                  <a:srgbClr val="FFFFFF"/>
-                </a:solidFill>
-              </a:defRPr>
-            </a:pPr>
-            <a:r>
-              <a:t>2.  Click '+ New registration'</a:t>
-            </a:r>
-          </a:p>
-          <a:p>
-            <a:pPr>
-              <a:spcBef>
-                <a:spcPts val="1000"/>
-              </a:spcBef>
-              <a:spcAft>
-                <a:spcPts val="400"/>
-              </a:spcAft>
-              <a:defRPr sz="2000">
-                <a:solidFill>
-                  <a:srgbClr val="FFFFFF"/>
-                </a:solidFill>
-              </a:defRPr>
-            </a:pPr>
-            <a:r>
-              <a:t>3.  Name: 'Factory AI Dashboard'</a:t>
-            </a:r>
-          </a:p>
-          <a:p>
-            <a:pPr>
-              <a:spcBef>
-                <a:spcPts val="1000"/>
-              </a:spcBef>
-              <a:spcAft>
-                <a:spcPts val="400"/>
-              </a:spcAft>
-              <a:defRPr sz="2000">
-                <a:solidFill>
-                  <a:srgbClr val="FFFFFF"/>
-                </a:solidFill>
-              </a:defRPr>
-            </a:pPr>
-            <a:r>
-              <a:t>4.  Account type: 'This organizational directory only' (EY only)</a:t>
-            </a:r>
-          </a:p>
-          <a:p>
-            <a:pPr>
-              <a:spcBef>
-                <a:spcPts val="1000"/>
-              </a:spcBef>
-              <a:spcAft>
-                <a:spcPts val="400"/>
-              </a:spcAft>
-              <a:defRPr sz="2000">
-                <a:solidFill>
-                  <a:srgbClr val="FFFFFF"/>
-                </a:solidFill>
-              </a:defRPr>
-            </a:pPr>
-            <a:r>
-              <a:t>5.  Redirect URI: Web &gt; your Streamlit Cloud URL</a:t>
-            </a:r>
-          </a:p>
-          <a:p>
-            <a:pPr>
-              <a:spcBef>
-                <a:spcPts val="1000"/>
-              </a:spcBef>
-              <a:spcAft>
-                <a:spcPts val="400"/>
-              </a:spcAft>
-              <a:defRPr sz="2000">
-                <a:solidFill>
-                  <a:srgbClr val="FFFFFF"/>
-                </a:solidFill>
-              </a:defRPr>
-            </a:pPr>
-            <a:r>
-              <a:t>6.  Click 'Register'</a:t>
+              <a:t>Your app already has SSO built in from Step 2.</a:t>
+            </a:r>
+          </a:p>
+          <a:p>
+            <a:pPr>
+              <a:spcBef>
+                <a:spcPts val="1000"/>
+              </a:spcBef>
+              <a:spcAft>
+                <a:spcPts val="400"/>
+              </a:spcAft>
+              <a:defRPr sz="2000">
+                <a:solidFill>
+                  <a:srgbClr val="FFFFFF"/>
+                </a:solidFill>
+              </a:defRPr>
+            </a:pPr>
+            <a:r>
+              <a:t>Now you activate it with the 3 values from your IT team.</a:t>
+            </a:r>
+          </a:p>
+          <a:p>
+            <a:pPr>
+              <a:spcBef>
+                <a:spcPts val="1000"/>
+              </a:spcBef>
+              <a:spcAft>
+                <a:spcPts val="400"/>
+              </a:spcAft>
+              <a:defRPr sz="2000">
+                <a:solidFill>
+                  <a:srgbClr val="FFFFFF"/>
+                </a:solidFill>
+              </a:defRPr>
+            </a:pPr>
+          </a:p>
+          <a:p>
+            <a:pPr>
+              <a:spcBef>
+                <a:spcPts val="1000"/>
+              </a:spcBef>
+              <a:spcAft>
+                <a:spcPts val="400"/>
+              </a:spcAft>
+              <a:defRPr sz="2000">
+                <a:solidFill>
+                  <a:srgbClr val="FFFFFF"/>
+                </a:solidFill>
+              </a:defRPr>
+            </a:pPr>
+            <a:r>
+              <a:t>Without SSO: anyone can type any @ey.com email — no verification.</a:t>
+            </a:r>
+          </a:p>
+          <a:p>
+            <a:pPr>
+              <a:spcBef>
+                <a:spcPts val="1000"/>
+              </a:spcBef>
+              <a:spcAft>
+                <a:spcPts val="400"/>
+              </a:spcAft>
+              <a:defRPr sz="2000">
+                <a:solidFill>
+                  <a:srgbClr val="FFFFFF"/>
+                </a:solidFill>
+              </a:defRPr>
+            </a:pPr>
+            <a:r>
+              <a:t>With SSO: users sign in with their real EY Microsoft account.</a:t>
+            </a:r>
+          </a:p>
+          <a:p>
+            <a:pPr>
+              <a:spcBef>
+                <a:spcPts val="1000"/>
+              </a:spcBef>
+              <a:spcAft>
+                <a:spcPts val="400"/>
+              </a:spcAft>
+              <a:defRPr sz="2000">
+                <a:solidFill>
+                  <a:srgbClr val="FFFFFF"/>
+                </a:solidFill>
+              </a:defRPr>
+            </a:pPr>
+          </a:p>
+          <a:p>
+            <a:pPr>
+              <a:spcBef>
+                <a:spcPts val="1000"/>
+              </a:spcBef>
+              <a:spcAft>
+                <a:spcPts val="400"/>
+              </a:spcAft>
+              <a:defRPr sz="2000">
+                <a:solidFill>
+                  <a:srgbClr val="FFFFFF"/>
+                </a:solidFill>
+              </a:defRPr>
+            </a:pPr>
+            <a:r>
+              <a:t>Zero code changes needed — you are only pasting configuration.</a:t>
             </a:r>
           </a:p>
         </p:txBody>
@@ -4091,7 +4107,7 @@
               </a:defRPr>
             </a:pPr>
             <a:r>
-              <a:t>Step 8b-c: Get Your Three Values</a:t>
+              <a:t>Step 8a: Register an App in Azure</a:t>
             </a:r>
           </a:p>
         </p:txBody>
@@ -4132,127 +4148,130 @@
               </a:defRPr>
             </a:pPr>
             <a:r>
-              <a:t>From the app Overview page, copy:</a:t>
-            </a:r>
-          </a:p>
-          <a:p>
-            <a:pPr>
-              <a:spcBef>
-                <a:spcPts val="1000"/>
-              </a:spcBef>
-              <a:spcAft>
-                <a:spcPts val="400"/>
-              </a:spcAft>
-              <a:defRPr sz="2000">
-                <a:solidFill>
-                  <a:srgbClr val="FFFFFF"/>
-                </a:solidFill>
-              </a:defRPr>
-            </a:pPr>
-            <a:r>
-              <a:t>   1.  Application (client) ID  →  your client_id</a:t>
-            </a:r>
-          </a:p>
-          <a:p>
-            <a:pPr>
-              <a:spcBef>
-                <a:spcPts val="1000"/>
-              </a:spcBef>
-              <a:spcAft>
-                <a:spcPts val="400"/>
-              </a:spcAft>
-              <a:defRPr sz="2000">
-                <a:solidFill>
-                  <a:srgbClr val="FFFFFF"/>
-                </a:solidFill>
-              </a:defRPr>
-            </a:pPr>
-            <a:r>
-              <a:t>   2.  Directory (tenant) ID    →  your tenant_id</a:t>
-            </a:r>
-          </a:p>
-          <a:p>
-            <a:pPr>
-              <a:spcBef>
-                <a:spcPts val="1000"/>
-              </a:spcBef>
-              <a:spcAft>
-                <a:spcPts val="400"/>
-              </a:spcAft>
-              <a:defRPr sz="2000">
-                <a:solidFill>
-                  <a:srgbClr val="FFFFFF"/>
-                </a:solidFill>
-              </a:defRPr>
-            </a:pPr>
-          </a:p>
-          <a:p>
-            <a:pPr>
-              <a:spcBef>
-                <a:spcPts val="1000"/>
-              </a:spcBef>
-              <a:spcAft>
-                <a:spcPts val="400"/>
-              </a:spcAft>
-              <a:defRPr sz="2000">
-                <a:solidFill>
-                  <a:srgbClr val="FFFFFF"/>
-                </a:solidFill>
-              </a:defRPr>
-            </a:pPr>
-            <a:r>
-              <a:t>Then go to Certificates &amp; secrets:</a:t>
-            </a:r>
-          </a:p>
-          <a:p>
-            <a:pPr>
-              <a:spcBef>
-                <a:spcPts val="1000"/>
-              </a:spcBef>
-              <a:spcAft>
-                <a:spcPts val="400"/>
-              </a:spcAft>
-              <a:defRPr sz="2000">
-                <a:solidFill>
-                  <a:srgbClr val="FFFFFF"/>
-                </a:solidFill>
-              </a:defRPr>
-            </a:pPr>
-            <a:r>
-              <a:t>   3.  Click '+ New client secret' &gt; copy the Value  →  your client_secret</a:t>
-            </a:r>
-          </a:p>
-          <a:p>
-            <a:pPr>
-              <a:spcBef>
-                <a:spcPts val="1000"/>
-              </a:spcBef>
-              <a:spcAft>
-                <a:spcPts val="400"/>
-              </a:spcAft>
-              <a:defRPr sz="2000">
-                <a:solidFill>
-                  <a:srgbClr val="FFFFFF"/>
-                </a:solidFill>
-              </a:defRPr>
-            </a:pPr>
-          </a:p>
-          <a:p>
-            <a:pPr>
-              <a:spcBef>
-                <a:spcPts val="1000"/>
-              </a:spcBef>
-              <a:spcAft>
-                <a:spcPts val="400"/>
-              </a:spcAft>
-              <a:defRPr sz="2000">
-                <a:solidFill>
-                  <a:srgbClr val="FFFFFF"/>
-                </a:solidFill>
-              </a:defRPr>
-            </a:pPr>
-            <a:r>
-              <a:t>IMPORTANT: The secret is only shown once — copy it immediately.</a:t>
+              <a:t>You need someone with Azure AD admin access (typically IT).</a:t>
+            </a:r>
+          </a:p>
+          <a:p>
+            <a:pPr>
+              <a:spcBef>
+                <a:spcPts val="1000"/>
+              </a:spcBef>
+              <a:spcAft>
+                <a:spcPts val="400"/>
+              </a:spcAft>
+              <a:defRPr sz="2000">
+                <a:solidFill>
+                  <a:srgbClr val="FFFFFF"/>
+                </a:solidFill>
+              </a:defRPr>
+            </a:pPr>
+          </a:p>
+          <a:p>
+            <a:pPr>
+              <a:spcBef>
+                <a:spcPts val="1000"/>
+              </a:spcBef>
+              <a:spcAft>
+                <a:spcPts val="400"/>
+              </a:spcAft>
+              <a:defRPr sz="2000">
+                <a:solidFill>
+                  <a:srgbClr val="FFFFFF"/>
+                </a:solidFill>
+              </a:defRPr>
+            </a:pPr>
+            <a:r>
+              <a:t>1.  Go to portal.azure.com &gt; search 'App registrations'</a:t>
+            </a:r>
+          </a:p>
+          <a:p>
+            <a:pPr>
+              <a:spcBef>
+                <a:spcPts val="1000"/>
+              </a:spcBef>
+              <a:spcAft>
+                <a:spcPts val="400"/>
+              </a:spcAft>
+              <a:defRPr sz="2000">
+                <a:solidFill>
+                  <a:srgbClr val="FFFFFF"/>
+                </a:solidFill>
+              </a:defRPr>
+            </a:pPr>
+            <a:r>
+              <a:t>2.  Click '+ New registration'</a:t>
+            </a:r>
+          </a:p>
+          <a:p>
+            <a:pPr>
+              <a:spcBef>
+                <a:spcPts val="1000"/>
+              </a:spcBef>
+              <a:spcAft>
+                <a:spcPts val="400"/>
+              </a:spcAft>
+              <a:defRPr sz="2000">
+                <a:solidFill>
+                  <a:srgbClr val="FFFFFF"/>
+                </a:solidFill>
+              </a:defRPr>
+            </a:pPr>
+            <a:r>
+              <a:t>3.  Name: 'Factory AI Dashboard'</a:t>
+            </a:r>
+          </a:p>
+          <a:p>
+            <a:pPr>
+              <a:spcBef>
+                <a:spcPts val="1000"/>
+              </a:spcBef>
+              <a:spcAft>
+                <a:spcPts val="400"/>
+              </a:spcAft>
+              <a:defRPr sz="2000">
+                <a:solidFill>
+                  <a:srgbClr val="FFFFFF"/>
+                </a:solidFill>
+              </a:defRPr>
+            </a:pPr>
+            <a:r>
+              <a:t>4.  Account type: 'This organizational directory only' (EY only)</a:t>
+            </a:r>
+          </a:p>
+          <a:p>
+            <a:pPr>
+              <a:spcBef>
+                <a:spcPts val="1000"/>
+              </a:spcBef>
+              <a:spcAft>
+                <a:spcPts val="400"/>
+              </a:spcAft>
+              <a:defRPr sz="2000">
+                <a:solidFill>
+                  <a:srgbClr val="FFFFFF"/>
+                </a:solidFill>
+              </a:defRPr>
+            </a:pPr>
+            <a:r>
+              <a:t>5.  Redirect URI: Web &gt; your Streamlit Cloud URL</a:t>
+            </a:r>
+          </a:p>
+          <a:p>
+            <a:pPr>
+              <a:spcBef>
+                <a:spcPts val="1000"/>
+              </a:spcBef>
+              <a:spcAft>
+                <a:spcPts val="400"/>
+              </a:spcAft>
+              <a:defRPr sz="2000">
+                <a:solidFill>
+                  <a:srgbClr val="FFFFFF"/>
+                </a:solidFill>
+              </a:defRPr>
+            </a:pPr>
+            <a:r>
+              <a:t>6.  Click 'Register'</a:t>
             </a:r>
           </a:p>
         </p:txBody>
@@ -4356,7 +4375,7 @@
               </a:defRPr>
             </a:pPr>
             <a:r>
-              <a:t>Step 8d: Add API Permissions</a:t>
+              <a:t>Step 8b-c: Get Your Three Values</a:t>
             </a:r>
           </a:p>
         </p:txBody>
@@ -4397,112 +4416,127 @@
               </a:defRPr>
             </a:pPr>
             <a:r>
-              <a:t>1.  Go to API permissions &gt; '+ Add a permission'</a:t>
-            </a:r>
-          </a:p>
-          <a:p>
-            <a:pPr>
-              <a:spcBef>
-                <a:spcPts val="1000"/>
-              </a:spcBef>
-              <a:spcAft>
-                <a:spcPts val="400"/>
-              </a:spcAft>
-              <a:defRPr sz="2000">
-                <a:solidFill>
-                  <a:srgbClr val="FFFFFF"/>
-                </a:solidFill>
-              </a:defRPr>
-            </a:pPr>
-            <a:r>
-              <a:t>2.  Select 'Microsoft Graph' &gt; 'Delegated permissions'</a:t>
-            </a:r>
-          </a:p>
-          <a:p>
-            <a:pPr>
-              <a:spcBef>
-                <a:spcPts val="1000"/>
-              </a:spcBef>
-              <a:spcAft>
-                <a:spcPts val="400"/>
-              </a:spcAft>
-              <a:defRPr sz="2000">
-                <a:solidFill>
-                  <a:srgbClr val="FFFFFF"/>
-                </a:solidFill>
-              </a:defRPr>
-            </a:pPr>
-            <a:r>
-              <a:t>3.  Search for 'User.Read' and check it</a:t>
-            </a:r>
-          </a:p>
-          <a:p>
-            <a:pPr>
-              <a:spcBef>
-                <a:spcPts val="1000"/>
-              </a:spcBef>
-              <a:spcAft>
-                <a:spcPts val="400"/>
-              </a:spcAft>
-              <a:defRPr sz="2000">
-                <a:solidFill>
-                  <a:srgbClr val="FFFFFF"/>
-                </a:solidFill>
-              </a:defRPr>
-            </a:pPr>
-            <a:r>
-              <a:t>4.  Click 'Add permissions'</a:t>
-            </a:r>
-          </a:p>
-          <a:p>
-            <a:pPr>
-              <a:spcBef>
-                <a:spcPts val="1000"/>
-              </a:spcBef>
-              <a:spcAft>
-                <a:spcPts val="400"/>
-              </a:spcAft>
-              <a:defRPr sz="2000">
-                <a:solidFill>
-                  <a:srgbClr val="FFFFFF"/>
-                </a:solidFill>
-              </a:defRPr>
-            </a:pPr>
-            <a:r>
-              <a:t>5.  Click 'Grant admin consent for EY'</a:t>
-            </a:r>
-          </a:p>
-          <a:p>
-            <a:pPr>
-              <a:spcBef>
-                <a:spcPts val="1000"/>
-              </a:spcBef>
-              <a:spcAft>
-                <a:spcPts val="400"/>
-              </a:spcAft>
-              <a:defRPr sz="2000">
-                <a:solidFill>
-                  <a:srgbClr val="FFFFFF"/>
-                </a:solidFill>
-              </a:defRPr>
-            </a:pPr>
-          </a:p>
-          <a:p>
-            <a:pPr>
-              <a:spcBef>
-                <a:spcPts val="1000"/>
-              </a:spcBef>
-              <a:spcAft>
-                <a:spcPts val="400"/>
-              </a:spcAft>
-              <a:defRPr sz="2000">
-                <a:solidFill>
-                  <a:srgbClr val="FFFFFF"/>
-                </a:solidFill>
-              </a:defRPr>
-            </a:pPr>
-            <a:r>
-              <a:t>If you don't see the consent button, ask a Global Admin to do it.</a:t>
+              <a:t>From the app Overview page, copy:</a:t>
+            </a:r>
+          </a:p>
+          <a:p>
+            <a:pPr>
+              <a:spcBef>
+                <a:spcPts val="1000"/>
+              </a:spcBef>
+              <a:spcAft>
+                <a:spcPts val="400"/>
+              </a:spcAft>
+              <a:defRPr sz="2000">
+                <a:solidFill>
+                  <a:srgbClr val="FFFFFF"/>
+                </a:solidFill>
+              </a:defRPr>
+            </a:pPr>
+            <a:r>
+              <a:t>   1.  Application (client) ID  →  your client_id</a:t>
+            </a:r>
+          </a:p>
+          <a:p>
+            <a:pPr>
+              <a:spcBef>
+                <a:spcPts val="1000"/>
+              </a:spcBef>
+              <a:spcAft>
+                <a:spcPts val="400"/>
+              </a:spcAft>
+              <a:defRPr sz="2000">
+                <a:solidFill>
+                  <a:srgbClr val="FFFFFF"/>
+                </a:solidFill>
+              </a:defRPr>
+            </a:pPr>
+            <a:r>
+              <a:t>   2.  Directory (tenant) ID    →  your tenant_id</a:t>
+            </a:r>
+          </a:p>
+          <a:p>
+            <a:pPr>
+              <a:spcBef>
+                <a:spcPts val="1000"/>
+              </a:spcBef>
+              <a:spcAft>
+                <a:spcPts val="400"/>
+              </a:spcAft>
+              <a:defRPr sz="2000">
+                <a:solidFill>
+                  <a:srgbClr val="FFFFFF"/>
+                </a:solidFill>
+              </a:defRPr>
+            </a:pPr>
+          </a:p>
+          <a:p>
+            <a:pPr>
+              <a:spcBef>
+                <a:spcPts val="1000"/>
+              </a:spcBef>
+              <a:spcAft>
+                <a:spcPts val="400"/>
+              </a:spcAft>
+              <a:defRPr sz="2000">
+                <a:solidFill>
+                  <a:srgbClr val="FFFFFF"/>
+                </a:solidFill>
+              </a:defRPr>
+            </a:pPr>
+            <a:r>
+              <a:t>Then go to Certificates &amp; secrets:</a:t>
+            </a:r>
+          </a:p>
+          <a:p>
+            <a:pPr>
+              <a:spcBef>
+                <a:spcPts val="1000"/>
+              </a:spcBef>
+              <a:spcAft>
+                <a:spcPts val="400"/>
+              </a:spcAft>
+              <a:defRPr sz="2000">
+                <a:solidFill>
+                  <a:srgbClr val="FFFFFF"/>
+                </a:solidFill>
+              </a:defRPr>
+            </a:pPr>
+            <a:r>
+              <a:t>   3.  Click '+ New client secret' &gt; copy the Value  →  your client_secret</a:t>
+            </a:r>
+          </a:p>
+          <a:p>
+            <a:pPr>
+              <a:spcBef>
+                <a:spcPts val="1000"/>
+              </a:spcBef>
+              <a:spcAft>
+                <a:spcPts val="400"/>
+              </a:spcAft>
+              <a:defRPr sz="2000">
+                <a:solidFill>
+                  <a:srgbClr val="FFFFFF"/>
+                </a:solidFill>
+              </a:defRPr>
+            </a:pPr>
+          </a:p>
+          <a:p>
+            <a:pPr>
+              <a:spcBef>
+                <a:spcPts val="1000"/>
+              </a:spcBef>
+              <a:spcAft>
+                <a:spcPts val="400"/>
+              </a:spcAft>
+              <a:defRPr sz="2000">
+                <a:solidFill>
+                  <a:srgbClr val="FFFFFF"/>
+                </a:solidFill>
+              </a:defRPr>
+            </a:pPr>
+            <a:r>
+              <a:t>IMPORTANT: The secret is only shown once — copy it immediately.</a:t>
             </a:r>
           </a:p>
         </p:txBody>
@@ -4606,7 +4640,7 @@
               </a:defRPr>
             </a:pPr>
             <a:r>
-              <a:t>Step 8e: Paste Values into Streamlit Cloud</a:t>
+              <a:t>Step 8d: Add API Permissions</a:t>
             </a:r>
           </a:p>
         </p:txBody>
@@ -4647,163 +4681,112 @@
               </a:defRPr>
             </a:pPr>
             <a:r>
-              <a:t>1.  Go to share.streamlit.io &gt; your app &gt; Settings &gt; Secrets</a:t>
-            </a:r>
-          </a:p>
-          <a:p>
-            <a:pPr>
-              <a:spcBef>
-                <a:spcPts val="1000"/>
-              </a:spcBef>
-              <a:spcAft>
-                <a:spcPts val="400"/>
-              </a:spcAft>
-              <a:defRPr sz="2000">
-                <a:solidFill>
-                  <a:srgbClr val="FFFFFF"/>
-                </a:solidFill>
-              </a:defRPr>
-            </a:pPr>
-            <a:r>
-              <a:t>2.  Paste:</a:t>
-            </a:r>
-          </a:p>
-          <a:p>
-            <a:pPr>
-              <a:spcBef>
-                <a:spcPts val="1000"/>
-              </a:spcBef>
-              <a:spcAft>
-                <a:spcPts val="400"/>
-              </a:spcAft>
-              <a:defRPr sz="2000">
-                <a:solidFill>
-                  <a:srgbClr val="FFFFFF"/>
-                </a:solidFill>
-              </a:defRPr>
-            </a:pPr>
-          </a:p>
-          <a:p>
-            <a:pPr>
-              <a:spcBef>
-                <a:spcPts val="1000"/>
-              </a:spcBef>
-              <a:spcAft>
-                <a:spcPts val="400"/>
-              </a:spcAft>
-              <a:defRPr sz="2000">
-                <a:solidFill>
-                  <a:srgbClr val="FFFFFF"/>
-                </a:solidFill>
-              </a:defRPr>
-            </a:pPr>
-            <a:r>
-              <a:t>     [azure]</a:t>
-            </a:r>
-          </a:p>
-          <a:p>
-            <a:pPr>
-              <a:spcBef>
-                <a:spcPts val="1000"/>
-              </a:spcBef>
-              <a:spcAft>
-                <a:spcPts val="400"/>
-              </a:spcAft>
-              <a:defRPr sz="2000">
-                <a:solidFill>
-                  <a:srgbClr val="FFFFFF"/>
-                </a:solidFill>
-              </a:defRPr>
-            </a:pPr>
-            <a:r>
-              <a:t>     client_id = "your-client-id"</a:t>
-            </a:r>
-          </a:p>
-          <a:p>
-            <a:pPr>
-              <a:spcBef>
-                <a:spcPts val="1000"/>
-              </a:spcBef>
-              <a:spcAft>
-                <a:spcPts val="400"/>
-              </a:spcAft>
-              <a:defRPr sz="2000">
-                <a:solidFill>
-                  <a:srgbClr val="FFFFFF"/>
-                </a:solidFill>
-              </a:defRPr>
-            </a:pPr>
-            <a:r>
-              <a:t>     client_secret = "your-client-secret"</a:t>
-            </a:r>
-          </a:p>
-          <a:p>
-            <a:pPr>
-              <a:spcBef>
-                <a:spcPts val="1000"/>
-              </a:spcBef>
-              <a:spcAft>
-                <a:spcPts val="400"/>
-              </a:spcAft>
-              <a:defRPr sz="2000">
-                <a:solidFill>
-                  <a:srgbClr val="FFFFFF"/>
-                </a:solidFill>
-              </a:defRPr>
-            </a:pPr>
-            <a:r>
-              <a:t>     tenant_id = "your-tenant-id"</a:t>
-            </a:r>
-          </a:p>
-          <a:p>
-            <a:pPr>
-              <a:spcBef>
-                <a:spcPts val="1000"/>
-              </a:spcBef>
-              <a:spcAft>
-                <a:spcPts val="400"/>
-              </a:spcAft>
-              <a:defRPr sz="2000">
-                <a:solidFill>
-                  <a:srgbClr val="FFFFFF"/>
-                </a:solidFill>
-              </a:defRPr>
-            </a:pPr>
-            <a:r>
-              <a:t>     redirect_uri = "https://your-app.streamlit.app"</a:t>
-            </a:r>
-          </a:p>
-          <a:p>
-            <a:pPr>
-              <a:spcBef>
-                <a:spcPts val="1000"/>
-              </a:spcBef>
-              <a:spcAft>
-                <a:spcPts val="400"/>
-              </a:spcAft>
-              <a:defRPr sz="2000">
-                <a:solidFill>
-                  <a:srgbClr val="FFFFFF"/>
-                </a:solidFill>
-              </a:defRPr>
-            </a:pPr>
-          </a:p>
-          <a:p>
-            <a:pPr>
-              <a:spcBef>
-                <a:spcPts val="1000"/>
-              </a:spcBef>
-              <a:spcAft>
-                <a:spcPts val="400"/>
-              </a:spcAft>
-              <a:defRPr sz="2000">
-                <a:solidFill>
-                  <a:srgbClr val="FFFFFF"/>
-                </a:solidFill>
-              </a:defRPr>
-            </a:pPr>
-            <a:r>
-              <a:t>3.  Click Save &gt; Reboot app. That's it — SSO is live.</a:t>
+              <a:t>1.  Go to API permissions &gt; '+ Add a permission'</a:t>
+            </a:r>
+          </a:p>
+          <a:p>
+            <a:pPr>
+              <a:spcBef>
+                <a:spcPts val="1000"/>
+              </a:spcBef>
+              <a:spcAft>
+                <a:spcPts val="400"/>
+              </a:spcAft>
+              <a:defRPr sz="2000">
+                <a:solidFill>
+                  <a:srgbClr val="FFFFFF"/>
+                </a:solidFill>
+              </a:defRPr>
+            </a:pPr>
+            <a:r>
+              <a:t>2.  Select 'Microsoft Graph' &gt; 'Delegated permissions'</a:t>
+            </a:r>
+          </a:p>
+          <a:p>
+            <a:pPr>
+              <a:spcBef>
+                <a:spcPts val="1000"/>
+              </a:spcBef>
+              <a:spcAft>
+                <a:spcPts val="400"/>
+              </a:spcAft>
+              <a:defRPr sz="2000">
+                <a:solidFill>
+                  <a:srgbClr val="FFFFFF"/>
+                </a:solidFill>
+              </a:defRPr>
+            </a:pPr>
+            <a:r>
+              <a:t>3.  Search for 'User.Read' and check it</a:t>
+            </a:r>
+          </a:p>
+          <a:p>
+            <a:pPr>
+              <a:spcBef>
+                <a:spcPts val="1000"/>
+              </a:spcBef>
+              <a:spcAft>
+                <a:spcPts val="400"/>
+              </a:spcAft>
+              <a:defRPr sz="2000">
+                <a:solidFill>
+                  <a:srgbClr val="FFFFFF"/>
+                </a:solidFill>
+              </a:defRPr>
+            </a:pPr>
+            <a:r>
+              <a:t>4.  Click 'Add permissions'</a:t>
+            </a:r>
+          </a:p>
+          <a:p>
+            <a:pPr>
+              <a:spcBef>
+                <a:spcPts val="1000"/>
+              </a:spcBef>
+              <a:spcAft>
+                <a:spcPts val="400"/>
+              </a:spcAft>
+              <a:defRPr sz="2000">
+                <a:solidFill>
+                  <a:srgbClr val="FFFFFF"/>
+                </a:solidFill>
+              </a:defRPr>
+            </a:pPr>
+            <a:r>
+              <a:t>5.  Click 'Grant admin consent for EY'</a:t>
+            </a:r>
+          </a:p>
+          <a:p>
+            <a:pPr>
+              <a:spcBef>
+                <a:spcPts val="1000"/>
+              </a:spcBef>
+              <a:spcAft>
+                <a:spcPts val="400"/>
+              </a:spcAft>
+              <a:defRPr sz="2000">
+                <a:solidFill>
+                  <a:srgbClr val="FFFFFF"/>
+                </a:solidFill>
+              </a:defRPr>
+            </a:pPr>
+          </a:p>
+          <a:p>
+            <a:pPr>
+              <a:spcBef>
+                <a:spcPts val="1000"/>
+              </a:spcBef>
+              <a:spcAft>
+                <a:spcPts val="400"/>
+              </a:spcAft>
+              <a:defRPr sz="2000">
+                <a:solidFill>
+                  <a:srgbClr val="FFFFFF"/>
+                </a:solidFill>
+              </a:defRPr>
+            </a:pPr>
+            <a:r>
+              <a:t>If you don't see the consent button, ask a Global Admin to do it.</a:t>
             </a:r>
           </a:p>
         </p:txBody>
@@ -4907,7 +4890,7 @@
               </a:defRPr>
             </a:pPr>
             <a:r>
-              <a:t>What Changes After SSO</a:t>
+              <a:t>Step 8e: Paste Values into Streamlit Cloud</a:t>
             </a:r>
           </a:p>
         </p:txBody>
@@ -4948,112 +4931,163 @@
               </a:defRPr>
             </a:pPr>
             <a:r>
-              <a:t>BEFORE:                                    AFTER:</a:t>
-            </a:r>
-          </a:p>
-          <a:p>
-            <a:pPr>
-              <a:spcBef>
-                <a:spcPts val="1000"/>
-              </a:spcBef>
-              <a:spcAft>
-                <a:spcPts val="400"/>
-              </a:spcAft>
-              <a:defRPr sz="2000">
-                <a:solidFill>
-                  <a:srgbClr val="FFFFFF"/>
-                </a:solidFill>
-              </a:defRPr>
-            </a:pPr>
-            <a:r>
-              <a:t>  Users type email in a text box              Users click 'Sign in with Microsoft'</a:t>
-            </a:r>
-          </a:p>
-          <a:p>
-            <a:pPr>
-              <a:spcBef>
-                <a:spcPts val="1000"/>
-              </a:spcBef>
-              <a:spcAft>
-                <a:spcPts val="400"/>
-              </a:spcAft>
-              <a:defRPr sz="2000">
-                <a:solidFill>
-                  <a:srgbClr val="FFFFFF"/>
-                </a:solidFill>
-              </a:defRPr>
-            </a:pPr>
-            <a:r>
-              <a:t>  No verification at all                           Microsoft verifies their identity</a:t>
-            </a:r>
-          </a:p>
-          <a:p>
-            <a:pPr>
-              <a:spcBef>
-                <a:spcPts val="1000"/>
-              </a:spcBef>
-              <a:spcAft>
-                <a:spcPts val="400"/>
-              </a:spcAft>
-              <a:defRPr sz="2000">
-                <a:solidFill>
-                  <a:srgbClr val="FFFFFF"/>
-                </a:solidFill>
-              </a:defRPr>
-            </a:pPr>
-            <a:r>
-              <a:t>  Not safe for sensitive data                  Enterprise-grade security</a:t>
-            </a:r>
-          </a:p>
-          <a:p>
-            <a:pPr>
-              <a:spcBef>
-                <a:spcPts val="1000"/>
-              </a:spcBef>
-              <a:spcAft>
-                <a:spcPts val="400"/>
-              </a:spcAft>
-              <a:defRPr sz="2000">
-                <a:solidFill>
-                  <a:srgbClr val="FFFFFF"/>
-                </a:solidFill>
-              </a:defRPr>
-            </a:pPr>
-            <a:r>
-              <a:t>  No audit trail                                      Microsoft logs all sign-ins</a:t>
-            </a:r>
-          </a:p>
-          <a:p>
-            <a:pPr>
-              <a:spcBef>
-                <a:spcPts val="1000"/>
-              </a:spcBef>
-              <a:spcAft>
-                <a:spcPts val="400"/>
-              </a:spcAft>
-              <a:defRPr sz="2000">
-                <a:solidFill>
-                  <a:srgbClr val="FFFFFF"/>
-                </a:solidFill>
-              </a:defRPr>
-            </a:pPr>
-          </a:p>
-          <a:p>
-            <a:pPr>
-              <a:spcBef>
-                <a:spcPts val="1000"/>
-              </a:spcBef>
-              <a:spcAft>
-                <a:spcPts val="400"/>
-              </a:spcAft>
-              <a:defRPr sz="2000">
-                <a:solidFill>
-                  <a:srgbClr val="FFFFFF"/>
-                </a:solidFill>
-              </a:defRPr>
-            </a:pPr>
-            <a:r>
-              <a:t>The app switches automatically — no code changes needed.</a:t>
+              <a:t>1.  Go to share.streamlit.io &gt; your app &gt; Settings &gt; Secrets</a:t>
+            </a:r>
+          </a:p>
+          <a:p>
+            <a:pPr>
+              <a:spcBef>
+                <a:spcPts val="1000"/>
+              </a:spcBef>
+              <a:spcAft>
+                <a:spcPts val="400"/>
+              </a:spcAft>
+              <a:defRPr sz="2000">
+                <a:solidFill>
+                  <a:srgbClr val="FFFFFF"/>
+                </a:solidFill>
+              </a:defRPr>
+            </a:pPr>
+            <a:r>
+              <a:t>2.  Paste:</a:t>
+            </a:r>
+          </a:p>
+          <a:p>
+            <a:pPr>
+              <a:spcBef>
+                <a:spcPts val="1000"/>
+              </a:spcBef>
+              <a:spcAft>
+                <a:spcPts val="400"/>
+              </a:spcAft>
+              <a:defRPr sz="2000">
+                <a:solidFill>
+                  <a:srgbClr val="FFFFFF"/>
+                </a:solidFill>
+              </a:defRPr>
+            </a:pPr>
+          </a:p>
+          <a:p>
+            <a:pPr>
+              <a:spcBef>
+                <a:spcPts val="1000"/>
+              </a:spcBef>
+              <a:spcAft>
+                <a:spcPts val="400"/>
+              </a:spcAft>
+              <a:defRPr sz="2000">
+                <a:solidFill>
+                  <a:srgbClr val="FFFFFF"/>
+                </a:solidFill>
+              </a:defRPr>
+            </a:pPr>
+            <a:r>
+              <a:t>     [azure]</a:t>
+            </a:r>
+          </a:p>
+          <a:p>
+            <a:pPr>
+              <a:spcBef>
+                <a:spcPts val="1000"/>
+              </a:spcBef>
+              <a:spcAft>
+                <a:spcPts val="400"/>
+              </a:spcAft>
+              <a:defRPr sz="2000">
+                <a:solidFill>
+                  <a:srgbClr val="FFFFFF"/>
+                </a:solidFill>
+              </a:defRPr>
+            </a:pPr>
+            <a:r>
+              <a:t>     client_id = "your-client-id"</a:t>
+            </a:r>
+          </a:p>
+          <a:p>
+            <a:pPr>
+              <a:spcBef>
+                <a:spcPts val="1000"/>
+              </a:spcBef>
+              <a:spcAft>
+                <a:spcPts val="400"/>
+              </a:spcAft>
+              <a:defRPr sz="2000">
+                <a:solidFill>
+                  <a:srgbClr val="FFFFFF"/>
+                </a:solidFill>
+              </a:defRPr>
+            </a:pPr>
+            <a:r>
+              <a:t>     client_secret = "your-client-secret"</a:t>
+            </a:r>
+          </a:p>
+          <a:p>
+            <a:pPr>
+              <a:spcBef>
+                <a:spcPts val="1000"/>
+              </a:spcBef>
+              <a:spcAft>
+                <a:spcPts val="400"/>
+              </a:spcAft>
+              <a:defRPr sz="2000">
+                <a:solidFill>
+                  <a:srgbClr val="FFFFFF"/>
+                </a:solidFill>
+              </a:defRPr>
+            </a:pPr>
+            <a:r>
+              <a:t>     tenant_id = "your-tenant-id"</a:t>
+            </a:r>
+          </a:p>
+          <a:p>
+            <a:pPr>
+              <a:spcBef>
+                <a:spcPts val="1000"/>
+              </a:spcBef>
+              <a:spcAft>
+                <a:spcPts val="400"/>
+              </a:spcAft>
+              <a:defRPr sz="2000">
+                <a:solidFill>
+                  <a:srgbClr val="FFFFFF"/>
+                </a:solidFill>
+              </a:defRPr>
+            </a:pPr>
+            <a:r>
+              <a:t>     redirect_uri = "https://your-app.streamlit.app"</a:t>
+            </a:r>
+          </a:p>
+          <a:p>
+            <a:pPr>
+              <a:spcBef>
+                <a:spcPts val="1000"/>
+              </a:spcBef>
+              <a:spcAft>
+                <a:spcPts val="400"/>
+              </a:spcAft>
+              <a:defRPr sz="2000">
+                <a:solidFill>
+                  <a:srgbClr val="FFFFFF"/>
+                </a:solidFill>
+              </a:defRPr>
+            </a:pPr>
+          </a:p>
+          <a:p>
+            <a:pPr>
+              <a:spcBef>
+                <a:spcPts val="1000"/>
+              </a:spcBef>
+              <a:spcAft>
+                <a:spcPts val="400"/>
+              </a:spcAft>
+              <a:defRPr sz="2000">
+                <a:solidFill>
+                  <a:srgbClr val="FFFFFF"/>
+                </a:solidFill>
+              </a:defRPr>
+            </a:pPr>
+            <a:r>
+              <a:t>3.  Click Save &gt; Reboot app. That's it — SSO is live.</a:t>
             </a:r>
           </a:p>
         </p:txBody>
@@ -5157,7 +5191,7 @@
               </a:defRPr>
             </a:pPr>
             <a:r>
-              <a:t>Email Template for Your IT Team</a:t>
+              <a:t>What Changes After SSO</a:t>
             </a:r>
           </a:p>
         </p:txBody>
@@ -5198,148 +5232,112 @@
               </a:defRPr>
             </a:pPr>
             <a:r>
-              <a:t>"Hi, I need an Azure AD app registration for a Streamlit dashboard."</a:t>
-            </a:r>
-          </a:p>
-          <a:p>
-            <a:pPr>
-              <a:spcBef>
-                <a:spcPts val="1000"/>
-              </a:spcBef>
-              <a:spcAft>
-                <a:spcPts val="400"/>
-              </a:spcAft>
-              <a:defRPr sz="2000">
-                <a:solidFill>
-                  <a:srgbClr val="FFFFFF"/>
-                </a:solidFill>
-              </a:defRPr>
-            </a:pPr>
-          </a:p>
-          <a:p>
-            <a:pPr>
-              <a:spcBef>
-                <a:spcPts val="1000"/>
-              </a:spcBef>
-              <a:spcAft>
-                <a:spcPts val="400"/>
-              </a:spcAft>
-              <a:defRPr sz="2000">
-                <a:solidFill>
-                  <a:srgbClr val="FFFFFF"/>
-                </a:solidFill>
-              </a:defRPr>
-            </a:pPr>
-            <a:r>
-              <a:t>Ask them to:</a:t>
-            </a:r>
-          </a:p>
-          <a:p>
-            <a:pPr>
-              <a:spcBef>
-                <a:spcPts val="1000"/>
-              </a:spcBef>
-              <a:spcAft>
-                <a:spcPts val="400"/>
-              </a:spcAft>
-              <a:defRPr sz="2000">
-                <a:solidFill>
-                  <a:srgbClr val="FFFFFF"/>
-                </a:solidFill>
-              </a:defRPr>
-            </a:pPr>
-            <a:r>
-              <a:t>  1.  Register app named "Factory AI Dashboard"</a:t>
-            </a:r>
-          </a:p>
-          <a:p>
-            <a:pPr>
-              <a:spcBef>
-                <a:spcPts val="1000"/>
-              </a:spcBef>
-              <a:spcAft>
-                <a:spcPts val="400"/>
-              </a:spcAft>
-              <a:defRPr sz="2000">
-                <a:solidFill>
-                  <a:srgbClr val="FFFFFF"/>
-                </a:solidFill>
-              </a:defRPr>
-            </a:pPr>
-            <a:r>
-              <a:t>  2.  Set to EY tenant only</a:t>
-            </a:r>
-          </a:p>
-          <a:p>
-            <a:pPr>
-              <a:spcBef>
-                <a:spcPts val="1000"/>
-              </a:spcBef>
-              <a:spcAft>
-                <a:spcPts val="400"/>
-              </a:spcAft>
-              <a:defRPr sz="2000">
-                <a:solidFill>
-                  <a:srgbClr val="FFFFFF"/>
-                </a:solidFill>
-              </a:defRPr>
-            </a:pPr>
-            <a:r>
-              <a:t>  3.  Add Web redirect URI: [your Streamlit URL]</a:t>
-            </a:r>
-          </a:p>
-          <a:p>
-            <a:pPr>
-              <a:spcBef>
-                <a:spcPts val="1000"/>
-              </a:spcBef>
-              <a:spcAft>
-                <a:spcPts val="400"/>
-              </a:spcAft>
-              <a:defRPr sz="2000">
-                <a:solidFill>
-                  <a:srgbClr val="FFFFFF"/>
-                </a:solidFill>
-              </a:defRPr>
-            </a:pPr>
-            <a:r>
-              <a:t>  4.  Create a client secret</a:t>
-            </a:r>
-          </a:p>
-          <a:p>
-            <a:pPr>
-              <a:spcBef>
-                <a:spcPts val="1000"/>
-              </a:spcBef>
-              <a:spcAft>
-                <a:spcPts val="400"/>
-              </a:spcAft>
-              <a:defRPr sz="2000">
-                <a:solidFill>
-                  <a:srgbClr val="FFFFFF"/>
-                </a:solidFill>
-              </a:defRPr>
-            </a:pPr>
-            <a:r>
-              <a:t>  5.  Add User.Read permission + grant admin consent</a:t>
-            </a:r>
-          </a:p>
-          <a:p>
-            <a:pPr>
-              <a:spcBef>
-                <a:spcPts val="1000"/>
-              </a:spcBef>
-              <a:spcAft>
-                <a:spcPts val="400"/>
-              </a:spcAft>
-              <a:defRPr sz="2000">
-                <a:solidFill>
-                  <a:srgbClr val="FFFFFF"/>
-                </a:solidFill>
-              </a:defRPr>
-            </a:pPr>
-            <a:r>
-              <a:t>  6.  Send you the client_id, tenant_id, and client_secret</a:t>
+              <a:t>BEFORE:                                    AFTER:</a:t>
+            </a:r>
+          </a:p>
+          <a:p>
+            <a:pPr>
+              <a:spcBef>
+                <a:spcPts val="1000"/>
+              </a:spcBef>
+              <a:spcAft>
+                <a:spcPts val="400"/>
+              </a:spcAft>
+              <a:defRPr sz="2000">
+                <a:solidFill>
+                  <a:srgbClr val="FFFFFF"/>
+                </a:solidFill>
+              </a:defRPr>
+            </a:pPr>
+            <a:r>
+              <a:t>  Users type email in a text box              Users click 'Sign in with Microsoft'</a:t>
+            </a:r>
+          </a:p>
+          <a:p>
+            <a:pPr>
+              <a:spcBef>
+                <a:spcPts val="1000"/>
+              </a:spcBef>
+              <a:spcAft>
+                <a:spcPts val="400"/>
+              </a:spcAft>
+              <a:defRPr sz="2000">
+                <a:solidFill>
+                  <a:srgbClr val="FFFFFF"/>
+                </a:solidFill>
+              </a:defRPr>
+            </a:pPr>
+            <a:r>
+              <a:t>  No verification at all                           Microsoft verifies their identity</a:t>
+            </a:r>
+          </a:p>
+          <a:p>
+            <a:pPr>
+              <a:spcBef>
+                <a:spcPts val="1000"/>
+              </a:spcBef>
+              <a:spcAft>
+                <a:spcPts val="400"/>
+              </a:spcAft>
+              <a:defRPr sz="2000">
+                <a:solidFill>
+                  <a:srgbClr val="FFFFFF"/>
+                </a:solidFill>
+              </a:defRPr>
+            </a:pPr>
+            <a:r>
+              <a:t>  Not safe for sensitive data                  Enterprise-grade security</a:t>
+            </a:r>
+          </a:p>
+          <a:p>
+            <a:pPr>
+              <a:spcBef>
+                <a:spcPts val="1000"/>
+              </a:spcBef>
+              <a:spcAft>
+                <a:spcPts val="400"/>
+              </a:spcAft>
+              <a:defRPr sz="2000">
+                <a:solidFill>
+                  <a:srgbClr val="FFFFFF"/>
+                </a:solidFill>
+              </a:defRPr>
+            </a:pPr>
+            <a:r>
+              <a:t>  No audit trail                                      Microsoft logs all sign-ins</a:t>
+            </a:r>
+          </a:p>
+          <a:p>
+            <a:pPr>
+              <a:spcBef>
+                <a:spcPts val="1000"/>
+              </a:spcBef>
+              <a:spcAft>
+                <a:spcPts val="400"/>
+              </a:spcAft>
+              <a:defRPr sz="2000">
+                <a:solidFill>
+                  <a:srgbClr val="FFFFFF"/>
+                </a:solidFill>
+              </a:defRPr>
+            </a:pPr>
+          </a:p>
+          <a:p>
+            <a:pPr>
+              <a:spcBef>
+                <a:spcPts val="1000"/>
+              </a:spcBef>
+              <a:spcAft>
+                <a:spcPts val="400"/>
+              </a:spcAft>
+              <a:defRPr sz="2000">
+                <a:solidFill>
+                  <a:srgbClr val="FFFFFF"/>
+                </a:solidFill>
+              </a:defRPr>
+            </a:pPr>
+            <a:r>
+              <a:t>The app switches automatically — no code changes needed.</a:t>
             </a:r>
           </a:p>
         </p:txBody>
@@ -5443,7 +5441,7 @@
               </a:defRPr>
             </a:pPr>
             <a:r>
-              <a:t>Troubleshooting</a:t>
+              <a:t>Reminder: Follow Up with IT</a:t>
             </a:r>
           </a:p>
         </p:txBody>
@@ -5484,97 +5482,163 @@
               </a:defRPr>
             </a:pPr>
             <a:r>
-              <a:t>ModuleNotFoundError  →  "Add [package] to requirements.txt and push"</a:t>
-            </a:r>
-          </a:p>
-          <a:p>
-            <a:pPr>
-              <a:spcBef>
-                <a:spcPts val="1000"/>
-              </a:spcBef>
-              <a:spcAft>
-                <a:spcPts val="400"/>
-              </a:spcAft>
-              <a:defRPr sz="2000">
-                <a:solidFill>
-                  <a:srgbClr val="FFFFFF"/>
-                </a:solidFill>
-              </a:defRPr>
-            </a:pPr>
-            <a:r>
-              <a:t>Excel file not found  →  "Copy Excel into data folder and push"</a:t>
-            </a:r>
-          </a:p>
-          <a:p>
-            <a:pPr>
-              <a:spcBef>
-                <a:spcPts val="1000"/>
-              </a:spcBef>
-              <a:spcAft>
-                <a:spcPts val="400"/>
-              </a:spcAft>
-              <a:defRPr sz="2000">
-                <a:solidFill>
-                  <a:srgbClr val="FFFFFF"/>
-                </a:solidFill>
-              </a:defRPr>
-            </a:pPr>
-            <a:r>
-              <a:t>Dashboard broken  →  Paste error, say "fix this", then push</a:t>
-            </a:r>
-          </a:p>
-          <a:p>
-            <a:pPr>
-              <a:spcBef>
-                <a:spcPts val="1000"/>
-              </a:spcBef>
-              <a:spcAft>
-                <a:spcPts val="400"/>
-              </a:spcAft>
-              <a:defRPr sz="2000">
-                <a:solidFill>
-                  <a:srgbClr val="FFFFFF"/>
-                </a:solidFill>
-              </a:defRPr>
-            </a:pPr>
-            <a:r>
-              <a:t>Wrong data  →  Check Excel for blank rows or text in number columns</a:t>
-            </a:r>
-          </a:p>
-          <a:p>
-            <a:pPr>
-              <a:spcBef>
-                <a:spcPts val="1000"/>
-              </a:spcBef>
-              <a:spcAft>
-                <a:spcPts val="400"/>
-              </a:spcAft>
-              <a:defRPr sz="2000">
-                <a:solidFill>
-                  <a:srgbClr val="FFFFFF"/>
-                </a:solidFill>
-              </a:defRPr>
-            </a:pPr>
-            <a:r>
-              <a:t>SSO redirect error  →  Verify redirect URI matches exactly in Azure</a:t>
-            </a:r>
-          </a:p>
-          <a:p>
-            <a:pPr>
-              <a:spcBef>
-                <a:spcPts val="1000"/>
-              </a:spcBef>
-              <a:spcAft>
-                <a:spcPts val="400"/>
-              </a:spcAft>
-              <a:defRPr sz="2000">
-                <a:solidFill>
-                  <a:srgbClr val="FFFFFF"/>
-                </a:solidFill>
-              </a:defRPr>
-            </a:pPr>
-            <a:r>
-              <a:t>SSO auth failed  →  Client secret may have expired; create a new one</a:t>
+              <a:t>If your IT team has not yet responded to the email</a:t>
+            </a:r>
+          </a:p>
+          <a:p>
+            <a:pPr>
+              <a:spcBef>
+                <a:spcPts val="1000"/>
+              </a:spcBef>
+              <a:spcAft>
+                <a:spcPts val="400"/>
+              </a:spcAft>
+              <a:defRPr sz="2000">
+                <a:solidFill>
+                  <a:srgbClr val="FFFFFF"/>
+                </a:solidFill>
+              </a:defRPr>
+            </a:pPr>
+            <a:r>
+              <a:t>you sent at the beginning of this guide:</a:t>
+            </a:r>
+          </a:p>
+          <a:p>
+            <a:pPr>
+              <a:spcBef>
+                <a:spcPts val="1000"/>
+              </a:spcBef>
+              <a:spcAft>
+                <a:spcPts val="400"/>
+              </a:spcAft>
+              <a:defRPr sz="2000">
+                <a:solidFill>
+                  <a:srgbClr val="FFFFFF"/>
+                </a:solidFill>
+              </a:defRPr>
+            </a:pPr>
+          </a:p>
+          <a:p>
+            <a:pPr>
+              <a:spcBef>
+                <a:spcPts val="1000"/>
+              </a:spcBef>
+              <a:spcAft>
+                <a:spcPts val="400"/>
+              </a:spcAft>
+              <a:defRPr sz="2000">
+                <a:solidFill>
+                  <a:srgbClr val="FFFFFF"/>
+                </a:solidFill>
+              </a:defRPr>
+            </a:pPr>
+            <a:r>
+              <a:t>  1.  Follow up and provide your Streamlit Cloud URL</a:t>
+            </a:r>
+          </a:p>
+          <a:p>
+            <a:pPr>
+              <a:spcBef>
+                <a:spcPts val="1000"/>
+              </a:spcBef>
+              <a:spcAft>
+                <a:spcPts val="400"/>
+              </a:spcAft>
+              <a:defRPr sz="2000">
+                <a:solidFill>
+                  <a:srgbClr val="FFFFFF"/>
+                </a:solidFill>
+              </a:defRPr>
+            </a:pPr>
+            <a:r>
+              <a:t>       (from Step 5) as the redirect URI</a:t>
+            </a:r>
+          </a:p>
+          <a:p>
+            <a:pPr>
+              <a:spcBef>
+                <a:spcPts val="1000"/>
+              </a:spcBef>
+              <a:spcAft>
+                <a:spcPts val="400"/>
+              </a:spcAft>
+              <a:defRPr sz="2000">
+                <a:solidFill>
+                  <a:srgbClr val="FFFFFF"/>
+                </a:solidFill>
+              </a:defRPr>
+            </a:pPr>
+            <a:r>
+              <a:t>  2.  Share the AZURE_SSO_SETUP.md file from your</a:t>
+            </a:r>
+          </a:p>
+          <a:p>
+            <a:pPr>
+              <a:spcBef>
+                <a:spcPts val="1000"/>
+              </a:spcBef>
+              <a:spcAft>
+                <a:spcPts val="400"/>
+              </a:spcAft>
+              <a:defRPr sz="2000">
+                <a:solidFill>
+                  <a:srgbClr val="FFFFFF"/>
+                </a:solidFill>
+              </a:defRPr>
+            </a:pPr>
+            <a:r>
+              <a:t>       GitHub repository for full technical details</a:t>
+            </a:r>
+          </a:p>
+          <a:p>
+            <a:pPr>
+              <a:spcBef>
+                <a:spcPts val="1000"/>
+              </a:spcBef>
+              <a:spcAft>
+                <a:spcPts val="400"/>
+              </a:spcAft>
+              <a:defRPr sz="2000">
+                <a:solidFill>
+                  <a:srgbClr val="FFFFFF"/>
+                </a:solidFill>
+              </a:defRPr>
+            </a:pPr>
+          </a:p>
+          <a:p>
+            <a:pPr>
+              <a:spcBef>
+                <a:spcPts val="1000"/>
+              </a:spcBef>
+              <a:spcAft>
+                <a:spcPts val="400"/>
+              </a:spcAft>
+              <a:defRPr sz="2000">
+                <a:solidFill>
+                  <a:srgbClr val="FFFFFF"/>
+                </a:solidFill>
+              </a:defRPr>
+            </a:pPr>
+            <a:r>
+              <a:t>Once you have the 3 values, paste them into Streamlit</a:t>
+            </a:r>
+          </a:p>
+          <a:p>
+            <a:pPr>
+              <a:spcBef>
+                <a:spcPts val="1000"/>
+              </a:spcBef>
+              <a:spcAft>
+                <a:spcPts val="400"/>
+              </a:spcAft>
+              <a:defRPr sz="2000">
+                <a:solidFill>
+                  <a:srgbClr val="FFFFFF"/>
+                </a:solidFill>
+              </a:defRPr>
+            </a:pPr>
+            <a:r>
+              <a:t>Cloud Secrets (Step 8e) and SSO goes live instantly.</a:t>
             </a:r>
           </a:p>
         </p:txBody>
@@ -5678,7 +5742,7 @@
               </a:defRPr>
             </a:pPr>
             <a:r>
-              <a:t>Quick Reference: What to Tell Factory.AI</a:t>
+              <a:t>Troubleshooting</a:t>
             </a:r>
           </a:p>
         </p:txBody>
@@ -5719,79 +5783,97 @@
               </a:defRPr>
             </a:pPr>
             <a:r>
-              <a:t>Build a dashboard     →  "Create a Streamlit dashboard using [file]"</a:t>
-            </a:r>
-          </a:p>
-          <a:p>
-            <a:pPr>
-              <a:spcBef>
-                <a:spcPts val="1000"/>
-              </a:spcBef>
-              <a:spcAft>
-                <a:spcPts val="400"/>
-              </a:spcAft>
-              <a:defRPr sz="2000">
-                <a:solidFill>
-                  <a:srgbClr val="FFFFFF"/>
-                </a:solidFill>
-              </a:defRPr>
-            </a:pPr>
-            <a:r>
-              <a:t>Change a chart          →  "Change the bar chart to a line chart"</a:t>
-            </a:r>
-          </a:p>
-          <a:p>
-            <a:pPr>
-              <a:spcBef>
-                <a:spcPts val="1000"/>
-              </a:spcBef>
-              <a:spcAft>
-                <a:spcPts val="400"/>
-              </a:spcAft>
-              <a:defRPr sz="2000">
-                <a:solidFill>
-                  <a:srgbClr val="FFFFFF"/>
-                </a:solidFill>
-              </a:defRPr>
-            </a:pPr>
-            <a:r>
-              <a:t>Add a filter                 →  "Add a filter for [column name]"</a:t>
-            </a:r>
-          </a:p>
-          <a:p>
-            <a:pPr>
-              <a:spcBef>
-                <a:spcPts val="1000"/>
-              </a:spcBef>
-              <a:spcAft>
-                <a:spcPts val="400"/>
-              </a:spcAft>
-              <a:defRPr sz="2000">
-                <a:solidFill>
-                  <a:srgbClr val="FFFFFF"/>
-                </a:solidFill>
-              </a:defRPr>
-            </a:pPr>
-            <a:r>
-              <a:t>Fix an error                →  Paste the error, say "fix this"</a:t>
-            </a:r>
-          </a:p>
-          <a:p>
-            <a:pPr>
-              <a:spcBef>
-                <a:spcPts val="1000"/>
-              </a:spcBef>
-              <a:spcAft>
-                <a:spcPts val="400"/>
-              </a:spcAft>
-              <a:defRPr sz="2000">
-                <a:solidFill>
-                  <a:srgbClr val="FFFFFF"/>
-                </a:solidFill>
-              </a:defRPr>
-            </a:pPr>
-            <a:r>
-              <a:t>Push to GitHub          →  "Push the changes to GitHub"</a:t>
+              <a:t>ModuleNotFoundError  →  "Add [package] to requirements.txt and push"</a:t>
+            </a:r>
+          </a:p>
+          <a:p>
+            <a:pPr>
+              <a:spcBef>
+                <a:spcPts val="1000"/>
+              </a:spcBef>
+              <a:spcAft>
+                <a:spcPts val="400"/>
+              </a:spcAft>
+              <a:defRPr sz="2000">
+                <a:solidFill>
+                  <a:srgbClr val="FFFFFF"/>
+                </a:solidFill>
+              </a:defRPr>
+            </a:pPr>
+            <a:r>
+              <a:t>Excel file not found  →  "Copy Excel into data folder and push"</a:t>
+            </a:r>
+          </a:p>
+          <a:p>
+            <a:pPr>
+              <a:spcBef>
+                <a:spcPts val="1000"/>
+              </a:spcBef>
+              <a:spcAft>
+                <a:spcPts val="400"/>
+              </a:spcAft>
+              <a:defRPr sz="2000">
+                <a:solidFill>
+                  <a:srgbClr val="FFFFFF"/>
+                </a:solidFill>
+              </a:defRPr>
+            </a:pPr>
+            <a:r>
+              <a:t>Dashboard broken  →  Paste error, say "fix this", then push</a:t>
+            </a:r>
+          </a:p>
+          <a:p>
+            <a:pPr>
+              <a:spcBef>
+                <a:spcPts val="1000"/>
+              </a:spcBef>
+              <a:spcAft>
+                <a:spcPts val="400"/>
+              </a:spcAft>
+              <a:defRPr sz="2000">
+                <a:solidFill>
+                  <a:srgbClr val="FFFFFF"/>
+                </a:solidFill>
+              </a:defRPr>
+            </a:pPr>
+            <a:r>
+              <a:t>Wrong data  →  Check Excel for blank rows or text in number columns</a:t>
+            </a:r>
+          </a:p>
+          <a:p>
+            <a:pPr>
+              <a:spcBef>
+                <a:spcPts val="1000"/>
+              </a:spcBef>
+              <a:spcAft>
+                <a:spcPts val="400"/>
+              </a:spcAft>
+              <a:defRPr sz="2000">
+                <a:solidFill>
+                  <a:srgbClr val="FFFFFF"/>
+                </a:solidFill>
+              </a:defRPr>
+            </a:pPr>
+            <a:r>
+              <a:t>SSO redirect error  →  Verify redirect URI matches exactly in Azure</a:t>
+            </a:r>
+          </a:p>
+          <a:p>
+            <a:pPr>
+              <a:spcBef>
+                <a:spcPts val="1000"/>
+              </a:spcBef>
+              <a:spcAft>
+                <a:spcPts val="400"/>
+              </a:spcAft>
+              <a:defRPr sz="2000">
+                <a:solidFill>
+                  <a:srgbClr val="FFFFFF"/>
+                </a:solidFill>
+              </a:defRPr>
+            </a:pPr>
+            <a:r>
+              <a:t>SSO auth failed  →  Client secret may have expired; create a new one</a:t>
             </a:r>
           </a:p>
         </p:txBody>
@@ -6007,23 +6089,41 @@
                 </a:solidFill>
               </a:defRPr>
             </a:pPr>
-          </a:p>
-          <a:p>
-            <a:pPr>
-              <a:spcBef>
-                <a:spcPts val="1000"/>
-              </a:spcBef>
-              <a:spcAft>
-                <a:spcPts val="400"/>
-              </a:spcAft>
-              <a:defRPr sz="2000">
-                <a:solidFill>
-                  <a:srgbClr val="FFFFFF"/>
-                </a:solidFill>
-              </a:defRPr>
-            </a:pPr>
-            <a:r>
-              <a:t>Time: ~20 minutes  |  Technical experience: None</a:t>
+            <a:r>
+              <a:t>Secured with Microsoft SSO — real EY account sign-in</a:t>
+            </a:r>
+          </a:p>
+          <a:p>
+            <a:pPr>
+              <a:spcBef>
+                <a:spcPts val="1000"/>
+              </a:spcBef>
+              <a:spcAft>
+                <a:spcPts val="400"/>
+              </a:spcAft>
+              <a:defRPr sz="2000">
+                <a:solidFill>
+                  <a:srgbClr val="FFFFFF"/>
+                </a:solidFill>
+              </a:defRPr>
+            </a:pPr>
+          </a:p>
+          <a:p>
+            <a:pPr>
+              <a:spcBef>
+                <a:spcPts val="1000"/>
+              </a:spcBef>
+              <a:spcAft>
+                <a:spcPts val="400"/>
+              </a:spcAft>
+              <a:defRPr sz="2000">
+                <a:solidFill>
+                  <a:srgbClr val="FFFFFF"/>
+                </a:solidFill>
+              </a:defRPr>
+            </a:pPr>
+            <a:r>
+              <a:t>Time: ~30 minutes (including SSO)  |  Technical experience: None</a:t>
             </a:r>
           </a:p>
         </p:txBody>
@@ -6105,8 +6205,8 @@
         </p:nvSpPr>
         <p:spPr>
           <a:xfrm>
-            <a:off x="914400" y="2011680"/>
-            <a:ext cx="10362895" cy="1828800"/>
+            <a:off x="731520" y="320040"/>
+            <a:ext cx="10728655" cy="822960"/>
           </a:xfrm>
           <a:prstGeom prst="rect">
             <a:avLst/>
@@ -6119,30 +6219,128 @@
           </a:bodyPr>
           <a:lstStyle/>
           <a:p>
-            <a:pPr algn="ctr">
-              <a:defRPr sz="4000" b="1">
-                <a:solidFill>
-                  <a:srgbClr val="FFFFFF"/>
-                </a:solidFill>
-              </a:defRPr>
-            </a:pPr>
-            <a:r>
-              <a:t>Start Building Today</a:t>
-            </a:r>
-          </a:p>
-          <a:p>
-            <a:pPr algn="ctr">
-              <a:spcBef>
-                <a:spcPts val="1600"/>
-              </a:spcBef>
-              <a:defRPr sz="2200">
+            <a:pPr>
+              <a:defRPr sz="3000" b="1">
                 <a:solidFill>
                   <a:srgbClr val="FFE600"/>
                 </a:solidFill>
               </a:defRPr>
             </a:pPr>
             <a:r>
-              <a:t>factory.ai</a:t>
+              <a:t>Quick Reference: What to Tell Factory.AI</a:t>
+            </a:r>
+          </a:p>
+        </p:txBody>
+      </p:sp>
+      <p:sp>
+        <p:nvSpPr>
+          <p:cNvPr id="4" name="TextBox 3"/>
+          <p:cNvSpPr txBox="1"/>
+          <p:nvPr/>
+        </p:nvSpPr>
+        <p:spPr>
+          <a:xfrm>
+            <a:off x="914400" y="1371600"/>
+            <a:ext cx="10362895" cy="5029200"/>
+          </a:xfrm>
+          <a:prstGeom prst="rect">
+            <a:avLst/>
+          </a:prstGeom>
+          <a:noFill/>
+        </p:spPr>
+        <p:txBody>
+          <a:bodyPr wrap="square">
+            <a:spAutoFit/>
+          </a:bodyPr>
+          <a:lstStyle/>
+          <a:p>
+            <a:pPr>
+              <a:spcBef>
+                <a:spcPts val="1000"/>
+              </a:spcBef>
+              <a:spcAft>
+                <a:spcPts val="400"/>
+              </a:spcAft>
+              <a:defRPr sz="2000">
+                <a:solidFill>
+                  <a:srgbClr val="FFFFFF"/>
+                </a:solidFill>
+              </a:defRPr>
+            </a:pPr>
+            <a:r>
+              <a:t>Build a dashboard     →  "Create a Streamlit dashboard using [file]"</a:t>
+            </a:r>
+          </a:p>
+          <a:p>
+            <a:pPr>
+              <a:spcBef>
+                <a:spcPts val="1000"/>
+              </a:spcBef>
+              <a:spcAft>
+                <a:spcPts val="400"/>
+              </a:spcAft>
+              <a:defRPr sz="2000">
+                <a:solidFill>
+                  <a:srgbClr val="FFFFFF"/>
+                </a:solidFill>
+              </a:defRPr>
+            </a:pPr>
+            <a:r>
+              <a:t>Change a chart          →  "Change the bar chart to a line chart"</a:t>
+            </a:r>
+          </a:p>
+          <a:p>
+            <a:pPr>
+              <a:spcBef>
+                <a:spcPts val="1000"/>
+              </a:spcBef>
+              <a:spcAft>
+                <a:spcPts val="400"/>
+              </a:spcAft>
+              <a:defRPr sz="2000">
+                <a:solidFill>
+                  <a:srgbClr val="FFFFFF"/>
+                </a:solidFill>
+              </a:defRPr>
+            </a:pPr>
+            <a:r>
+              <a:t>Add a filter                 →  "Add a filter for [column name]"</a:t>
+            </a:r>
+          </a:p>
+          <a:p>
+            <a:pPr>
+              <a:spcBef>
+                <a:spcPts val="1000"/>
+              </a:spcBef>
+              <a:spcAft>
+                <a:spcPts val="400"/>
+              </a:spcAft>
+              <a:defRPr sz="2000">
+                <a:solidFill>
+                  <a:srgbClr val="FFFFFF"/>
+                </a:solidFill>
+              </a:defRPr>
+            </a:pPr>
+            <a:r>
+              <a:t>Fix an error                →  Paste the error, say "fix this"</a:t>
+            </a:r>
+          </a:p>
+          <a:p>
+            <a:pPr>
+              <a:spcBef>
+                <a:spcPts val="1000"/>
+              </a:spcBef>
+              <a:spcAft>
+                <a:spcPts val="400"/>
+              </a:spcAft>
+              <a:defRPr sz="2000">
+                <a:solidFill>
+                  <a:srgbClr val="FFFFFF"/>
+                </a:solidFill>
+              </a:defRPr>
+            </a:pPr>
+            <a:r>
+              <a:t>Push to GitHub          →  "Push the changes to GitHub"</a:t>
             </a:r>
           </a:p>
         </p:txBody>
@@ -6155,7 +6353,7 @@
 </p:sld>
 </file>
 
-<file path=ppt/slides/slide3.xml><?xml version="1.0" encoding="utf-8"?>
+<file path=ppt/slides/slide21.xml><?xml version="1.0" encoding="utf-8"?>
 <p:sld xmlns:a="http://schemas.openxmlformats.org/drawingml/2006/main" xmlns:p="http://schemas.openxmlformats.org/presentationml/2006/main" xmlns:r="http://schemas.openxmlformats.org/officeDocument/2006/relationships">
   <p:cSld>
     <p:bg>
@@ -6224,8 +6422,8 @@
         </p:nvSpPr>
         <p:spPr>
           <a:xfrm>
-            <a:off x="731520" y="320040"/>
-            <a:ext cx="10728655" cy="822960"/>
+            <a:off x="914400" y="2011680"/>
+            <a:ext cx="10362895" cy="1828800"/>
           </a:xfrm>
           <a:prstGeom prst="rect">
             <a:avLst/>
@@ -6238,110 +6436,30 @@
           </a:bodyPr>
           <a:lstStyle/>
           <a:p>
-            <a:pPr>
-              <a:defRPr sz="3000" b="1">
+            <a:pPr algn="ctr">
+              <a:defRPr sz="4000" b="1">
+                <a:solidFill>
+                  <a:srgbClr val="FFFFFF"/>
+                </a:solidFill>
+              </a:defRPr>
+            </a:pPr>
+            <a:r>
+              <a:t>Start Building Today</a:t>
+            </a:r>
+          </a:p>
+          <a:p>
+            <a:pPr algn="ctr">
+              <a:spcBef>
+                <a:spcPts val="1600"/>
+              </a:spcBef>
+              <a:defRPr sz="2200">
                 <a:solidFill>
                   <a:srgbClr val="FFE600"/>
                 </a:solidFill>
               </a:defRPr>
             </a:pPr>
             <a:r>
-              <a:t>What You Need Before Starting</a:t>
-            </a:r>
-          </a:p>
-        </p:txBody>
-      </p:sp>
-      <p:sp>
-        <p:nvSpPr>
-          <p:cNvPr id="4" name="TextBox 3"/>
-          <p:cNvSpPr txBox="1"/>
-          <p:nvPr/>
-        </p:nvSpPr>
-        <p:spPr>
-          <a:xfrm>
-            <a:off x="914400" y="1371600"/>
-            <a:ext cx="10362895" cy="5029200"/>
-          </a:xfrm>
-          <a:prstGeom prst="rect">
-            <a:avLst/>
-          </a:prstGeom>
-          <a:noFill/>
-        </p:spPr>
-        <p:txBody>
-          <a:bodyPr wrap="square">
-            <a:spAutoFit/>
-          </a:bodyPr>
-          <a:lstStyle/>
-          <a:p>
-            <a:pPr>
-              <a:spcBef>
-                <a:spcPts val="1000"/>
-              </a:spcBef>
-              <a:spcAft>
-                <a:spcPts val="400"/>
-              </a:spcAft>
-              <a:defRPr sz="2000">
-                <a:solidFill>
-                  <a:srgbClr val="FFFFFF"/>
-                </a:solidFill>
-              </a:defRPr>
-            </a:pPr>
-            <a:r>
-              <a:t>1.  Factory.AI CLI (Droid) — pre-installed or visit factory.ai</a:t>
-            </a:r>
-          </a:p>
-          <a:p>
-            <a:pPr>
-              <a:spcBef>
-                <a:spcPts val="1000"/>
-              </a:spcBef>
-              <a:spcAft>
-                <a:spcPts val="400"/>
-              </a:spcAft>
-              <a:defRPr sz="2000">
-                <a:solidFill>
-                  <a:srgbClr val="FFFFFF"/>
-                </a:solidFill>
-              </a:defRPr>
-            </a:pPr>
-            <a:r>
-              <a:t>2.  A GitHub account — github.com (free)</a:t>
-            </a:r>
-          </a:p>
-          <a:p>
-            <a:pPr>
-              <a:spcBef>
-                <a:spcPts val="1000"/>
-              </a:spcBef>
-              <a:spcAft>
-                <a:spcPts val="400"/>
-              </a:spcAft>
-              <a:defRPr sz="2000">
-                <a:solidFill>
-                  <a:srgbClr val="FFFFFF"/>
-                </a:solidFill>
-              </a:defRPr>
-            </a:pPr>
-            <a:r>
-              <a:t>3.  A Streamlit Cloud account — streamlit.io/cloud (free)</a:t>
-            </a:r>
-          </a:p>
-          <a:p>
-            <a:pPr>
-              <a:spcBef>
-                <a:spcPts val="1000"/>
-              </a:spcBef>
-              <a:spcAft>
-                <a:spcPts val="400"/>
-              </a:spcAft>
-              <a:defRPr sz="2000">
-                <a:solidFill>
-                  <a:srgbClr val="FFFFFF"/>
-                </a:solidFill>
-              </a:defRPr>
-            </a:pPr>
-            <a:r>
-              <a:t>4.  Your data in an Excel file (.xlsx)</a:t>
+              <a:t>factory.ai</a:t>
             </a:r>
           </a:p>
         </p:txBody>
@@ -6354,7 +6472,7 @@
 </p:sld>
 </file>
 
-<file path=ppt/slides/slide4.xml><?xml version="1.0" encoding="utf-8"?>
+<file path=ppt/slides/slide3.xml><?xml version="1.0" encoding="utf-8"?>
 <p:sld xmlns:a="http://schemas.openxmlformats.org/drawingml/2006/main" xmlns:p="http://schemas.openxmlformats.org/presentationml/2006/main" xmlns:r="http://schemas.openxmlformats.org/officeDocument/2006/relationships">
   <p:cSld>
     <p:bg>
@@ -6445,7 +6563,7 @@
               </a:defRPr>
             </a:pPr>
             <a:r>
-              <a:t>Step 1: Open Factory.AI</a:t>
+              <a:t>What You Need Before Starting</a:t>
             </a:r>
           </a:p>
         </p:txBody>
@@ -6486,91 +6604,79 @@
               </a:defRPr>
             </a:pPr>
             <a:r>
-              <a:t>Open your terminal (Mac: search "Terminal" in Spotlight)</a:t>
-            </a:r>
-          </a:p>
-          <a:p>
-            <a:pPr>
-              <a:spcBef>
-                <a:spcPts val="1000"/>
-              </a:spcBef>
-              <a:spcAft>
-                <a:spcPts val="400"/>
-              </a:spcAft>
-              <a:defRPr sz="2000">
-                <a:solidFill>
-                  <a:srgbClr val="FFFFFF"/>
-                </a:solidFill>
-              </a:defRPr>
-            </a:pPr>
-          </a:p>
-          <a:p>
-            <a:pPr>
-              <a:spcBef>
-                <a:spcPts val="1000"/>
-              </a:spcBef>
-              <a:spcAft>
-                <a:spcPts val="400"/>
-              </a:spcAft>
-              <a:defRPr sz="2000">
-                <a:solidFill>
-                  <a:srgbClr val="FFFFFF"/>
-                </a:solidFill>
-              </a:defRPr>
-            </a:pPr>
-            <a:r>
-              <a:t>Type:  droid</a:t>
-            </a:r>
-          </a:p>
-          <a:p>
-            <a:pPr>
-              <a:spcBef>
-                <a:spcPts val="1000"/>
-              </a:spcBef>
-              <a:spcAft>
-                <a:spcPts val="400"/>
-              </a:spcAft>
-              <a:defRPr sz="2000">
-                <a:solidFill>
-                  <a:srgbClr val="FFFFFF"/>
-                </a:solidFill>
-              </a:defRPr>
-            </a:pPr>
-          </a:p>
-          <a:p>
-            <a:pPr>
-              <a:spcBef>
-                <a:spcPts val="1000"/>
-              </a:spcBef>
-              <a:spcAft>
-                <a:spcPts val="400"/>
-              </a:spcAft>
-              <a:defRPr sz="2000">
-                <a:solidFill>
-                  <a:srgbClr val="FFFFFF"/>
-                </a:solidFill>
-              </a:defRPr>
-            </a:pPr>
-            <a:r>
-              <a:t>The Factory.AI prompt will appear.</a:t>
-            </a:r>
-          </a:p>
-          <a:p>
-            <a:pPr>
-              <a:spcBef>
-                <a:spcPts val="1000"/>
-              </a:spcBef>
-              <a:spcAft>
-                <a:spcPts val="400"/>
-              </a:spcAft>
-              <a:defRPr sz="2000">
-                <a:solidFill>
-                  <a:srgbClr val="FFFFFF"/>
-                </a:solidFill>
-              </a:defRPr>
-            </a:pPr>
-            <a:r>
-              <a:t>You give instructions in plain English — it writes the code.</a:t>
+              <a:t>1.  Factory.AI CLI (Droid) — pre-installed or visit factory.ai</a:t>
+            </a:r>
+          </a:p>
+          <a:p>
+            <a:pPr>
+              <a:spcBef>
+                <a:spcPts val="1000"/>
+              </a:spcBef>
+              <a:spcAft>
+                <a:spcPts val="400"/>
+              </a:spcAft>
+              <a:defRPr sz="2000">
+                <a:solidFill>
+                  <a:srgbClr val="FFFFFF"/>
+                </a:solidFill>
+              </a:defRPr>
+            </a:pPr>
+            <a:r>
+              <a:t>2.  A GitHub account — github.com (free)</a:t>
+            </a:r>
+          </a:p>
+          <a:p>
+            <a:pPr>
+              <a:spcBef>
+                <a:spcPts val="1000"/>
+              </a:spcBef>
+              <a:spcAft>
+                <a:spcPts val="400"/>
+              </a:spcAft>
+              <a:defRPr sz="2000">
+                <a:solidFill>
+                  <a:srgbClr val="FFFFFF"/>
+                </a:solidFill>
+              </a:defRPr>
+            </a:pPr>
+            <a:r>
+              <a:t>3.  A Streamlit Cloud account — streamlit.io/cloud (free)</a:t>
+            </a:r>
+          </a:p>
+          <a:p>
+            <a:pPr>
+              <a:spcBef>
+                <a:spcPts val="1000"/>
+              </a:spcBef>
+              <a:spcAft>
+                <a:spcPts val="400"/>
+              </a:spcAft>
+              <a:defRPr sz="2000">
+                <a:solidFill>
+                  <a:srgbClr val="FFFFFF"/>
+                </a:solidFill>
+              </a:defRPr>
+            </a:pPr>
+            <a:r>
+              <a:t>4.  Your data in an Excel file (.xlsx)</a:t>
+            </a:r>
+          </a:p>
+          <a:p>
+            <a:pPr>
+              <a:spcBef>
+                <a:spcPts val="1000"/>
+              </a:spcBef>
+              <a:spcAft>
+                <a:spcPts val="400"/>
+              </a:spcAft>
+              <a:defRPr sz="2000">
+                <a:solidFill>
+                  <a:srgbClr val="FFFFFF"/>
+                </a:solidFill>
+              </a:defRPr>
+            </a:pPr>
+            <a:r>
+              <a:t>5.  Azure AD app registration — request from IT (see next slide)</a:t>
             </a:r>
           </a:p>
         </p:txBody>
@@ -6583,7 +6689,7 @@
 </p:sld>
 </file>
 
-<file path=ppt/slides/slide5.xml><?xml version="1.0" encoding="utf-8"?>
+<file path=ppt/slides/slide4.xml><?xml version="1.0" encoding="utf-8"?>
 <p:sld xmlns:a="http://schemas.openxmlformats.org/drawingml/2006/main" xmlns:p="http://schemas.openxmlformats.org/presentationml/2006/main" xmlns:r="http://schemas.openxmlformats.org/officeDocument/2006/relationships">
   <p:cSld>
     <p:bg>
@@ -6674,7 +6780,7 @@
               </a:defRPr>
             </a:pPr>
             <a:r>
-              <a:t>Step 2: Describe Your Dashboard</a:t>
+              <a:t>FIRST: Send This Email to Your IT Team</a:t>
             </a:r>
           </a:p>
         </p:txBody>
@@ -6715,127 +6821,166 @@
               </a:defRPr>
             </a:pPr>
             <a:r>
-              <a:t>Tell Factory.AI what you want. Example:</a:t>
-            </a:r>
-          </a:p>
-          <a:p>
-            <a:pPr>
-              <a:spcBef>
-                <a:spcPts val="1000"/>
-              </a:spcBef>
-              <a:spcAft>
-                <a:spcPts val="400"/>
-              </a:spcAft>
-              <a:defRPr sz="2000">
-                <a:solidFill>
-                  <a:srgbClr val="FFFFFF"/>
-                </a:solidFill>
-              </a:defRPr>
-            </a:pPr>
-          </a:p>
-          <a:p>
-            <a:pPr>
-              <a:spcBef>
-                <a:spcPts val="1000"/>
-              </a:spcBef>
-              <a:spcAft>
-                <a:spcPts val="400"/>
-              </a:spcAft>
-              <a:defRPr sz="2000">
-                <a:solidFill>
-                  <a:srgbClr val="FFFFFF"/>
-                </a:solidFill>
-              </a:defRPr>
-            </a:pPr>
-            <a:r>
-              <a:t>   "Create a Streamlit dashboard using the Excel file at</a:t>
-            </a:r>
-          </a:p>
-          <a:p>
-            <a:pPr>
-              <a:spcBef>
-                <a:spcPts val="1000"/>
-              </a:spcBef>
-              <a:spcAft>
-                <a:spcPts val="400"/>
-              </a:spcAft>
-              <a:defRPr sz="2000">
-                <a:solidFill>
-                  <a:srgbClr val="FFFFFF"/>
-                </a:solidFill>
-              </a:defRPr>
-            </a:pPr>
-            <a:r>
-              <a:t>    [your file path] as the data source.</a:t>
-            </a:r>
-          </a:p>
-          <a:p>
-            <a:pPr>
-              <a:spcBef>
-                <a:spcPts val="1000"/>
-              </a:spcBef>
-              <a:spcAft>
-                <a:spcPts val="400"/>
-              </a:spcAft>
-              <a:defRPr sz="2000">
-                <a:solidFill>
-                  <a:srgbClr val="FFFFFF"/>
-                </a:solidFill>
-              </a:defRPr>
-            </a:pPr>
-            <a:r>
-              <a:t>    Use EY branding. Include KPI cards, charts, and filters.</a:t>
-            </a:r>
-          </a:p>
-          <a:p>
-            <a:pPr>
-              <a:spcBef>
-                <a:spcPts val="1000"/>
-              </a:spcBef>
-              <a:spcAft>
-                <a:spcPts val="400"/>
-              </a:spcAft>
-              <a:defRPr sz="2000">
-                <a:solidFill>
-                  <a:srgbClr val="FFFFFF"/>
-                </a:solidFill>
-              </a:defRPr>
-            </a:pPr>
-            <a:r>
-              <a:t>    Add role-based access for @ey.com emails."</a:t>
-            </a:r>
-          </a:p>
-          <a:p>
-            <a:pPr>
-              <a:spcBef>
-                <a:spcPts val="1000"/>
-              </a:spcBef>
-              <a:spcAft>
-                <a:spcPts val="400"/>
-              </a:spcAft>
-              <a:defRPr sz="2000">
-                <a:solidFill>
-                  <a:srgbClr val="FFFFFF"/>
-                </a:solidFill>
-              </a:defRPr>
-            </a:pPr>
-          </a:p>
-          <a:p>
-            <a:pPr>
-              <a:spcBef>
-                <a:spcPts val="1000"/>
-              </a:spcBef>
-              <a:spcAft>
-                <a:spcPts val="400"/>
-              </a:spcAft>
-              <a:defRPr sz="2000">
-                <a:solidFill>
-                  <a:srgbClr val="FFFFFF"/>
-                </a:solidFill>
-              </a:defRPr>
-            </a:pPr>
-            <a:r>
-              <a:t>Tip: Right-click your Excel file &gt; Option + Copy as Pathname</a:t>
+              <a:t>Send this request NOW — it may take a day or two to process.</a:t>
+            </a:r>
+          </a:p>
+          <a:p>
+            <a:pPr>
+              <a:spcBef>
+                <a:spcPts val="1000"/>
+              </a:spcBef>
+              <a:spcAft>
+                <a:spcPts val="400"/>
+              </a:spcAft>
+              <a:defRPr sz="2000">
+                <a:solidFill>
+                  <a:srgbClr val="FFFFFF"/>
+                </a:solidFill>
+              </a:defRPr>
+            </a:pPr>
+            <a:r>
+              <a:t>The dashboard works without SSO while you wait.</a:t>
+            </a:r>
+          </a:p>
+          <a:p>
+            <a:pPr>
+              <a:spcBef>
+                <a:spcPts val="1000"/>
+              </a:spcBef>
+              <a:spcAft>
+                <a:spcPts val="400"/>
+              </a:spcAft>
+              <a:defRPr sz="2000">
+                <a:solidFill>
+                  <a:srgbClr val="FFFFFF"/>
+                </a:solidFill>
+              </a:defRPr>
+            </a:pPr>
+          </a:p>
+          <a:p>
+            <a:pPr>
+              <a:spcBef>
+                <a:spcPts val="1000"/>
+              </a:spcBef>
+              <a:spcAft>
+                <a:spcPts val="400"/>
+              </a:spcAft>
+              <a:defRPr sz="2000">
+                <a:solidFill>
+                  <a:srgbClr val="FFFFFF"/>
+                </a:solidFill>
+              </a:defRPr>
+            </a:pPr>
+            <a:r>
+              <a:t>"Hi, I need an Azure AD app registration for a Streamlit dashboard.</a:t>
+            </a:r>
+          </a:p>
+          <a:p>
+            <a:pPr>
+              <a:spcBef>
+                <a:spcPts val="1000"/>
+              </a:spcBef>
+              <a:spcAft>
+                <a:spcPts val="400"/>
+              </a:spcAft>
+              <a:defRPr sz="2000">
+                <a:solidFill>
+                  <a:srgbClr val="FFFFFF"/>
+                </a:solidFill>
+              </a:defRPr>
+            </a:pPr>
+            <a:r>
+              <a:t>  1. Register app: Factory AI Dashboard</a:t>
+            </a:r>
+          </a:p>
+          <a:p>
+            <a:pPr>
+              <a:spcBef>
+                <a:spcPts val="1000"/>
+              </a:spcBef>
+              <a:spcAft>
+                <a:spcPts val="400"/>
+              </a:spcAft>
+              <a:defRPr sz="2000">
+                <a:solidFill>
+                  <a:srgbClr val="FFFFFF"/>
+                </a:solidFill>
+              </a:defRPr>
+            </a:pPr>
+            <a:r>
+              <a:t>  2. Account type: This organizational directory only</a:t>
+            </a:r>
+          </a:p>
+          <a:p>
+            <a:pPr>
+              <a:spcBef>
+                <a:spcPts val="1000"/>
+              </a:spcBef>
+              <a:spcAft>
+                <a:spcPts val="400"/>
+              </a:spcAft>
+              <a:defRPr sz="2000">
+                <a:solidFill>
+                  <a:srgbClr val="FFFFFF"/>
+                </a:solidFill>
+              </a:defRPr>
+            </a:pPr>
+            <a:r>
+              <a:t>  3. Redirect URI: Web &gt; [I will provide the URL]</a:t>
+            </a:r>
+          </a:p>
+          <a:p>
+            <a:pPr>
+              <a:spcBef>
+                <a:spcPts val="1000"/>
+              </a:spcBef>
+              <a:spcAft>
+                <a:spcPts val="400"/>
+              </a:spcAft>
+              <a:defRPr sz="2000">
+                <a:solidFill>
+                  <a:srgbClr val="FFFFFF"/>
+                </a:solidFill>
+              </a:defRPr>
+            </a:pPr>
+            <a:r>
+              <a:t>  4. Create a client secret</a:t>
+            </a:r>
+          </a:p>
+          <a:p>
+            <a:pPr>
+              <a:spcBef>
+                <a:spcPts val="1000"/>
+              </a:spcBef>
+              <a:spcAft>
+                <a:spcPts val="400"/>
+              </a:spcAft>
+              <a:defRPr sz="2000">
+                <a:solidFill>
+                  <a:srgbClr val="FFFFFF"/>
+                </a:solidFill>
+              </a:defRPr>
+            </a:pPr>
+            <a:r>
+              <a:t>  5. Add User.Read permission + grant admin consent</a:t>
+            </a:r>
+          </a:p>
+          <a:p>
+            <a:pPr>
+              <a:spcBef>
+                <a:spcPts val="1000"/>
+              </a:spcBef>
+              <a:spcAft>
+                <a:spcPts val="400"/>
+              </a:spcAft>
+              <a:defRPr sz="2000">
+                <a:solidFill>
+                  <a:srgbClr val="FFFFFF"/>
+                </a:solidFill>
+              </a:defRPr>
+            </a:pPr>
+            <a:r>
+              <a:t>  6. Send me: client_id, tenant_id, client_secret"</a:t>
             </a:r>
           </a:p>
         </p:txBody>
@@ -6848,7 +6993,7 @@
 </p:sld>
 </file>
 
-<file path=ppt/slides/slide6.xml><?xml version="1.0" encoding="utf-8"?>
+<file path=ppt/slides/slide5.xml><?xml version="1.0" encoding="utf-8"?>
 <p:sld xmlns:a="http://schemas.openxmlformats.org/drawingml/2006/main" xmlns:p="http://schemas.openxmlformats.org/presentationml/2006/main" xmlns:r="http://schemas.openxmlformats.org/officeDocument/2006/relationships">
   <p:cSld>
     <p:bg>
@@ -6939,7 +7084,7 @@
               </a:defRPr>
             </a:pPr>
             <a:r>
-              <a:t>Step 3: Test Locally</a:t>
+              <a:t>Step 1: Open Factory.AI</a:t>
             </a:r>
           </a:p>
         </p:txBody>
@@ -6980,145 +7125,91 @@
               </a:defRPr>
             </a:pPr>
             <a:r>
-              <a:t>Factory.AI launches the dashboard in your browser.</a:t>
-            </a:r>
-          </a:p>
-          <a:p>
-            <a:pPr>
-              <a:spcBef>
-                <a:spcPts val="1000"/>
-              </a:spcBef>
-              <a:spcAft>
-                <a:spcPts val="400"/>
-              </a:spcAft>
-              <a:defRPr sz="2000">
-                <a:solidFill>
-                  <a:srgbClr val="FFFFFF"/>
-                </a:solidFill>
-              </a:defRPr>
-            </a:pPr>
-            <a:r>
-              <a:t>If not, type:  "run the streamlit app"</a:t>
-            </a:r>
-          </a:p>
-          <a:p>
-            <a:pPr>
-              <a:spcBef>
-                <a:spcPts val="1000"/>
-              </a:spcBef>
-              <a:spcAft>
-                <a:spcPts val="400"/>
-              </a:spcAft>
-              <a:defRPr sz="2000">
-                <a:solidFill>
-                  <a:srgbClr val="FFFFFF"/>
-                </a:solidFill>
-              </a:defRPr>
-            </a:pPr>
-          </a:p>
-          <a:p>
-            <a:pPr>
-              <a:spcBef>
-                <a:spcPts val="1000"/>
-              </a:spcBef>
-              <a:spcAft>
-                <a:spcPts val="400"/>
-              </a:spcAft>
-              <a:defRPr sz="2000">
-                <a:solidFill>
-                  <a:srgbClr val="FFFFFF"/>
-                </a:solidFill>
-              </a:defRPr>
-            </a:pPr>
-            <a:r>
-              <a:t>Verify:</a:t>
-            </a:r>
-          </a:p>
-          <a:p>
-            <a:pPr>
-              <a:spcBef>
-                <a:spcPts val="1000"/>
-              </a:spcBef>
-              <a:spcAft>
-                <a:spcPts val="400"/>
-              </a:spcAft>
-              <a:defRPr sz="2000">
-                <a:solidFill>
-                  <a:srgbClr val="FFFFFF"/>
-                </a:solidFill>
-              </a:defRPr>
-            </a:pPr>
-            <a:r>
-              <a:t>   Charts display your data correctly</a:t>
-            </a:r>
-          </a:p>
-          <a:p>
-            <a:pPr>
-              <a:spcBef>
-                <a:spcPts val="1000"/>
-              </a:spcBef>
-              <a:spcAft>
-                <a:spcPts val="400"/>
-              </a:spcAft>
-              <a:defRPr sz="2000">
-                <a:solidFill>
-                  <a:srgbClr val="FFFFFF"/>
-                </a:solidFill>
-              </a:defRPr>
-            </a:pPr>
-            <a:r>
-              <a:t>   Filters work (Region, Date Range, etc.)</a:t>
-            </a:r>
-          </a:p>
-          <a:p>
-            <a:pPr>
-              <a:spcBef>
-                <a:spcPts val="1000"/>
-              </a:spcBef>
-              <a:spcAft>
-                <a:spcPts val="400"/>
-              </a:spcAft>
-              <a:defRPr sz="2000">
-                <a:solidFill>
-                  <a:srgbClr val="FFFFFF"/>
-                </a:solidFill>
-              </a:defRPr>
-            </a:pPr>
-            <a:r>
-              <a:t>   KPI numbers look reasonable</a:t>
-            </a:r>
-          </a:p>
-          <a:p>
-            <a:pPr>
-              <a:spcBef>
-                <a:spcPts val="1000"/>
-              </a:spcBef>
-              <a:spcAft>
-                <a:spcPts val="400"/>
-              </a:spcAft>
-              <a:defRPr sz="2000">
-                <a:solidFill>
-                  <a:srgbClr val="FFFFFF"/>
-                </a:solidFill>
-              </a:defRPr>
-            </a:pPr>
-          </a:p>
-          <a:p>
-            <a:pPr>
-              <a:spcBef>
-                <a:spcPts val="1000"/>
-              </a:spcBef>
-              <a:spcAft>
-                <a:spcPts val="400"/>
-              </a:spcAft>
-              <a:defRPr sz="2000">
-                <a:solidFill>
-                  <a:srgbClr val="FFFFFF"/>
-                </a:solidFill>
-              </a:defRPr>
-            </a:pPr>
-            <a:r>
-              <a:t>Want changes? Just say it: "Make the title bigger"</a:t>
+              <a:t>Open your terminal (Mac: search "Terminal" in Spotlight)</a:t>
+            </a:r>
+          </a:p>
+          <a:p>
+            <a:pPr>
+              <a:spcBef>
+                <a:spcPts val="1000"/>
+              </a:spcBef>
+              <a:spcAft>
+                <a:spcPts val="400"/>
+              </a:spcAft>
+              <a:defRPr sz="2000">
+                <a:solidFill>
+                  <a:srgbClr val="FFFFFF"/>
+                </a:solidFill>
+              </a:defRPr>
+            </a:pPr>
+          </a:p>
+          <a:p>
+            <a:pPr>
+              <a:spcBef>
+                <a:spcPts val="1000"/>
+              </a:spcBef>
+              <a:spcAft>
+                <a:spcPts val="400"/>
+              </a:spcAft>
+              <a:defRPr sz="2000">
+                <a:solidFill>
+                  <a:srgbClr val="FFFFFF"/>
+                </a:solidFill>
+              </a:defRPr>
+            </a:pPr>
+            <a:r>
+              <a:t>Type:  droid</a:t>
+            </a:r>
+          </a:p>
+          <a:p>
+            <a:pPr>
+              <a:spcBef>
+                <a:spcPts val="1000"/>
+              </a:spcBef>
+              <a:spcAft>
+                <a:spcPts val="400"/>
+              </a:spcAft>
+              <a:defRPr sz="2000">
+                <a:solidFill>
+                  <a:srgbClr val="FFFFFF"/>
+                </a:solidFill>
+              </a:defRPr>
+            </a:pPr>
+          </a:p>
+          <a:p>
+            <a:pPr>
+              <a:spcBef>
+                <a:spcPts val="1000"/>
+              </a:spcBef>
+              <a:spcAft>
+                <a:spcPts val="400"/>
+              </a:spcAft>
+              <a:defRPr sz="2000">
+                <a:solidFill>
+                  <a:srgbClr val="FFFFFF"/>
+                </a:solidFill>
+              </a:defRPr>
+            </a:pPr>
+            <a:r>
+              <a:t>The Factory.AI prompt will appear.</a:t>
+            </a:r>
+          </a:p>
+          <a:p>
+            <a:pPr>
+              <a:spcBef>
+                <a:spcPts val="1000"/>
+              </a:spcBef>
+              <a:spcAft>
+                <a:spcPts val="400"/>
+              </a:spcAft>
+              <a:defRPr sz="2000">
+                <a:solidFill>
+                  <a:srgbClr val="FFFFFF"/>
+                </a:solidFill>
+              </a:defRPr>
+            </a:pPr>
+            <a:r>
+              <a:t>You give instructions in plain English — it writes the code.</a:t>
             </a:r>
           </a:p>
         </p:txBody>
@@ -7131,7 +7222,7 @@
 </p:sld>
 </file>
 
-<file path=ppt/slides/slide7.xml><?xml version="1.0" encoding="utf-8"?>
+<file path=ppt/slides/slide6.xml><?xml version="1.0" encoding="utf-8"?>
 <p:sld xmlns:a="http://schemas.openxmlformats.org/drawingml/2006/main" xmlns:p="http://schemas.openxmlformats.org/presentationml/2006/main" xmlns:r="http://schemas.openxmlformats.org/officeDocument/2006/relationships">
   <p:cSld>
     <p:bg>
@@ -7222,7 +7313,7 @@
               </a:defRPr>
             </a:pPr>
             <a:r>
-              <a:t>Step 4: Push to GitHub</a:t>
+              <a:t>Step 2: Describe Your Dashboard</a:t>
             </a:r>
           </a:p>
         </p:txBody>
@@ -7263,109 +7354,145 @@
               </a:defRPr>
             </a:pPr>
             <a:r>
-              <a:t>Tell Factory.AI:</a:t>
-            </a:r>
-          </a:p>
-          <a:p>
-            <a:pPr>
-              <a:spcBef>
-                <a:spcPts val="1000"/>
-              </a:spcBef>
-              <a:spcAft>
-                <a:spcPts val="400"/>
-              </a:spcAft>
-              <a:defRPr sz="2000">
-                <a:solidFill>
-                  <a:srgbClr val="FFFFFF"/>
-                </a:solidFill>
-              </a:defRPr>
-            </a:pPr>
-          </a:p>
-          <a:p>
-            <a:pPr>
-              <a:spcBef>
-                <a:spcPts val="1000"/>
-              </a:spcBef>
-              <a:spcAft>
-                <a:spcPts val="400"/>
-              </a:spcAft>
-              <a:defRPr sz="2000">
-                <a:solidFill>
-                  <a:srgbClr val="FFFFFF"/>
-                </a:solidFill>
-              </a:defRPr>
-            </a:pPr>
-            <a:r>
-              <a:t>   "Push this code to GitHub and create a new</a:t>
-            </a:r>
-          </a:p>
-          <a:p>
-            <a:pPr>
-              <a:spcBef>
-                <a:spcPts val="1000"/>
-              </a:spcBef>
-              <a:spcAft>
-                <a:spcPts val="400"/>
-              </a:spcAft>
-              <a:defRPr sz="2000">
-                <a:solidFill>
-                  <a:srgbClr val="FFFFFF"/>
-                </a:solidFill>
-              </a:defRPr>
-            </a:pPr>
-            <a:r>
-              <a:t>    repo called My Dashboard Name"</a:t>
-            </a:r>
-          </a:p>
-          <a:p>
-            <a:pPr>
-              <a:spcBef>
-                <a:spcPts val="1000"/>
-              </a:spcBef>
-              <a:spcAft>
-                <a:spcPts val="400"/>
-              </a:spcAft>
-              <a:defRPr sz="2000">
-                <a:solidFill>
-                  <a:srgbClr val="FFFFFF"/>
-                </a:solidFill>
-              </a:defRPr>
-            </a:pPr>
-          </a:p>
-          <a:p>
-            <a:pPr>
-              <a:spcBef>
-                <a:spcPts val="1000"/>
-              </a:spcBef>
-              <a:spcAft>
-                <a:spcPts val="400"/>
-              </a:spcAft>
-              <a:defRPr sz="2000">
-                <a:solidFill>
-                  <a:srgbClr val="FFFFFF"/>
-                </a:solidFill>
-              </a:defRPr>
-            </a:pPr>
-            <a:r>
-              <a:t>It will create the repository and upload everything.</a:t>
-            </a:r>
-          </a:p>
-          <a:p>
-            <a:pPr>
-              <a:spcBef>
-                <a:spcPts val="1000"/>
-              </a:spcBef>
-              <a:spcAft>
-                <a:spcPts val="400"/>
-              </a:spcAft>
-              <a:defRPr sz="2000">
-                <a:solidFill>
-                  <a:srgbClr val="FFFFFF"/>
-                </a:solidFill>
-              </a:defRPr>
-            </a:pPr>
-            <a:r>
-              <a:t>Save the URL it gives you — you need it next.</a:t>
+              <a:t>Tell Factory.AI what you want. Example:</a:t>
+            </a:r>
+          </a:p>
+          <a:p>
+            <a:pPr>
+              <a:spcBef>
+                <a:spcPts val="1000"/>
+              </a:spcBef>
+              <a:spcAft>
+                <a:spcPts val="400"/>
+              </a:spcAft>
+              <a:defRPr sz="2000">
+                <a:solidFill>
+                  <a:srgbClr val="FFFFFF"/>
+                </a:solidFill>
+              </a:defRPr>
+            </a:pPr>
+          </a:p>
+          <a:p>
+            <a:pPr>
+              <a:spcBef>
+                <a:spcPts val="1000"/>
+              </a:spcBef>
+              <a:spcAft>
+                <a:spcPts val="400"/>
+              </a:spcAft>
+              <a:defRPr sz="2000">
+                <a:solidFill>
+                  <a:srgbClr val="FFFFFF"/>
+                </a:solidFill>
+              </a:defRPr>
+            </a:pPr>
+            <a:r>
+              <a:t>   "Create a Streamlit dashboard using [my file path].</a:t>
+            </a:r>
+          </a:p>
+          <a:p>
+            <a:pPr>
+              <a:spcBef>
+                <a:spcPts val="1000"/>
+              </a:spcBef>
+              <a:spcAft>
+                <a:spcPts val="400"/>
+              </a:spcAft>
+              <a:defRPr sz="2000">
+                <a:solidFill>
+                  <a:srgbClr val="FFFFFF"/>
+                </a:solidFill>
+              </a:defRPr>
+            </a:pPr>
+            <a:r>
+              <a:t>    Use EY branding. Include KPI cards, charts, and filters.</a:t>
+            </a:r>
+          </a:p>
+          <a:p>
+            <a:pPr>
+              <a:spcBef>
+                <a:spcPts val="1000"/>
+              </a:spcBef>
+              <a:spcAft>
+                <a:spcPts val="400"/>
+              </a:spcAft>
+              <a:defRPr sz="2000">
+                <a:solidFill>
+                  <a:srgbClr val="FFFFFF"/>
+                </a:solidFill>
+              </a:defRPr>
+            </a:pPr>
+            <a:r>
+              <a:t>    Add role-based access for @ey.com emails.</a:t>
+            </a:r>
+          </a:p>
+          <a:p>
+            <a:pPr>
+              <a:spcBef>
+                <a:spcPts val="1000"/>
+              </a:spcBef>
+              <a:spcAft>
+                <a:spcPts val="400"/>
+              </a:spcAft>
+              <a:defRPr sz="2000">
+                <a:solidFill>
+                  <a:srgbClr val="FFFFFF"/>
+                </a:solidFill>
+              </a:defRPr>
+            </a:pPr>
+            <a:r>
+              <a:t>    Include Microsoft SSO using Azure AD.</a:t>
+            </a:r>
+          </a:p>
+          <a:p>
+            <a:pPr>
+              <a:spcBef>
+                <a:spcPts val="1000"/>
+              </a:spcBef>
+              <a:spcAft>
+                <a:spcPts val="400"/>
+              </a:spcAft>
+              <a:defRPr sz="2000">
+                <a:solidFill>
+                  <a:srgbClr val="FFFFFF"/>
+                </a:solidFill>
+              </a:defRPr>
+            </a:pPr>
+            <a:r>
+              <a:t>    Fall back to email input if Azure secrets are not configured."</a:t>
+            </a:r>
+          </a:p>
+          <a:p>
+            <a:pPr>
+              <a:spcBef>
+                <a:spcPts val="1000"/>
+              </a:spcBef>
+              <a:spcAft>
+                <a:spcPts val="400"/>
+              </a:spcAft>
+              <a:defRPr sz="2000">
+                <a:solidFill>
+                  <a:srgbClr val="FFFFFF"/>
+                </a:solidFill>
+              </a:defRPr>
+            </a:pPr>
+          </a:p>
+          <a:p>
+            <a:pPr>
+              <a:spcBef>
+                <a:spcPts val="1000"/>
+              </a:spcBef>
+              <a:spcAft>
+                <a:spcPts val="400"/>
+              </a:spcAft>
+              <a:defRPr sz="2000">
+                <a:solidFill>
+                  <a:srgbClr val="FFFFFF"/>
+                </a:solidFill>
+              </a:defRPr>
+            </a:pPr>
+            <a:r>
+              <a:t>Tip: Right-click your Excel file &gt; Option + Copy as Pathname</a:t>
             </a:r>
           </a:p>
         </p:txBody>
@@ -7378,7 +7505,7 @@
 </p:sld>
 </file>
 
-<file path=ppt/slides/slide8.xml><?xml version="1.0" encoding="utf-8"?>
+<file path=ppt/slides/slide7.xml><?xml version="1.0" encoding="utf-8"?>
 <p:sld xmlns:a="http://schemas.openxmlformats.org/drawingml/2006/main" xmlns:p="http://schemas.openxmlformats.org/presentationml/2006/main" xmlns:r="http://schemas.openxmlformats.org/officeDocument/2006/relationships">
   <p:cSld>
     <p:bg>
@@ -7469,7 +7596,7 @@
               </a:defRPr>
             </a:pPr>
             <a:r>
-              <a:t>Step 5: Deploy to Streamlit Cloud</a:t>
+              <a:t>Step 3: Test Locally</a:t>
             </a:r>
           </a:p>
         </p:txBody>
@@ -7510,130 +7637,145 @@
               </a:defRPr>
             </a:pPr>
             <a:r>
-              <a:t>1.  Go to share.streamlit.io and sign in with GitHub</a:t>
-            </a:r>
-          </a:p>
-          <a:p>
-            <a:pPr>
-              <a:spcBef>
-                <a:spcPts val="1000"/>
-              </a:spcBef>
-              <a:spcAft>
-                <a:spcPts val="400"/>
-              </a:spcAft>
-              <a:defRPr sz="2000">
-                <a:solidFill>
-                  <a:srgbClr val="FFFFFF"/>
-                </a:solidFill>
-              </a:defRPr>
-            </a:pPr>
-            <a:r>
-              <a:t>2.  Click "New app"</a:t>
-            </a:r>
-          </a:p>
-          <a:p>
-            <a:pPr>
-              <a:spcBef>
-                <a:spcPts val="1000"/>
-              </a:spcBef>
-              <a:spcAft>
-                <a:spcPts val="400"/>
-              </a:spcAft>
-              <a:defRPr sz="2000">
-                <a:solidFill>
-                  <a:srgbClr val="FFFFFF"/>
-                </a:solidFill>
-              </a:defRPr>
-            </a:pPr>
-            <a:r>
-              <a:t>3.  Select your repository, branch: main, file: app.py</a:t>
-            </a:r>
-          </a:p>
-          <a:p>
-            <a:pPr>
-              <a:spcBef>
-                <a:spcPts val="1000"/>
-              </a:spcBef>
-              <a:spcAft>
-                <a:spcPts val="400"/>
-              </a:spcAft>
-              <a:defRPr sz="2000">
-                <a:solidFill>
-                  <a:srgbClr val="FFFFFF"/>
-                </a:solidFill>
-              </a:defRPr>
-            </a:pPr>
-            <a:r>
-              <a:t>4.  Click "Deploy"</a:t>
-            </a:r>
-          </a:p>
-          <a:p>
-            <a:pPr>
-              <a:spcBef>
-                <a:spcPts val="1000"/>
-              </a:spcBef>
-              <a:spcAft>
-                <a:spcPts val="400"/>
-              </a:spcAft>
-              <a:defRPr sz="2000">
-                <a:solidFill>
-                  <a:srgbClr val="FFFFFF"/>
-                </a:solidFill>
-              </a:defRPr>
-            </a:pPr>
-            <a:r>
-              <a:t>5.  Wait 2-3 minutes for the app to build</a:t>
-            </a:r>
-          </a:p>
-          <a:p>
-            <a:pPr>
-              <a:spcBef>
-                <a:spcPts val="1000"/>
-              </a:spcBef>
-              <a:spcAft>
-                <a:spcPts val="400"/>
-              </a:spcAft>
-              <a:defRPr sz="2000">
-                <a:solidFill>
-                  <a:srgbClr val="FFFFFF"/>
-                </a:solidFill>
-              </a:defRPr>
-            </a:pPr>
-          </a:p>
-          <a:p>
-            <a:pPr>
-              <a:spcBef>
-                <a:spcPts val="1000"/>
-              </a:spcBef>
-              <a:spcAft>
-                <a:spcPts val="400"/>
-              </a:spcAft>
-              <a:defRPr sz="2000">
-                <a:solidFill>
-                  <a:srgbClr val="FFFFFF"/>
-                </a:solidFill>
-              </a:defRPr>
-            </a:pPr>
-            <a:r>
-              <a:t>You will get a live URL like:</a:t>
-            </a:r>
-          </a:p>
-          <a:p>
-            <a:pPr>
-              <a:spcBef>
-                <a:spcPts val="1000"/>
-              </a:spcBef>
-              <a:spcAft>
-                <a:spcPts val="400"/>
-              </a:spcAft>
-              <a:defRPr sz="2000">
-                <a:solidFill>
-                  <a:srgbClr val="FFFFFF"/>
-                </a:solidFill>
-              </a:defRPr>
-            </a:pPr>
-            <a:r>
-              <a:t>   https://my-dashboard-xyz.streamlit.app</a:t>
+              <a:t>Factory.AI launches the dashboard in your browser.</a:t>
+            </a:r>
+          </a:p>
+          <a:p>
+            <a:pPr>
+              <a:spcBef>
+                <a:spcPts val="1000"/>
+              </a:spcBef>
+              <a:spcAft>
+                <a:spcPts val="400"/>
+              </a:spcAft>
+              <a:defRPr sz="2000">
+                <a:solidFill>
+                  <a:srgbClr val="FFFFFF"/>
+                </a:solidFill>
+              </a:defRPr>
+            </a:pPr>
+            <a:r>
+              <a:t>If not, type:  "run the streamlit app"</a:t>
+            </a:r>
+          </a:p>
+          <a:p>
+            <a:pPr>
+              <a:spcBef>
+                <a:spcPts val="1000"/>
+              </a:spcBef>
+              <a:spcAft>
+                <a:spcPts val="400"/>
+              </a:spcAft>
+              <a:defRPr sz="2000">
+                <a:solidFill>
+                  <a:srgbClr val="FFFFFF"/>
+                </a:solidFill>
+              </a:defRPr>
+            </a:pPr>
+          </a:p>
+          <a:p>
+            <a:pPr>
+              <a:spcBef>
+                <a:spcPts val="1000"/>
+              </a:spcBef>
+              <a:spcAft>
+                <a:spcPts val="400"/>
+              </a:spcAft>
+              <a:defRPr sz="2000">
+                <a:solidFill>
+                  <a:srgbClr val="FFFFFF"/>
+                </a:solidFill>
+              </a:defRPr>
+            </a:pPr>
+            <a:r>
+              <a:t>Verify:</a:t>
+            </a:r>
+          </a:p>
+          <a:p>
+            <a:pPr>
+              <a:spcBef>
+                <a:spcPts val="1000"/>
+              </a:spcBef>
+              <a:spcAft>
+                <a:spcPts val="400"/>
+              </a:spcAft>
+              <a:defRPr sz="2000">
+                <a:solidFill>
+                  <a:srgbClr val="FFFFFF"/>
+                </a:solidFill>
+              </a:defRPr>
+            </a:pPr>
+            <a:r>
+              <a:t>   Charts display your data correctly</a:t>
+            </a:r>
+          </a:p>
+          <a:p>
+            <a:pPr>
+              <a:spcBef>
+                <a:spcPts val="1000"/>
+              </a:spcBef>
+              <a:spcAft>
+                <a:spcPts val="400"/>
+              </a:spcAft>
+              <a:defRPr sz="2000">
+                <a:solidFill>
+                  <a:srgbClr val="FFFFFF"/>
+                </a:solidFill>
+              </a:defRPr>
+            </a:pPr>
+            <a:r>
+              <a:t>   Filters work (Region, Date Range, etc.)</a:t>
+            </a:r>
+          </a:p>
+          <a:p>
+            <a:pPr>
+              <a:spcBef>
+                <a:spcPts val="1000"/>
+              </a:spcBef>
+              <a:spcAft>
+                <a:spcPts val="400"/>
+              </a:spcAft>
+              <a:defRPr sz="2000">
+                <a:solidFill>
+                  <a:srgbClr val="FFFFFF"/>
+                </a:solidFill>
+              </a:defRPr>
+            </a:pPr>
+            <a:r>
+              <a:t>   KPI numbers look reasonable</a:t>
+            </a:r>
+          </a:p>
+          <a:p>
+            <a:pPr>
+              <a:spcBef>
+                <a:spcPts val="1000"/>
+              </a:spcBef>
+              <a:spcAft>
+                <a:spcPts val="400"/>
+              </a:spcAft>
+              <a:defRPr sz="2000">
+                <a:solidFill>
+                  <a:srgbClr val="FFFFFF"/>
+                </a:solidFill>
+              </a:defRPr>
+            </a:pPr>
+          </a:p>
+          <a:p>
+            <a:pPr>
+              <a:spcBef>
+                <a:spcPts val="1000"/>
+              </a:spcBef>
+              <a:spcAft>
+                <a:spcPts val="400"/>
+              </a:spcAft>
+              <a:defRPr sz="2000">
+                <a:solidFill>
+                  <a:srgbClr val="FFFFFF"/>
+                </a:solidFill>
+              </a:defRPr>
+            </a:pPr>
+            <a:r>
+              <a:t>Want changes? Just say it: "Make the title bigger"</a:t>
             </a:r>
           </a:p>
         </p:txBody>
@@ -7646,7 +7788,7 @@
 </p:sld>
 </file>
 
-<file path=ppt/slides/slide9.xml><?xml version="1.0" encoding="utf-8"?>
+<file path=ppt/slides/slide8.xml><?xml version="1.0" encoding="utf-8"?>
 <p:sld xmlns:a="http://schemas.openxmlformats.org/drawingml/2006/main" xmlns:p="http://schemas.openxmlformats.org/presentationml/2006/main" xmlns:r="http://schemas.openxmlformats.org/officeDocument/2006/relationships">
   <p:cSld>
     <p:bg>
@@ -7737,7 +7879,7 @@
               </a:defRPr>
             </a:pPr>
             <a:r>
-              <a:t>Step 6: Share With Your Team</a:t>
+              <a:t>Step 4: Push to GitHub</a:t>
             </a:r>
           </a:p>
         </p:txBody>
@@ -7778,127 +7920,377 @@
               </a:defRPr>
             </a:pPr>
             <a:r>
-              <a:t>Send the Streamlit URL to anyone at EY.</a:t>
-            </a:r>
-          </a:p>
-          <a:p>
-            <a:pPr>
-              <a:spcBef>
-                <a:spcPts val="1000"/>
-              </a:spcBef>
-              <a:spcAft>
-                <a:spcPts val="400"/>
-              </a:spcAft>
-              <a:defRPr sz="2000">
-                <a:solidFill>
-                  <a:srgbClr val="FFFFFF"/>
-                </a:solidFill>
-              </a:defRPr>
-            </a:pPr>
-          </a:p>
-          <a:p>
-            <a:pPr>
-              <a:spcBef>
-                <a:spcPts val="1000"/>
-              </a:spcBef>
-              <a:spcAft>
-                <a:spcPts val="400"/>
-              </a:spcAft>
-              <a:defRPr sz="2000">
-                <a:solidFill>
-                  <a:srgbClr val="FFFFFF"/>
-                </a:solidFill>
-              </a:defRPr>
-            </a:pPr>
-            <a:r>
-              <a:t>Access model:</a:t>
-            </a:r>
-          </a:p>
-          <a:p>
-            <a:pPr>
-              <a:spcBef>
-                <a:spcPts val="1000"/>
-              </a:spcBef>
-              <a:spcAft>
-                <a:spcPts val="400"/>
-              </a:spcAft>
-              <a:defRPr sz="2000">
-                <a:solidFill>
-                  <a:srgbClr val="FFFFFF"/>
-                </a:solidFill>
-              </a:defRPr>
-            </a:pPr>
-            <a:r>
-              <a:t>   Any @ey.com email  →  View dashboard (read-only)</a:t>
-            </a:r>
-          </a:p>
-          <a:p>
-            <a:pPr>
-              <a:spcBef>
-                <a:spcPts val="1000"/>
-              </a:spcBef>
-              <a:spcAft>
-                <a:spcPts val="400"/>
-              </a:spcAft>
-              <a:defRPr sz="2000">
-                <a:solidFill>
-                  <a:srgbClr val="FFFFFF"/>
-                </a:solidFill>
-              </a:defRPr>
-            </a:pPr>
-            <a:r>
-              <a:t>   Admins you configure  →  Edit data, manage access</a:t>
-            </a:r>
-          </a:p>
-          <a:p>
-            <a:pPr>
-              <a:spcBef>
-                <a:spcPts val="1000"/>
-              </a:spcBef>
-              <a:spcAft>
-                <a:spcPts val="400"/>
-              </a:spcAft>
-              <a:defRPr sz="2000">
-                <a:solidFill>
-                  <a:srgbClr val="FFFFFF"/>
-                </a:solidFill>
-              </a:defRPr>
-            </a:pPr>
-          </a:p>
-          <a:p>
-            <a:pPr>
-              <a:spcBef>
-                <a:spcPts val="1000"/>
-              </a:spcBef>
-              <a:spcAft>
-                <a:spcPts val="400"/>
-              </a:spcAft>
-              <a:defRPr sz="2000">
-                <a:solidFill>
-                  <a:srgbClr val="FFFFFF"/>
-                </a:solidFill>
-              </a:defRPr>
-            </a:pPr>
-            <a:r>
-              <a:t>To add an admin: scroll to bottom of dashboard</a:t>
-            </a:r>
-          </a:p>
-          <a:p>
-            <a:pPr>
-              <a:spcBef>
-                <a:spcPts val="1000"/>
-              </a:spcBef>
-              <a:spcAft>
-                <a:spcPts val="400"/>
-              </a:spcAft>
-              <a:defRPr sz="2000">
-                <a:solidFill>
-                  <a:srgbClr val="FFFFFF"/>
-                </a:solidFill>
-              </a:defRPr>
-            </a:pPr>
-            <a:r>
-              <a:t>   → "Admin: Manage Admins" → enter their @ey.com email</a:t>
+              <a:t>Tell Factory.AI:</a:t>
+            </a:r>
+          </a:p>
+          <a:p>
+            <a:pPr>
+              <a:spcBef>
+                <a:spcPts val="1000"/>
+              </a:spcBef>
+              <a:spcAft>
+                <a:spcPts val="400"/>
+              </a:spcAft>
+              <a:defRPr sz="2000">
+                <a:solidFill>
+                  <a:srgbClr val="FFFFFF"/>
+                </a:solidFill>
+              </a:defRPr>
+            </a:pPr>
+          </a:p>
+          <a:p>
+            <a:pPr>
+              <a:spcBef>
+                <a:spcPts val="1000"/>
+              </a:spcBef>
+              <a:spcAft>
+                <a:spcPts val="400"/>
+              </a:spcAft>
+              <a:defRPr sz="2000">
+                <a:solidFill>
+                  <a:srgbClr val="FFFFFF"/>
+                </a:solidFill>
+              </a:defRPr>
+            </a:pPr>
+            <a:r>
+              <a:t>   "Push this code to GitHub and create a new</a:t>
+            </a:r>
+          </a:p>
+          <a:p>
+            <a:pPr>
+              <a:spcBef>
+                <a:spcPts val="1000"/>
+              </a:spcBef>
+              <a:spcAft>
+                <a:spcPts val="400"/>
+              </a:spcAft>
+              <a:defRPr sz="2000">
+                <a:solidFill>
+                  <a:srgbClr val="FFFFFF"/>
+                </a:solidFill>
+              </a:defRPr>
+            </a:pPr>
+            <a:r>
+              <a:t>    repo called My Dashboard Name"</a:t>
+            </a:r>
+          </a:p>
+          <a:p>
+            <a:pPr>
+              <a:spcBef>
+                <a:spcPts val="1000"/>
+              </a:spcBef>
+              <a:spcAft>
+                <a:spcPts val="400"/>
+              </a:spcAft>
+              <a:defRPr sz="2000">
+                <a:solidFill>
+                  <a:srgbClr val="FFFFFF"/>
+                </a:solidFill>
+              </a:defRPr>
+            </a:pPr>
+          </a:p>
+          <a:p>
+            <a:pPr>
+              <a:spcBef>
+                <a:spcPts val="1000"/>
+              </a:spcBef>
+              <a:spcAft>
+                <a:spcPts val="400"/>
+              </a:spcAft>
+              <a:defRPr sz="2000">
+                <a:solidFill>
+                  <a:srgbClr val="FFFFFF"/>
+                </a:solidFill>
+              </a:defRPr>
+            </a:pPr>
+            <a:r>
+              <a:t>It will create the repository and upload everything.</a:t>
+            </a:r>
+          </a:p>
+          <a:p>
+            <a:pPr>
+              <a:spcBef>
+                <a:spcPts val="1000"/>
+              </a:spcBef>
+              <a:spcAft>
+                <a:spcPts val="400"/>
+              </a:spcAft>
+              <a:defRPr sz="2000">
+                <a:solidFill>
+                  <a:srgbClr val="FFFFFF"/>
+                </a:solidFill>
+              </a:defRPr>
+            </a:pPr>
+            <a:r>
+              <a:t>Save the URL it gives you — you need it next.</a:t>
+            </a:r>
+          </a:p>
+        </p:txBody>
+      </p:sp>
+    </p:spTree>
+  </p:cSld>
+  <p:clrMapOvr>
+    <a:masterClrMapping/>
+  </p:clrMapOvr>
+</p:sld>
+</file>
+
+<file path=ppt/slides/slide9.xml><?xml version="1.0" encoding="utf-8"?>
+<p:sld xmlns:a="http://schemas.openxmlformats.org/drawingml/2006/main" xmlns:p="http://schemas.openxmlformats.org/presentationml/2006/main" xmlns:r="http://schemas.openxmlformats.org/officeDocument/2006/relationships">
+  <p:cSld>
+    <p:bg>
+      <p:bgPr>
+        <a:solidFill>
+          <a:srgbClr val="2E2E38"/>
+        </a:solidFill>
+        <a:effectLst/>
+      </p:bgPr>
+    </p:bg>
+    <p:spTree>
+      <p:nvGrpSpPr>
+        <p:cNvPr id="1" name=""/>
+        <p:cNvGrpSpPr/>
+        <p:nvPr/>
+      </p:nvGrpSpPr>
+      <p:grpSpPr/>
+      <p:sp>
+        <p:nvSpPr>
+          <p:cNvPr id="2" name="Rectangle 1"/>
+          <p:cNvSpPr/>
+          <p:nvPr/>
+        </p:nvSpPr>
+        <p:spPr>
+          <a:xfrm>
+            <a:off x="0" y="0"/>
+            <a:ext cx="12191695" cy="73152"/>
+          </a:xfrm>
+          <a:prstGeom prst="rect">
+            <a:avLst/>
+          </a:prstGeom>
+          <a:solidFill>
+            <a:srgbClr val="FFE600"/>
+          </a:solidFill>
+          <a:ln>
+            <a:noFill/>
+          </a:ln>
+        </p:spPr>
+        <p:style>
+          <a:lnRef idx="1">
+            <a:schemeClr val="accent1"/>
+          </a:lnRef>
+          <a:fillRef idx="3">
+            <a:schemeClr val="accent1"/>
+          </a:fillRef>
+          <a:effectRef idx="2">
+            <a:schemeClr val="accent1"/>
+          </a:effectRef>
+          <a:fontRef idx="minor">
+            <a:schemeClr val="lt1"/>
+          </a:fontRef>
+        </p:style>
+        <p:txBody>
+          <a:bodyPr rtlCol="0" anchor="ctr"/>
+          <a:lstStyle/>
+          <a:p>
+            <a:pPr algn="ctr"/>
+          </a:p>
+        </p:txBody>
+      </p:sp>
+      <p:sp>
+        <p:nvSpPr>
+          <p:cNvPr id="3" name="TextBox 2"/>
+          <p:cNvSpPr txBox="1"/>
+          <p:nvPr/>
+        </p:nvSpPr>
+        <p:spPr>
+          <a:xfrm>
+            <a:off x="731520" y="320040"/>
+            <a:ext cx="10728655" cy="822960"/>
+          </a:xfrm>
+          <a:prstGeom prst="rect">
+            <a:avLst/>
+          </a:prstGeom>
+          <a:noFill/>
+        </p:spPr>
+        <p:txBody>
+          <a:bodyPr wrap="square">
+            <a:spAutoFit/>
+          </a:bodyPr>
+          <a:lstStyle/>
+          <a:p>
+            <a:pPr>
+              <a:defRPr sz="3000" b="1">
+                <a:solidFill>
+                  <a:srgbClr val="FFE600"/>
+                </a:solidFill>
+              </a:defRPr>
+            </a:pPr>
+            <a:r>
+              <a:t>Step 5: Deploy to Streamlit Cloud</a:t>
+            </a:r>
+          </a:p>
+        </p:txBody>
+      </p:sp>
+      <p:sp>
+        <p:nvSpPr>
+          <p:cNvPr id="4" name="TextBox 3"/>
+          <p:cNvSpPr txBox="1"/>
+          <p:nvPr/>
+        </p:nvSpPr>
+        <p:spPr>
+          <a:xfrm>
+            <a:off x="914400" y="1371600"/>
+            <a:ext cx="10362895" cy="5029200"/>
+          </a:xfrm>
+          <a:prstGeom prst="rect">
+            <a:avLst/>
+          </a:prstGeom>
+          <a:noFill/>
+        </p:spPr>
+        <p:txBody>
+          <a:bodyPr wrap="square">
+            <a:spAutoFit/>
+          </a:bodyPr>
+          <a:lstStyle/>
+          <a:p>
+            <a:pPr>
+              <a:spcBef>
+                <a:spcPts val="1000"/>
+              </a:spcBef>
+              <a:spcAft>
+                <a:spcPts val="400"/>
+              </a:spcAft>
+              <a:defRPr sz="2000">
+                <a:solidFill>
+                  <a:srgbClr val="FFFFFF"/>
+                </a:solidFill>
+              </a:defRPr>
+            </a:pPr>
+            <a:r>
+              <a:t>1.  Go to share.streamlit.io and sign in with GitHub</a:t>
+            </a:r>
+          </a:p>
+          <a:p>
+            <a:pPr>
+              <a:spcBef>
+                <a:spcPts val="1000"/>
+              </a:spcBef>
+              <a:spcAft>
+                <a:spcPts val="400"/>
+              </a:spcAft>
+              <a:defRPr sz="2000">
+                <a:solidFill>
+                  <a:srgbClr val="FFFFFF"/>
+                </a:solidFill>
+              </a:defRPr>
+            </a:pPr>
+            <a:r>
+              <a:t>2.  Click "New app"</a:t>
+            </a:r>
+          </a:p>
+          <a:p>
+            <a:pPr>
+              <a:spcBef>
+                <a:spcPts val="1000"/>
+              </a:spcBef>
+              <a:spcAft>
+                <a:spcPts val="400"/>
+              </a:spcAft>
+              <a:defRPr sz="2000">
+                <a:solidFill>
+                  <a:srgbClr val="FFFFFF"/>
+                </a:solidFill>
+              </a:defRPr>
+            </a:pPr>
+            <a:r>
+              <a:t>3.  Select your repository, branch: main, file: app.py</a:t>
+            </a:r>
+          </a:p>
+          <a:p>
+            <a:pPr>
+              <a:spcBef>
+                <a:spcPts val="1000"/>
+              </a:spcBef>
+              <a:spcAft>
+                <a:spcPts val="400"/>
+              </a:spcAft>
+              <a:defRPr sz="2000">
+                <a:solidFill>
+                  <a:srgbClr val="FFFFFF"/>
+                </a:solidFill>
+              </a:defRPr>
+            </a:pPr>
+            <a:r>
+              <a:t>4.  Click "Deploy"</a:t>
+            </a:r>
+          </a:p>
+          <a:p>
+            <a:pPr>
+              <a:spcBef>
+                <a:spcPts val="1000"/>
+              </a:spcBef>
+              <a:spcAft>
+                <a:spcPts val="400"/>
+              </a:spcAft>
+              <a:defRPr sz="2000">
+                <a:solidFill>
+                  <a:srgbClr val="FFFFFF"/>
+                </a:solidFill>
+              </a:defRPr>
+            </a:pPr>
+            <a:r>
+              <a:t>5.  Wait 2-3 minutes for the app to build</a:t>
+            </a:r>
+          </a:p>
+          <a:p>
+            <a:pPr>
+              <a:spcBef>
+                <a:spcPts val="1000"/>
+              </a:spcBef>
+              <a:spcAft>
+                <a:spcPts val="400"/>
+              </a:spcAft>
+              <a:defRPr sz="2000">
+                <a:solidFill>
+                  <a:srgbClr val="FFFFFF"/>
+                </a:solidFill>
+              </a:defRPr>
+            </a:pPr>
+          </a:p>
+          <a:p>
+            <a:pPr>
+              <a:spcBef>
+                <a:spcPts val="1000"/>
+              </a:spcBef>
+              <a:spcAft>
+                <a:spcPts val="400"/>
+              </a:spcAft>
+              <a:defRPr sz="2000">
+                <a:solidFill>
+                  <a:srgbClr val="FFFFFF"/>
+                </a:solidFill>
+              </a:defRPr>
+            </a:pPr>
+            <a:r>
+              <a:t>You will get a live URL like:</a:t>
+            </a:r>
+          </a:p>
+          <a:p>
+            <a:pPr>
+              <a:spcBef>
+                <a:spcPts val="1000"/>
+              </a:spcBef>
+              <a:spcAft>
+                <a:spcPts val="400"/>
+              </a:spcAft>
+              <a:defRPr sz="2000">
+                <a:solidFill>
+                  <a:srgbClr val="FFFFFF"/>
+                </a:solidFill>
+              </a:defRPr>
+            </a:pPr>
+            <a:r>
+              <a:t>   https://my-dashboard-xyz.streamlit.app</a:t>
             </a:r>
           </a:p>
         </p:txBody>

</xml_diff>

<commit_message>
Add detailed admin vs viewer access management to all guides
Co-authored-by: factory-droid[bot] <138933559+factory-droid[bot]@users.noreply.github.com>
</commit_message>
<xml_diff>
--- a/Factory_AI_Dashboard_Guide.pptx
+++ b/Factory_AI_Dashboard_Guide.pptx
@@ -26,6 +26,7 @@
     <p:sldId id="274" r:id="rId25"/>
     <p:sldId id="275" r:id="rId26"/>
     <p:sldId id="276" r:id="rId27"/>
+    <p:sldId id="277" r:id="rId28"/>
   </p:sldIdLst>
   <p:sldSz cx="12191695" cy="6858000" type="screen4x3"/>
   <p:notesSz cx="6858000" cy="9144000"/>
@@ -3404,94 +3405,76 @@
               </a:defRPr>
             </a:pPr>
             <a:r>
-              <a:t>Access model:</a:t>
-            </a:r>
-          </a:p>
-          <a:p>
-            <a:pPr>
-              <a:spcBef>
-                <a:spcPts val="1000"/>
-              </a:spcBef>
-              <a:spcAft>
-                <a:spcPts val="400"/>
-              </a:spcAft>
-              <a:defRPr sz="2000">
-                <a:solidFill>
-                  <a:srgbClr val="FFFFFF"/>
-                </a:solidFill>
-              </a:defRPr>
-            </a:pPr>
-            <a:r>
-              <a:t>   Any @ey.com email  →  View dashboard (read-only)</a:t>
-            </a:r>
-          </a:p>
-          <a:p>
-            <a:pPr>
-              <a:spcBef>
-                <a:spcPts val="1000"/>
-              </a:spcBef>
-              <a:spcAft>
-                <a:spcPts val="400"/>
-              </a:spcAft>
-              <a:defRPr sz="2000">
-                <a:solidFill>
-                  <a:srgbClr val="FFFFFF"/>
-                </a:solidFill>
-              </a:defRPr>
-            </a:pPr>
-            <a:r>
-              <a:t>   Admins you configure  →  Edit data, manage access</a:t>
-            </a:r>
-          </a:p>
-          <a:p>
-            <a:pPr>
-              <a:spcBef>
-                <a:spcPts val="1000"/>
-              </a:spcBef>
-              <a:spcAft>
-                <a:spcPts val="400"/>
-              </a:spcAft>
-              <a:defRPr sz="2000">
-                <a:solidFill>
-                  <a:srgbClr val="FFFFFF"/>
-                </a:solidFill>
-              </a:defRPr>
-            </a:pPr>
-          </a:p>
-          <a:p>
-            <a:pPr>
-              <a:spcBef>
-                <a:spcPts val="1000"/>
-              </a:spcBef>
-              <a:spcAft>
-                <a:spcPts val="400"/>
-              </a:spcAft>
-              <a:defRPr sz="2000">
-                <a:solidFill>
-                  <a:srgbClr val="FFFFFF"/>
-                </a:solidFill>
-              </a:defRPr>
-            </a:pPr>
-            <a:r>
-              <a:t>To add an admin: scroll to bottom of dashboard</a:t>
-            </a:r>
-          </a:p>
-          <a:p>
-            <a:pPr>
-              <a:spcBef>
-                <a:spcPts val="1000"/>
-              </a:spcBef>
-              <a:spcAft>
-                <a:spcPts val="400"/>
-              </a:spcAft>
-              <a:defRPr sz="2000">
-                <a:solidFill>
-                  <a:srgbClr val="FFFFFF"/>
-                </a:solidFill>
-              </a:defRPr>
-            </a:pPr>
-            <a:r>
-              <a:t>   → "Admin: Manage Admins" → enter their @ey.com email</a:t>
+              <a:t>Two roles:</a:t>
+            </a:r>
+          </a:p>
+          <a:p>
+            <a:pPr>
+              <a:spcBef>
+                <a:spcPts val="1000"/>
+              </a:spcBef>
+              <a:spcAft>
+                <a:spcPts val="400"/>
+              </a:spcAft>
+              <a:defRPr sz="2000">
+                <a:solidFill>
+                  <a:srgbClr val="FFFFFF"/>
+                </a:solidFill>
+              </a:defRPr>
+            </a:pPr>
+            <a:r>
+              <a:t>   Viewer (any @ey.com email)  →  View charts, filters, read-only data</a:t>
+            </a:r>
+          </a:p>
+          <a:p>
+            <a:pPr>
+              <a:spcBef>
+                <a:spcPts val="1000"/>
+              </a:spcBef>
+              <a:spcAft>
+                <a:spcPts val="400"/>
+              </a:spcAft>
+              <a:defRPr sz="2000">
+                <a:solidFill>
+                  <a:srgbClr val="FFFFFF"/>
+                </a:solidFill>
+              </a:defRPr>
+            </a:pPr>
+            <a:r>
+              <a:t>   Admin (people you grant)      →  Edit data, download, manage access</a:t>
+            </a:r>
+          </a:p>
+          <a:p>
+            <a:pPr>
+              <a:spcBef>
+                <a:spcPts val="1000"/>
+              </a:spcBef>
+              <a:spcAft>
+                <a:spcPts val="400"/>
+              </a:spcAft>
+              <a:defRPr sz="2000">
+                <a:solidFill>
+                  <a:srgbClr val="FFFFFF"/>
+                </a:solidFill>
+              </a:defRPr>
+            </a:pPr>
+          </a:p>
+          <a:p>
+            <a:pPr>
+              <a:spcBef>
+                <a:spcPts val="1000"/>
+              </a:spcBef>
+              <a:spcAft>
+                <a:spcPts val="400"/>
+              </a:spcAft>
+              <a:defRPr sz="2000">
+                <a:solidFill>
+                  <a:srgbClr val="FFFFFF"/>
+                </a:solidFill>
+              </a:defRPr>
+            </a:pPr>
+            <a:r>
+              <a:t>You are the first admin. Everyone else starts as a viewer.</a:t>
             </a:r>
           </a:p>
         </p:txBody>
@@ -3595,7 +3578,7 @@
               </a:defRPr>
             </a:pPr>
             <a:r>
-              <a:t>Step 7: Keep It Updated</a:t>
+              <a:t>Managing Admin vs Viewer Access</a:t>
             </a:r>
           </a:p>
         </p:txBody>
@@ -3636,127 +3619,163 @@
               </a:defRPr>
             </a:pPr>
             <a:r>
-              <a:t>To update data:</a:t>
-            </a:r>
-          </a:p>
-          <a:p>
-            <a:pPr>
-              <a:spcBef>
-                <a:spcPts val="1000"/>
-              </a:spcBef>
-              <a:spcAft>
-                <a:spcPts val="400"/>
-              </a:spcAft>
-              <a:defRPr sz="2000">
-                <a:solidFill>
-                  <a:srgbClr val="FFFFFF"/>
-                </a:solidFill>
-              </a:defRPr>
-            </a:pPr>
-            <a:r>
-              <a:t>   Tell Factory.AI: "Copy latest Excel into data folder</a:t>
-            </a:r>
-          </a:p>
-          <a:p>
-            <a:pPr>
-              <a:spcBef>
-                <a:spcPts val="1000"/>
-              </a:spcBef>
-              <a:spcAft>
-                <a:spcPts val="400"/>
-              </a:spcAft>
-              <a:defRPr sz="2000">
-                <a:solidFill>
-                  <a:srgbClr val="FFFFFF"/>
-                </a:solidFill>
-              </a:defRPr>
-            </a:pPr>
-            <a:r>
-              <a:t>   and push to GitHub"</a:t>
-            </a:r>
-          </a:p>
-          <a:p>
-            <a:pPr>
-              <a:spcBef>
-                <a:spcPts val="1000"/>
-              </a:spcBef>
-              <a:spcAft>
-                <a:spcPts val="400"/>
-              </a:spcAft>
-              <a:defRPr sz="2000">
-                <a:solidFill>
-                  <a:srgbClr val="FFFFFF"/>
-                </a:solidFill>
-              </a:defRPr>
-            </a:pPr>
-          </a:p>
-          <a:p>
-            <a:pPr>
-              <a:spcBef>
-                <a:spcPts val="1000"/>
-              </a:spcBef>
-              <a:spcAft>
-                <a:spcPts val="400"/>
-              </a:spcAft>
-              <a:defRPr sz="2000">
-                <a:solidFill>
-                  <a:srgbClr val="FFFFFF"/>
-                </a:solidFill>
-              </a:defRPr>
-            </a:pPr>
-            <a:r>
-              <a:t>To change the dashboard:</a:t>
-            </a:r>
-          </a:p>
-          <a:p>
-            <a:pPr>
-              <a:spcBef>
-                <a:spcPts val="1000"/>
-              </a:spcBef>
-              <a:spcAft>
-                <a:spcPts val="400"/>
-              </a:spcAft>
-              <a:defRPr sz="2000">
-                <a:solidFill>
-                  <a:srgbClr val="FFFFFF"/>
-                </a:solidFill>
-              </a:defRPr>
-            </a:pPr>
-            <a:r>
-              <a:t>   Describe what you want → "push changes to GitHub"</a:t>
-            </a:r>
-          </a:p>
-          <a:p>
-            <a:pPr>
-              <a:spcBef>
-                <a:spcPts val="1000"/>
-              </a:spcBef>
-              <a:spcAft>
-                <a:spcPts val="400"/>
-              </a:spcAft>
-              <a:defRPr sz="2000">
-                <a:solidFill>
-                  <a:srgbClr val="FFFFFF"/>
-                </a:solidFill>
-              </a:defRPr>
-            </a:pPr>
-          </a:p>
-          <a:p>
-            <a:pPr>
-              <a:spcBef>
-                <a:spcPts val="1000"/>
-              </a:spcBef>
-              <a:spcAft>
-                <a:spcPts val="400"/>
-              </a:spcAft>
-              <a:defRPr sz="2000">
-                <a:solidFill>
-                  <a:srgbClr val="FFFFFF"/>
-                </a:solidFill>
-              </a:defRPr>
-            </a:pPr>
-            <a:r>
-              <a:t>Streamlit Cloud redeploys automatically (~1 minute).</a:t>
+              <a:t>To give someone admin access:</a:t>
+            </a:r>
+          </a:p>
+          <a:p>
+            <a:pPr>
+              <a:spcBef>
+                <a:spcPts val="1000"/>
+              </a:spcBef>
+              <a:spcAft>
+                <a:spcPts val="400"/>
+              </a:spcAft>
+              <a:defRPr sz="2000">
+                <a:solidFill>
+                  <a:srgbClr val="FFFFFF"/>
+                </a:solidFill>
+              </a:defRPr>
+            </a:pPr>
+            <a:r>
+              <a:t>   1.  Sign in as admin &gt; scroll to 'Admin: Manage Admins'</a:t>
+            </a:r>
+          </a:p>
+          <a:p>
+            <a:pPr>
+              <a:spcBef>
+                <a:spcPts val="1000"/>
+              </a:spcBef>
+              <a:spcAft>
+                <a:spcPts val="400"/>
+              </a:spcAft>
+              <a:defRPr sz="2000">
+                <a:solidFill>
+                  <a:srgbClr val="FFFFFF"/>
+                </a:solidFill>
+              </a:defRPr>
+            </a:pPr>
+            <a:r>
+              <a:t>   2.  Enter their @ey.com email &gt; click 'Add Admin'</a:t>
+            </a:r>
+          </a:p>
+          <a:p>
+            <a:pPr>
+              <a:spcBef>
+                <a:spcPts val="1000"/>
+              </a:spcBef>
+              <a:spcAft>
+                <a:spcPts val="400"/>
+              </a:spcAft>
+              <a:defRPr sz="2000">
+                <a:solidFill>
+                  <a:srgbClr val="FFFFFF"/>
+                </a:solidFill>
+              </a:defRPr>
+            </a:pPr>
+            <a:r>
+              <a:t>   3.  They have admin access immediately</a:t>
+            </a:r>
+          </a:p>
+          <a:p>
+            <a:pPr>
+              <a:spcBef>
+                <a:spcPts val="1000"/>
+              </a:spcBef>
+              <a:spcAft>
+                <a:spcPts val="400"/>
+              </a:spcAft>
+              <a:defRPr sz="2000">
+                <a:solidFill>
+                  <a:srgbClr val="FFFFFF"/>
+                </a:solidFill>
+              </a:defRPr>
+            </a:pPr>
+          </a:p>
+          <a:p>
+            <a:pPr>
+              <a:spcBef>
+                <a:spcPts val="1000"/>
+              </a:spcBef>
+              <a:spcAft>
+                <a:spcPts val="400"/>
+              </a:spcAft>
+              <a:defRPr sz="2000">
+                <a:solidFill>
+                  <a:srgbClr val="FFFFFF"/>
+                </a:solidFill>
+              </a:defRPr>
+            </a:pPr>
+            <a:r>
+              <a:t>To remove admin access:</a:t>
+            </a:r>
+          </a:p>
+          <a:p>
+            <a:pPr>
+              <a:spcBef>
+                <a:spcPts val="1000"/>
+              </a:spcBef>
+              <a:spcAft>
+                <a:spcPts val="400"/>
+              </a:spcAft>
+              <a:defRPr sz="2000">
+                <a:solidFill>
+                  <a:srgbClr val="FFFFFF"/>
+                </a:solidFill>
+              </a:defRPr>
+            </a:pPr>
+            <a:r>
+              <a:t>   1.  Use the 'Remove admin' dropdown &gt; click 'Remove Admin'</a:t>
+            </a:r>
+          </a:p>
+          <a:p>
+            <a:pPr>
+              <a:spcBef>
+                <a:spcPts val="1000"/>
+              </a:spcBef>
+              <a:spcAft>
+                <a:spcPts val="400"/>
+              </a:spcAft>
+              <a:defRPr sz="2000">
+                <a:solidFill>
+                  <a:srgbClr val="FFFFFF"/>
+                </a:solidFill>
+              </a:defRPr>
+            </a:pPr>
+            <a:r>
+              <a:t>   2.  They revert to viewer access immediately</a:t>
+            </a:r>
+          </a:p>
+          <a:p>
+            <a:pPr>
+              <a:spcBef>
+                <a:spcPts val="1000"/>
+              </a:spcBef>
+              <a:spcAft>
+                <a:spcPts val="400"/>
+              </a:spcAft>
+              <a:defRPr sz="2000">
+                <a:solidFill>
+                  <a:srgbClr val="FFFFFF"/>
+                </a:solidFill>
+              </a:defRPr>
+            </a:pPr>
+          </a:p>
+          <a:p>
+            <a:pPr>
+              <a:spcBef>
+                <a:spcPts val="1000"/>
+              </a:spcBef>
+              <a:spcAft>
+                <a:spcPts val="400"/>
+              </a:spcAft>
+              <a:defRPr sz="2000">
+                <a:solidFill>
+                  <a:srgbClr val="FFFFFF"/>
+                </a:solidFill>
+              </a:defRPr>
+            </a:pPr>
+            <a:r>
+              <a:t>Note: You cannot remove yourself. At least one admin is required.</a:t>
             </a:r>
           </a:p>
         </p:txBody>
@@ -3860,7 +3879,7 @@
               </a:defRPr>
             </a:pPr>
             <a:r>
-              <a:t>Step 8: Activate Microsoft SSO</a:t>
+              <a:t>Step 7: Keep It Updated</a:t>
             </a:r>
           </a:p>
         </p:txBody>
@@ -3901,109 +3920,127 @@
               </a:defRPr>
             </a:pPr>
             <a:r>
-              <a:t>Your app already has SSO built in from Step 2.</a:t>
-            </a:r>
-          </a:p>
-          <a:p>
-            <a:pPr>
-              <a:spcBef>
-                <a:spcPts val="1000"/>
-              </a:spcBef>
-              <a:spcAft>
-                <a:spcPts val="400"/>
-              </a:spcAft>
-              <a:defRPr sz="2000">
-                <a:solidFill>
-                  <a:srgbClr val="FFFFFF"/>
-                </a:solidFill>
-              </a:defRPr>
-            </a:pPr>
-            <a:r>
-              <a:t>Now you activate it with the 3 values from your IT team.</a:t>
-            </a:r>
-          </a:p>
-          <a:p>
-            <a:pPr>
-              <a:spcBef>
-                <a:spcPts val="1000"/>
-              </a:spcBef>
-              <a:spcAft>
-                <a:spcPts val="400"/>
-              </a:spcAft>
-              <a:defRPr sz="2000">
-                <a:solidFill>
-                  <a:srgbClr val="FFFFFF"/>
-                </a:solidFill>
-              </a:defRPr>
-            </a:pPr>
-          </a:p>
-          <a:p>
-            <a:pPr>
-              <a:spcBef>
-                <a:spcPts val="1000"/>
-              </a:spcBef>
-              <a:spcAft>
-                <a:spcPts val="400"/>
-              </a:spcAft>
-              <a:defRPr sz="2000">
-                <a:solidFill>
-                  <a:srgbClr val="FFFFFF"/>
-                </a:solidFill>
-              </a:defRPr>
-            </a:pPr>
-            <a:r>
-              <a:t>Without SSO: anyone can type any @ey.com email — no verification.</a:t>
-            </a:r>
-          </a:p>
-          <a:p>
-            <a:pPr>
-              <a:spcBef>
-                <a:spcPts val="1000"/>
-              </a:spcBef>
-              <a:spcAft>
-                <a:spcPts val="400"/>
-              </a:spcAft>
-              <a:defRPr sz="2000">
-                <a:solidFill>
-                  <a:srgbClr val="FFFFFF"/>
-                </a:solidFill>
-              </a:defRPr>
-            </a:pPr>
-            <a:r>
-              <a:t>With SSO: users sign in with their real EY Microsoft account.</a:t>
-            </a:r>
-          </a:p>
-          <a:p>
-            <a:pPr>
-              <a:spcBef>
-                <a:spcPts val="1000"/>
-              </a:spcBef>
-              <a:spcAft>
-                <a:spcPts val="400"/>
-              </a:spcAft>
-              <a:defRPr sz="2000">
-                <a:solidFill>
-                  <a:srgbClr val="FFFFFF"/>
-                </a:solidFill>
-              </a:defRPr>
-            </a:pPr>
-          </a:p>
-          <a:p>
-            <a:pPr>
-              <a:spcBef>
-                <a:spcPts val="1000"/>
-              </a:spcBef>
-              <a:spcAft>
-                <a:spcPts val="400"/>
-              </a:spcAft>
-              <a:defRPr sz="2000">
-                <a:solidFill>
-                  <a:srgbClr val="FFFFFF"/>
-                </a:solidFill>
-              </a:defRPr>
-            </a:pPr>
-            <a:r>
-              <a:t>Zero code changes needed — you are only pasting configuration.</a:t>
+              <a:t>To update data:</a:t>
+            </a:r>
+          </a:p>
+          <a:p>
+            <a:pPr>
+              <a:spcBef>
+                <a:spcPts val="1000"/>
+              </a:spcBef>
+              <a:spcAft>
+                <a:spcPts val="400"/>
+              </a:spcAft>
+              <a:defRPr sz="2000">
+                <a:solidFill>
+                  <a:srgbClr val="FFFFFF"/>
+                </a:solidFill>
+              </a:defRPr>
+            </a:pPr>
+            <a:r>
+              <a:t>   Tell Factory.AI: "Copy latest Excel into data folder</a:t>
+            </a:r>
+          </a:p>
+          <a:p>
+            <a:pPr>
+              <a:spcBef>
+                <a:spcPts val="1000"/>
+              </a:spcBef>
+              <a:spcAft>
+                <a:spcPts val="400"/>
+              </a:spcAft>
+              <a:defRPr sz="2000">
+                <a:solidFill>
+                  <a:srgbClr val="FFFFFF"/>
+                </a:solidFill>
+              </a:defRPr>
+            </a:pPr>
+            <a:r>
+              <a:t>   and push to GitHub"</a:t>
+            </a:r>
+          </a:p>
+          <a:p>
+            <a:pPr>
+              <a:spcBef>
+                <a:spcPts val="1000"/>
+              </a:spcBef>
+              <a:spcAft>
+                <a:spcPts val="400"/>
+              </a:spcAft>
+              <a:defRPr sz="2000">
+                <a:solidFill>
+                  <a:srgbClr val="FFFFFF"/>
+                </a:solidFill>
+              </a:defRPr>
+            </a:pPr>
+          </a:p>
+          <a:p>
+            <a:pPr>
+              <a:spcBef>
+                <a:spcPts val="1000"/>
+              </a:spcBef>
+              <a:spcAft>
+                <a:spcPts val="400"/>
+              </a:spcAft>
+              <a:defRPr sz="2000">
+                <a:solidFill>
+                  <a:srgbClr val="FFFFFF"/>
+                </a:solidFill>
+              </a:defRPr>
+            </a:pPr>
+            <a:r>
+              <a:t>To change the dashboard:</a:t>
+            </a:r>
+          </a:p>
+          <a:p>
+            <a:pPr>
+              <a:spcBef>
+                <a:spcPts val="1000"/>
+              </a:spcBef>
+              <a:spcAft>
+                <a:spcPts val="400"/>
+              </a:spcAft>
+              <a:defRPr sz="2000">
+                <a:solidFill>
+                  <a:srgbClr val="FFFFFF"/>
+                </a:solidFill>
+              </a:defRPr>
+            </a:pPr>
+            <a:r>
+              <a:t>   Describe what you want → "push changes to GitHub"</a:t>
+            </a:r>
+          </a:p>
+          <a:p>
+            <a:pPr>
+              <a:spcBef>
+                <a:spcPts val="1000"/>
+              </a:spcBef>
+              <a:spcAft>
+                <a:spcPts val="400"/>
+              </a:spcAft>
+              <a:defRPr sz="2000">
+                <a:solidFill>
+                  <a:srgbClr val="FFFFFF"/>
+                </a:solidFill>
+              </a:defRPr>
+            </a:pPr>
+          </a:p>
+          <a:p>
+            <a:pPr>
+              <a:spcBef>
+                <a:spcPts val="1000"/>
+              </a:spcBef>
+              <a:spcAft>
+                <a:spcPts val="400"/>
+              </a:spcAft>
+              <a:defRPr sz="2000">
+                <a:solidFill>
+                  <a:srgbClr val="FFFFFF"/>
+                </a:solidFill>
+              </a:defRPr>
+            </a:pPr>
+            <a:r>
+              <a:t>Streamlit Cloud redeploys automatically (~1 minute).</a:t>
             </a:r>
           </a:p>
         </p:txBody>
@@ -4107,7 +4144,7 @@
               </a:defRPr>
             </a:pPr>
             <a:r>
-              <a:t>Step 8a: Register an App in Azure</a:t>
+              <a:t>Step 8: Activate Microsoft SSO</a:t>
             </a:r>
           </a:p>
         </p:txBody>
@@ -4148,130 +4185,109 @@
               </a:defRPr>
             </a:pPr>
             <a:r>
-              <a:t>You need someone with Azure AD admin access (typically IT).</a:t>
-            </a:r>
-          </a:p>
-          <a:p>
-            <a:pPr>
-              <a:spcBef>
-                <a:spcPts val="1000"/>
-              </a:spcBef>
-              <a:spcAft>
-                <a:spcPts val="400"/>
-              </a:spcAft>
-              <a:defRPr sz="2000">
-                <a:solidFill>
-                  <a:srgbClr val="FFFFFF"/>
-                </a:solidFill>
-              </a:defRPr>
-            </a:pPr>
-          </a:p>
-          <a:p>
-            <a:pPr>
-              <a:spcBef>
-                <a:spcPts val="1000"/>
-              </a:spcBef>
-              <a:spcAft>
-                <a:spcPts val="400"/>
-              </a:spcAft>
-              <a:defRPr sz="2000">
-                <a:solidFill>
-                  <a:srgbClr val="FFFFFF"/>
-                </a:solidFill>
-              </a:defRPr>
-            </a:pPr>
-            <a:r>
-              <a:t>1.  Go to portal.azure.com &gt; search 'App registrations'</a:t>
-            </a:r>
-          </a:p>
-          <a:p>
-            <a:pPr>
-              <a:spcBef>
-                <a:spcPts val="1000"/>
-              </a:spcBef>
-              <a:spcAft>
-                <a:spcPts val="400"/>
-              </a:spcAft>
-              <a:defRPr sz="2000">
-                <a:solidFill>
-                  <a:srgbClr val="FFFFFF"/>
-                </a:solidFill>
-              </a:defRPr>
-            </a:pPr>
-            <a:r>
-              <a:t>2.  Click '+ New registration'</a:t>
-            </a:r>
-          </a:p>
-          <a:p>
-            <a:pPr>
-              <a:spcBef>
-                <a:spcPts val="1000"/>
-              </a:spcBef>
-              <a:spcAft>
-                <a:spcPts val="400"/>
-              </a:spcAft>
-              <a:defRPr sz="2000">
-                <a:solidFill>
-                  <a:srgbClr val="FFFFFF"/>
-                </a:solidFill>
-              </a:defRPr>
-            </a:pPr>
-            <a:r>
-              <a:t>3.  Name: 'Factory AI Dashboard'</a:t>
-            </a:r>
-          </a:p>
-          <a:p>
-            <a:pPr>
-              <a:spcBef>
-                <a:spcPts val="1000"/>
-              </a:spcBef>
-              <a:spcAft>
-                <a:spcPts val="400"/>
-              </a:spcAft>
-              <a:defRPr sz="2000">
-                <a:solidFill>
-                  <a:srgbClr val="FFFFFF"/>
-                </a:solidFill>
-              </a:defRPr>
-            </a:pPr>
-            <a:r>
-              <a:t>4.  Account type: 'This organizational directory only' (EY only)</a:t>
-            </a:r>
-          </a:p>
-          <a:p>
-            <a:pPr>
-              <a:spcBef>
-                <a:spcPts val="1000"/>
-              </a:spcBef>
-              <a:spcAft>
-                <a:spcPts val="400"/>
-              </a:spcAft>
-              <a:defRPr sz="2000">
-                <a:solidFill>
-                  <a:srgbClr val="FFFFFF"/>
-                </a:solidFill>
-              </a:defRPr>
-            </a:pPr>
-            <a:r>
-              <a:t>5.  Redirect URI: Web &gt; your Streamlit Cloud URL</a:t>
-            </a:r>
-          </a:p>
-          <a:p>
-            <a:pPr>
-              <a:spcBef>
-                <a:spcPts val="1000"/>
-              </a:spcBef>
-              <a:spcAft>
-                <a:spcPts val="400"/>
-              </a:spcAft>
-              <a:defRPr sz="2000">
-                <a:solidFill>
-                  <a:srgbClr val="FFFFFF"/>
-                </a:solidFill>
-              </a:defRPr>
-            </a:pPr>
-            <a:r>
-              <a:t>6.  Click 'Register'</a:t>
+              <a:t>Your app already has SSO built in from Step 2.</a:t>
+            </a:r>
+          </a:p>
+          <a:p>
+            <a:pPr>
+              <a:spcBef>
+                <a:spcPts val="1000"/>
+              </a:spcBef>
+              <a:spcAft>
+                <a:spcPts val="400"/>
+              </a:spcAft>
+              <a:defRPr sz="2000">
+                <a:solidFill>
+                  <a:srgbClr val="FFFFFF"/>
+                </a:solidFill>
+              </a:defRPr>
+            </a:pPr>
+            <a:r>
+              <a:t>Now you activate it with the 3 values from your IT team.</a:t>
+            </a:r>
+          </a:p>
+          <a:p>
+            <a:pPr>
+              <a:spcBef>
+                <a:spcPts val="1000"/>
+              </a:spcBef>
+              <a:spcAft>
+                <a:spcPts val="400"/>
+              </a:spcAft>
+              <a:defRPr sz="2000">
+                <a:solidFill>
+                  <a:srgbClr val="FFFFFF"/>
+                </a:solidFill>
+              </a:defRPr>
+            </a:pPr>
+          </a:p>
+          <a:p>
+            <a:pPr>
+              <a:spcBef>
+                <a:spcPts val="1000"/>
+              </a:spcBef>
+              <a:spcAft>
+                <a:spcPts val="400"/>
+              </a:spcAft>
+              <a:defRPr sz="2000">
+                <a:solidFill>
+                  <a:srgbClr val="FFFFFF"/>
+                </a:solidFill>
+              </a:defRPr>
+            </a:pPr>
+            <a:r>
+              <a:t>Without SSO: anyone can type any @ey.com email — no verification.</a:t>
+            </a:r>
+          </a:p>
+          <a:p>
+            <a:pPr>
+              <a:spcBef>
+                <a:spcPts val="1000"/>
+              </a:spcBef>
+              <a:spcAft>
+                <a:spcPts val="400"/>
+              </a:spcAft>
+              <a:defRPr sz="2000">
+                <a:solidFill>
+                  <a:srgbClr val="FFFFFF"/>
+                </a:solidFill>
+              </a:defRPr>
+            </a:pPr>
+            <a:r>
+              <a:t>With SSO: users sign in with their real EY Microsoft account.</a:t>
+            </a:r>
+          </a:p>
+          <a:p>
+            <a:pPr>
+              <a:spcBef>
+                <a:spcPts val="1000"/>
+              </a:spcBef>
+              <a:spcAft>
+                <a:spcPts val="400"/>
+              </a:spcAft>
+              <a:defRPr sz="2000">
+                <a:solidFill>
+                  <a:srgbClr val="FFFFFF"/>
+                </a:solidFill>
+              </a:defRPr>
+            </a:pPr>
+          </a:p>
+          <a:p>
+            <a:pPr>
+              <a:spcBef>
+                <a:spcPts val="1000"/>
+              </a:spcBef>
+              <a:spcAft>
+                <a:spcPts val="400"/>
+              </a:spcAft>
+              <a:defRPr sz="2000">
+                <a:solidFill>
+                  <a:srgbClr val="FFFFFF"/>
+                </a:solidFill>
+              </a:defRPr>
+            </a:pPr>
+            <a:r>
+              <a:t>Zero code changes needed — you are only pasting configuration.</a:t>
             </a:r>
           </a:p>
         </p:txBody>
@@ -4375,7 +4391,7 @@
               </a:defRPr>
             </a:pPr>
             <a:r>
-              <a:t>Step 8b-c: Get Your Three Values</a:t>
+              <a:t>Step 8a: Register an App in Azure</a:t>
             </a:r>
           </a:p>
         </p:txBody>
@@ -4416,127 +4432,130 @@
               </a:defRPr>
             </a:pPr>
             <a:r>
-              <a:t>From the app Overview page, copy:</a:t>
-            </a:r>
-          </a:p>
-          <a:p>
-            <a:pPr>
-              <a:spcBef>
-                <a:spcPts val="1000"/>
-              </a:spcBef>
-              <a:spcAft>
-                <a:spcPts val="400"/>
-              </a:spcAft>
-              <a:defRPr sz="2000">
-                <a:solidFill>
-                  <a:srgbClr val="FFFFFF"/>
-                </a:solidFill>
-              </a:defRPr>
-            </a:pPr>
-            <a:r>
-              <a:t>   1.  Application (client) ID  →  your client_id</a:t>
-            </a:r>
-          </a:p>
-          <a:p>
-            <a:pPr>
-              <a:spcBef>
-                <a:spcPts val="1000"/>
-              </a:spcBef>
-              <a:spcAft>
-                <a:spcPts val="400"/>
-              </a:spcAft>
-              <a:defRPr sz="2000">
-                <a:solidFill>
-                  <a:srgbClr val="FFFFFF"/>
-                </a:solidFill>
-              </a:defRPr>
-            </a:pPr>
-            <a:r>
-              <a:t>   2.  Directory (tenant) ID    →  your tenant_id</a:t>
-            </a:r>
-          </a:p>
-          <a:p>
-            <a:pPr>
-              <a:spcBef>
-                <a:spcPts val="1000"/>
-              </a:spcBef>
-              <a:spcAft>
-                <a:spcPts val="400"/>
-              </a:spcAft>
-              <a:defRPr sz="2000">
-                <a:solidFill>
-                  <a:srgbClr val="FFFFFF"/>
-                </a:solidFill>
-              </a:defRPr>
-            </a:pPr>
-          </a:p>
-          <a:p>
-            <a:pPr>
-              <a:spcBef>
-                <a:spcPts val="1000"/>
-              </a:spcBef>
-              <a:spcAft>
-                <a:spcPts val="400"/>
-              </a:spcAft>
-              <a:defRPr sz="2000">
-                <a:solidFill>
-                  <a:srgbClr val="FFFFFF"/>
-                </a:solidFill>
-              </a:defRPr>
-            </a:pPr>
-            <a:r>
-              <a:t>Then go to Certificates &amp; secrets:</a:t>
-            </a:r>
-          </a:p>
-          <a:p>
-            <a:pPr>
-              <a:spcBef>
-                <a:spcPts val="1000"/>
-              </a:spcBef>
-              <a:spcAft>
-                <a:spcPts val="400"/>
-              </a:spcAft>
-              <a:defRPr sz="2000">
-                <a:solidFill>
-                  <a:srgbClr val="FFFFFF"/>
-                </a:solidFill>
-              </a:defRPr>
-            </a:pPr>
-            <a:r>
-              <a:t>   3.  Click '+ New client secret' &gt; copy the Value  →  your client_secret</a:t>
-            </a:r>
-          </a:p>
-          <a:p>
-            <a:pPr>
-              <a:spcBef>
-                <a:spcPts val="1000"/>
-              </a:spcBef>
-              <a:spcAft>
-                <a:spcPts val="400"/>
-              </a:spcAft>
-              <a:defRPr sz="2000">
-                <a:solidFill>
-                  <a:srgbClr val="FFFFFF"/>
-                </a:solidFill>
-              </a:defRPr>
-            </a:pPr>
-          </a:p>
-          <a:p>
-            <a:pPr>
-              <a:spcBef>
-                <a:spcPts val="1000"/>
-              </a:spcBef>
-              <a:spcAft>
-                <a:spcPts val="400"/>
-              </a:spcAft>
-              <a:defRPr sz="2000">
-                <a:solidFill>
-                  <a:srgbClr val="FFFFFF"/>
-                </a:solidFill>
-              </a:defRPr>
-            </a:pPr>
-            <a:r>
-              <a:t>IMPORTANT: The secret is only shown once — copy it immediately.</a:t>
+              <a:t>You need someone with Azure AD admin access (typically IT).</a:t>
+            </a:r>
+          </a:p>
+          <a:p>
+            <a:pPr>
+              <a:spcBef>
+                <a:spcPts val="1000"/>
+              </a:spcBef>
+              <a:spcAft>
+                <a:spcPts val="400"/>
+              </a:spcAft>
+              <a:defRPr sz="2000">
+                <a:solidFill>
+                  <a:srgbClr val="FFFFFF"/>
+                </a:solidFill>
+              </a:defRPr>
+            </a:pPr>
+          </a:p>
+          <a:p>
+            <a:pPr>
+              <a:spcBef>
+                <a:spcPts val="1000"/>
+              </a:spcBef>
+              <a:spcAft>
+                <a:spcPts val="400"/>
+              </a:spcAft>
+              <a:defRPr sz="2000">
+                <a:solidFill>
+                  <a:srgbClr val="FFFFFF"/>
+                </a:solidFill>
+              </a:defRPr>
+            </a:pPr>
+            <a:r>
+              <a:t>1.  Go to portal.azure.com &gt; search 'App registrations'</a:t>
+            </a:r>
+          </a:p>
+          <a:p>
+            <a:pPr>
+              <a:spcBef>
+                <a:spcPts val="1000"/>
+              </a:spcBef>
+              <a:spcAft>
+                <a:spcPts val="400"/>
+              </a:spcAft>
+              <a:defRPr sz="2000">
+                <a:solidFill>
+                  <a:srgbClr val="FFFFFF"/>
+                </a:solidFill>
+              </a:defRPr>
+            </a:pPr>
+            <a:r>
+              <a:t>2.  Click '+ New registration'</a:t>
+            </a:r>
+          </a:p>
+          <a:p>
+            <a:pPr>
+              <a:spcBef>
+                <a:spcPts val="1000"/>
+              </a:spcBef>
+              <a:spcAft>
+                <a:spcPts val="400"/>
+              </a:spcAft>
+              <a:defRPr sz="2000">
+                <a:solidFill>
+                  <a:srgbClr val="FFFFFF"/>
+                </a:solidFill>
+              </a:defRPr>
+            </a:pPr>
+            <a:r>
+              <a:t>3.  Name: 'Factory AI Dashboard'</a:t>
+            </a:r>
+          </a:p>
+          <a:p>
+            <a:pPr>
+              <a:spcBef>
+                <a:spcPts val="1000"/>
+              </a:spcBef>
+              <a:spcAft>
+                <a:spcPts val="400"/>
+              </a:spcAft>
+              <a:defRPr sz="2000">
+                <a:solidFill>
+                  <a:srgbClr val="FFFFFF"/>
+                </a:solidFill>
+              </a:defRPr>
+            </a:pPr>
+            <a:r>
+              <a:t>4.  Account type: 'This organizational directory only' (EY only)</a:t>
+            </a:r>
+          </a:p>
+          <a:p>
+            <a:pPr>
+              <a:spcBef>
+                <a:spcPts val="1000"/>
+              </a:spcBef>
+              <a:spcAft>
+                <a:spcPts val="400"/>
+              </a:spcAft>
+              <a:defRPr sz="2000">
+                <a:solidFill>
+                  <a:srgbClr val="FFFFFF"/>
+                </a:solidFill>
+              </a:defRPr>
+            </a:pPr>
+            <a:r>
+              <a:t>5.  Redirect URI: Web &gt; your Streamlit Cloud URL</a:t>
+            </a:r>
+          </a:p>
+          <a:p>
+            <a:pPr>
+              <a:spcBef>
+                <a:spcPts val="1000"/>
+              </a:spcBef>
+              <a:spcAft>
+                <a:spcPts val="400"/>
+              </a:spcAft>
+              <a:defRPr sz="2000">
+                <a:solidFill>
+                  <a:srgbClr val="FFFFFF"/>
+                </a:solidFill>
+              </a:defRPr>
+            </a:pPr>
+            <a:r>
+              <a:t>6.  Click 'Register'</a:t>
             </a:r>
           </a:p>
         </p:txBody>
@@ -4640,7 +4659,7 @@
               </a:defRPr>
             </a:pPr>
             <a:r>
-              <a:t>Step 8d: Add API Permissions</a:t>
+              <a:t>Step 8b-c: Get Your Three Values</a:t>
             </a:r>
           </a:p>
         </p:txBody>
@@ -4681,112 +4700,127 @@
               </a:defRPr>
             </a:pPr>
             <a:r>
-              <a:t>1.  Go to API permissions &gt; '+ Add a permission'</a:t>
-            </a:r>
-          </a:p>
-          <a:p>
-            <a:pPr>
-              <a:spcBef>
-                <a:spcPts val="1000"/>
-              </a:spcBef>
-              <a:spcAft>
-                <a:spcPts val="400"/>
-              </a:spcAft>
-              <a:defRPr sz="2000">
-                <a:solidFill>
-                  <a:srgbClr val="FFFFFF"/>
-                </a:solidFill>
-              </a:defRPr>
-            </a:pPr>
-            <a:r>
-              <a:t>2.  Select 'Microsoft Graph' &gt; 'Delegated permissions'</a:t>
-            </a:r>
-          </a:p>
-          <a:p>
-            <a:pPr>
-              <a:spcBef>
-                <a:spcPts val="1000"/>
-              </a:spcBef>
-              <a:spcAft>
-                <a:spcPts val="400"/>
-              </a:spcAft>
-              <a:defRPr sz="2000">
-                <a:solidFill>
-                  <a:srgbClr val="FFFFFF"/>
-                </a:solidFill>
-              </a:defRPr>
-            </a:pPr>
-            <a:r>
-              <a:t>3.  Search for 'User.Read' and check it</a:t>
-            </a:r>
-          </a:p>
-          <a:p>
-            <a:pPr>
-              <a:spcBef>
-                <a:spcPts val="1000"/>
-              </a:spcBef>
-              <a:spcAft>
-                <a:spcPts val="400"/>
-              </a:spcAft>
-              <a:defRPr sz="2000">
-                <a:solidFill>
-                  <a:srgbClr val="FFFFFF"/>
-                </a:solidFill>
-              </a:defRPr>
-            </a:pPr>
-            <a:r>
-              <a:t>4.  Click 'Add permissions'</a:t>
-            </a:r>
-          </a:p>
-          <a:p>
-            <a:pPr>
-              <a:spcBef>
-                <a:spcPts val="1000"/>
-              </a:spcBef>
-              <a:spcAft>
-                <a:spcPts val="400"/>
-              </a:spcAft>
-              <a:defRPr sz="2000">
-                <a:solidFill>
-                  <a:srgbClr val="FFFFFF"/>
-                </a:solidFill>
-              </a:defRPr>
-            </a:pPr>
-            <a:r>
-              <a:t>5.  Click 'Grant admin consent for EY'</a:t>
-            </a:r>
-          </a:p>
-          <a:p>
-            <a:pPr>
-              <a:spcBef>
-                <a:spcPts val="1000"/>
-              </a:spcBef>
-              <a:spcAft>
-                <a:spcPts val="400"/>
-              </a:spcAft>
-              <a:defRPr sz="2000">
-                <a:solidFill>
-                  <a:srgbClr val="FFFFFF"/>
-                </a:solidFill>
-              </a:defRPr>
-            </a:pPr>
-          </a:p>
-          <a:p>
-            <a:pPr>
-              <a:spcBef>
-                <a:spcPts val="1000"/>
-              </a:spcBef>
-              <a:spcAft>
-                <a:spcPts val="400"/>
-              </a:spcAft>
-              <a:defRPr sz="2000">
-                <a:solidFill>
-                  <a:srgbClr val="FFFFFF"/>
-                </a:solidFill>
-              </a:defRPr>
-            </a:pPr>
-            <a:r>
-              <a:t>If you don't see the consent button, ask a Global Admin to do it.</a:t>
+              <a:t>From the app Overview page, copy:</a:t>
+            </a:r>
+          </a:p>
+          <a:p>
+            <a:pPr>
+              <a:spcBef>
+                <a:spcPts val="1000"/>
+              </a:spcBef>
+              <a:spcAft>
+                <a:spcPts val="400"/>
+              </a:spcAft>
+              <a:defRPr sz="2000">
+                <a:solidFill>
+                  <a:srgbClr val="FFFFFF"/>
+                </a:solidFill>
+              </a:defRPr>
+            </a:pPr>
+            <a:r>
+              <a:t>   1.  Application (client) ID  →  your client_id</a:t>
+            </a:r>
+          </a:p>
+          <a:p>
+            <a:pPr>
+              <a:spcBef>
+                <a:spcPts val="1000"/>
+              </a:spcBef>
+              <a:spcAft>
+                <a:spcPts val="400"/>
+              </a:spcAft>
+              <a:defRPr sz="2000">
+                <a:solidFill>
+                  <a:srgbClr val="FFFFFF"/>
+                </a:solidFill>
+              </a:defRPr>
+            </a:pPr>
+            <a:r>
+              <a:t>   2.  Directory (tenant) ID    →  your tenant_id</a:t>
+            </a:r>
+          </a:p>
+          <a:p>
+            <a:pPr>
+              <a:spcBef>
+                <a:spcPts val="1000"/>
+              </a:spcBef>
+              <a:spcAft>
+                <a:spcPts val="400"/>
+              </a:spcAft>
+              <a:defRPr sz="2000">
+                <a:solidFill>
+                  <a:srgbClr val="FFFFFF"/>
+                </a:solidFill>
+              </a:defRPr>
+            </a:pPr>
+          </a:p>
+          <a:p>
+            <a:pPr>
+              <a:spcBef>
+                <a:spcPts val="1000"/>
+              </a:spcBef>
+              <a:spcAft>
+                <a:spcPts val="400"/>
+              </a:spcAft>
+              <a:defRPr sz="2000">
+                <a:solidFill>
+                  <a:srgbClr val="FFFFFF"/>
+                </a:solidFill>
+              </a:defRPr>
+            </a:pPr>
+            <a:r>
+              <a:t>Then go to Certificates &amp; secrets:</a:t>
+            </a:r>
+          </a:p>
+          <a:p>
+            <a:pPr>
+              <a:spcBef>
+                <a:spcPts val="1000"/>
+              </a:spcBef>
+              <a:spcAft>
+                <a:spcPts val="400"/>
+              </a:spcAft>
+              <a:defRPr sz="2000">
+                <a:solidFill>
+                  <a:srgbClr val="FFFFFF"/>
+                </a:solidFill>
+              </a:defRPr>
+            </a:pPr>
+            <a:r>
+              <a:t>   3.  Click '+ New client secret' &gt; copy the Value  →  your client_secret</a:t>
+            </a:r>
+          </a:p>
+          <a:p>
+            <a:pPr>
+              <a:spcBef>
+                <a:spcPts val="1000"/>
+              </a:spcBef>
+              <a:spcAft>
+                <a:spcPts val="400"/>
+              </a:spcAft>
+              <a:defRPr sz="2000">
+                <a:solidFill>
+                  <a:srgbClr val="FFFFFF"/>
+                </a:solidFill>
+              </a:defRPr>
+            </a:pPr>
+          </a:p>
+          <a:p>
+            <a:pPr>
+              <a:spcBef>
+                <a:spcPts val="1000"/>
+              </a:spcBef>
+              <a:spcAft>
+                <a:spcPts val="400"/>
+              </a:spcAft>
+              <a:defRPr sz="2000">
+                <a:solidFill>
+                  <a:srgbClr val="FFFFFF"/>
+                </a:solidFill>
+              </a:defRPr>
+            </a:pPr>
+            <a:r>
+              <a:t>IMPORTANT: The secret is only shown once — copy it immediately.</a:t>
             </a:r>
           </a:p>
         </p:txBody>
@@ -4890,7 +4924,7 @@
               </a:defRPr>
             </a:pPr>
             <a:r>
-              <a:t>Step 8e: Paste Values into Streamlit Cloud</a:t>
+              <a:t>Step 8d: Add API Permissions</a:t>
             </a:r>
           </a:p>
         </p:txBody>
@@ -4931,163 +4965,112 @@
               </a:defRPr>
             </a:pPr>
             <a:r>
-              <a:t>1.  Go to share.streamlit.io &gt; your app &gt; Settings &gt; Secrets</a:t>
-            </a:r>
-          </a:p>
-          <a:p>
-            <a:pPr>
-              <a:spcBef>
-                <a:spcPts val="1000"/>
-              </a:spcBef>
-              <a:spcAft>
-                <a:spcPts val="400"/>
-              </a:spcAft>
-              <a:defRPr sz="2000">
-                <a:solidFill>
-                  <a:srgbClr val="FFFFFF"/>
-                </a:solidFill>
-              </a:defRPr>
-            </a:pPr>
-            <a:r>
-              <a:t>2.  Paste:</a:t>
-            </a:r>
-          </a:p>
-          <a:p>
-            <a:pPr>
-              <a:spcBef>
-                <a:spcPts val="1000"/>
-              </a:spcBef>
-              <a:spcAft>
-                <a:spcPts val="400"/>
-              </a:spcAft>
-              <a:defRPr sz="2000">
-                <a:solidFill>
-                  <a:srgbClr val="FFFFFF"/>
-                </a:solidFill>
-              </a:defRPr>
-            </a:pPr>
-          </a:p>
-          <a:p>
-            <a:pPr>
-              <a:spcBef>
-                <a:spcPts val="1000"/>
-              </a:spcBef>
-              <a:spcAft>
-                <a:spcPts val="400"/>
-              </a:spcAft>
-              <a:defRPr sz="2000">
-                <a:solidFill>
-                  <a:srgbClr val="FFFFFF"/>
-                </a:solidFill>
-              </a:defRPr>
-            </a:pPr>
-            <a:r>
-              <a:t>     [azure]</a:t>
-            </a:r>
-          </a:p>
-          <a:p>
-            <a:pPr>
-              <a:spcBef>
-                <a:spcPts val="1000"/>
-              </a:spcBef>
-              <a:spcAft>
-                <a:spcPts val="400"/>
-              </a:spcAft>
-              <a:defRPr sz="2000">
-                <a:solidFill>
-                  <a:srgbClr val="FFFFFF"/>
-                </a:solidFill>
-              </a:defRPr>
-            </a:pPr>
-            <a:r>
-              <a:t>     client_id = "your-client-id"</a:t>
-            </a:r>
-          </a:p>
-          <a:p>
-            <a:pPr>
-              <a:spcBef>
-                <a:spcPts val="1000"/>
-              </a:spcBef>
-              <a:spcAft>
-                <a:spcPts val="400"/>
-              </a:spcAft>
-              <a:defRPr sz="2000">
-                <a:solidFill>
-                  <a:srgbClr val="FFFFFF"/>
-                </a:solidFill>
-              </a:defRPr>
-            </a:pPr>
-            <a:r>
-              <a:t>     client_secret = "your-client-secret"</a:t>
-            </a:r>
-          </a:p>
-          <a:p>
-            <a:pPr>
-              <a:spcBef>
-                <a:spcPts val="1000"/>
-              </a:spcBef>
-              <a:spcAft>
-                <a:spcPts val="400"/>
-              </a:spcAft>
-              <a:defRPr sz="2000">
-                <a:solidFill>
-                  <a:srgbClr val="FFFFFF"/>
-                </a:solidFill>
-              </a:defRPr>
-            </a:pPr>
-            <a:r>
-              <a:t>     tenant_id = "your-tenant-id"</a:t>
-            </a:r>
-          </a:p>
-          <a:p>
-            <a:pPr>
-              <a:spcBef>
-                <a:spcPts val="1000"/>
-              </a:spcBef>
-              <a:spcAft>
-                <a:spcPts val="400"/>
-              </a:spcAft>
-              <a:defRPr sz="2000">
-                <a:solidFill>
-                  <a:srgbClr val="FFFFFF"/>
-                </a:solidFill>
-              </a:defRPr>
-            </a:pPr>
-            <a:r>
-              <a:t>     redirect_uri = "https://your-app.streamlit.app"</a:t>
-            </a:r>
-          </a:p>
-          <a:p>
-            <a:pPr>
-              <a:spcBef>
-                <a:spcPts val="1000"/>
-              </a:spcBef>
-              <a:spcAft>
-                <a:spcPts val="400"/>
-              </a:spcAft>
-              <a:defRPr sz="2000">
-                <a:solidFill>
-                  <a:srgbClr val="FFFFFF"/>
-                </a:solidFill>
-              </a:defRPr>
-            </a:pPr>
-          </a:p>
-          <a:p>
-            <a:pPr>
-              <a:spcBef>
-                <a:spcPts val="1000"/>
-              </a:spcBef>
-              <a:spcAft>
-                <a:spcPts val="400"/>
-              </a:spcAft>
-              <a:defRPr sz="2000">
-                <a:solidFill>
-                  <a:srgbClr val="FFFFFF"/>
-                </a:solidFill>
-              </a:defRPr>
-            </a:pPr>
-            <a:r>
-              <a:t>3.  Click Save &gt; Reboot app. That's it — SSO is live.</a:t>
+              <a:t>1.  Go to API permissions &gt; '+ Add a permission'</a:t>
+            </a:r>
+          </a:p>
+          <a:p>
+            <a:pPr>
+              <a:spcBef>
+                <a:spcPts val="1000"/>
+              </a:spcBef>
+              <a:spcAft>
+                <a:spcPts val="400"/>
+              </a:spcAft>
+              <a:defRPr sz="2000">
+                <a:solidFill>
+                  <a:srgbClr val="FFFFFF"/>
+                </a:solidFill>
+              </a:defRPr>
+            </a:pPr>
+            <a:r>
+              <a:t>2.  Select 'Microsoft Graph' &gt; 'Delegated permissions'</a:t>
+            </a:r>
+          </a:p>
+          <a:p>
+            <a:pPr>
+              <a:spcBef>
+                <a:spcPts val="1000"/>
+              </a:spcBef>
+              <a:spcAft>
+                <a:spcPts val="400"/>
+              </a:spcAft>
+              <a:defRPr sz="2000">
+                <a:solidFill>
+                  <a:srgbClr val="FFFFFF"/>
+                </a:solidFill>
+              </a:defRPr>
+            </a:pPr>
+            <a:r>
+              <a:t>3.  Search for 'User.Read' and check it</a:t>
+            </a:r>
+          </a:p>
+          <a:p>
+            <a:pPr>
+              <a:spcBef>
+                <a:spcPts val="1000"/>
+              </a:spcBef>
+              <a:spcAft>
+                <a:spcPts val="400"/>
+              </a:spcAft>
+              <a:defRPr sz="2000">
+                <a:solidFill>
+                  <a:srgbClr val="FFFFFF"/>
+                </a:solidFill>
+              </a:defRPr>
+            </a:pPr>
+            <a:r>
+              <a:t>4.  Click 'Add permissions'</a:t>
+            </a:r>
+          </a:p>
+          <a:p>
+            <a:pPr>
+              <a:spcBef>
+                <a:spcPts val="1000"/>
+              </a:spcBef>
+              <a:spcAft>
+                <a:spcPts val="400"/>
+              </a:spcAft>
+              <a:defRPr sz="2000">
+                <a:solidFill>
+                  <a:srgbClr val="FFFFFF"/>
+                </a:solidFill>
+              </a:defRPr>
+            </a:pPr>
+            <a:r>
+              <a:t>5.  Click 'Grant admin consent for EY'</a:t>
+            </a:r>
+          </a:p>
+          <a:p>
+            <a:pPr>
+              <a:spcBef>
+                <a:spcPts val="1000"/>
+              </a:spcBef>
+              <a:spcAft>
+                <a:spcPts val="400"/>
+              </a:spcAft>
+              <a:defRPr sz="2000">
+                <a:solidFill>
+                  <a:srgbClr val="FFFFFF"/>
+                </a:solidFill>
+              </a:defRPr>
+            </a:pPr>
+          </a:p>
+          <a:p>
+            <a:pPr>
+              <a:spcBef>
+                <a:spcPts val="1000"/>
+              </a:spcBef>
+              <a:spcAft>
+                <a:spcPts val="400"/>
+              </a:spcAft>
+              <a:defRPr sz="2000">
+                <a:solidFill>
+                  <a:srgbClr val="FFFFFF"/>
+                </a:solidFill>
+              </a:defRPr>
+            </a:pPr>
+            <a:r>
+              <a:t>If you don't see the consent button, ask a Global Admin to do it.</a:t>
             </a:r>
           </a:p>
         </p:txBody>
@@ -5191,7 +5174,7 @@
               </a:defRPr>
             </a:pPr>
             <a:r>
-              <a:t>What Changes After SSO</a:t>
+              <a:t>Step 8e: Paste Values into Streamlit Cloud</a:t>
             </a:r>
           </a:p>
         </p:txBody>
@@ -5232,112 +5215,163 @@
               </a:defRPr>
             </a:pPr>
             <a:r>
-              <a:t>BEFORE:                                    AFTER:</a:t>
-            </a:r>
-          </a:p>
-          <a:p>
-            <a:pPr>
-              <a:spcBef>
-                <a:spcPts val="1000"/>
-              </a:spcBef>
-              <a:spcAft>
-                <a:spcPts val="400"/>
-              </a:spcAft>
-              <a:defRPr sz="2000">
-                <a:solidFill>
-                  <a:srgbClr val="FFFFFF"/>
-                </a:solidFill>
-              </a:defRPr>
-            </a:pPr>
-            <a:r>
-              <a:t>  Users type email in a text box              Users click 'Sign in with Microsoft'</a:t>
-            </a:r>
-          </a:p>
-          <a:p>
-            <a:pPr>
-              <a:spcBef>
-                <a:spcPts val="1000"/>
-              </a:spcBef>
-              <a:spcAft>
-                <a:spcPts val="400"/>
-              </a:spcAft>
-              <a:defRPr sz="2000">
-                <a:solidFill>
-                  <a:srgbClr val="FFFFFF"/>
-                </a:solidFill>
-              </a:defRPr>
-            </a:pPr>
-            <a:r>
-              <a:t>  No verification at all                           Microsoft verifies their identity</a:t>
-            </a:r>
-          </a:p>
-          <a:p>
-            <a:pPr>
-              <a:spcBef>
-                <a:spcPts val="1000"/>
-              </a:spcBef>
-              <a:spcAft>
-                <a:spcPts val="400"/>
-              </a:spcAft>
-              <a:defRPr sz="2000">
-                <a:solidFill>
-                  <a:srgbClr val="FFFFFF"/>
-                </a:solidFill>
-              </a:defRPr>
-            </a:pPr>
-            <a:r>
-              <a:t>  Not safe for sensitive data                  Enterprise-grade security</a:t>
-            </a:r>
-          </a:p>
-          <a:p>
-            <a:pPr>
-              <a:spcBef>
-                <a:spcPts val="1000"/>
-              </a:spcBef>
-              <a:spcAft>
-                <a:spcPts val="400"/>
-              </a:spcAft>
-              <a:defRPr sz="2000">
-                <a:solidFill>
-                  <a:srgbClr val="FFFFFF"/>
-                </a:solidFill>
-              </a:defRPr>
-            </a:pPr>
-            <a:r>
-              <a:t>  No audit trail                                      Microsoft logs all sign-ins</a:t>
-            </a:r>
-          </a:p>
-          <a:p>
-            <a:pPr>
-              <a:spcBef>
-                <a:spcPts val="1000"/>
-              </a:spcBef>
-              <a:spcAft>
-                <a:spcPts val="400"/>
-              </a:spcAft>
-              <a:defRPr sz="2000">
-                <a:solidFill>
-                  <a:srgbClr val="FFFFFF"/>
-                </a:solidFill>
-              </a:defRPr>
-            </a:pPr>
-          </a:p>
-          <a:p>
-            <a:pPr>
-              <a:spcBef>
-                <a:spcPts val="1000"/>
-              </a:spcBef>
-              <a:spcAft>
-                <a:spcPts val="400"/>
-              </a:spcAft>
-              <a:defRPr sz="2000">
-                <a:solidFill>
-                  <a:srgbClr val="FFFFFF"/>
-                </a:solidFill>
-              </a:defRPr>
-            </a:pPr>
-            <a:r>
-              <a:t>The app switches automatically — no code changes needed.</a:t>
+              <a:t>1.  Go to share.streamlit.io &gt; your app &gt; Settings &gt; Secrets</a:t>
+            </a:r>
+          </a:p>
+          <a:p>
+            <a:pPr>
+              <a:spcBef>
+                <a:spcPts val="1000"/>
+              </a:spcBef>
+              <a:spcAft>
+                <a:spcPts val="400"/>
+              </a:spcAft>
+              <a:defRPr sz="2000">
+                <a:solidFill>
+                  <a:srgbClr val="FFFFFF"/>
+                </a:solidFill>
+              </a:defRPr>
+            </a:pPr>
+            <a:r>
+              <a:t>2.  Paste:</a:t>
+            </a:r>
+          </a:p>
+          <a:p>
+            <a:pPr>
+              <a:spcBef>
+                <a:spcPts val="1000"/>
+              </a:spcBef>
+              <a:spcAft>
+                <a:spcPts val="400"/>
+              </a:spcAft>
+              <a:defRPr sz="2000">
+                <a:solidFill>
+                  <a:srgbClr val="FFFFFF"/>
+                </a:solidFill>
+              </a:defRPr>
+            </a:pPr>
+          </a:p>
+          <a:p>
+            <a:pPr>
+              <a:spcBef>
+                <a:spcPts val="1000"/>
+              </a:spcBef>
+              <a:spcAft>
+                <a:spcPts val="400"/>
+              </a:spcAft>
+              <a:defRPr sz="2000">
+                <a:solidFill>
+                  <a:srgbClr val="FFFFFF"/>
+                </a:solidFill>
+              </a:defRPr>
+            </a:pPr>
+            <a:r>
+              <a:t>     [azure]</a:t>
+            </a:r>
+          </a:p>
+          <a:p>
+            <a:pPr>
+              <a:spcBef>
+                <a:spcPts val="1000"/>
+              </a:spcBef>
+              <a:spcAft>
+                <a:spcPts val="400"/>
+              </a:spcAft>
+              <a:defRPr sz="2000">
+                <a:solidFill>
+                  <a:srgbClr val="FFFFFF"/>
+                </a:solidFill>
+              </a:defRPr>
+            </a:pPr>
+            <a:r>
+              <a:t>     client_id = "your-client-id"</a:t>
+            </a:r>
+          </a:p>
+          <a:p>
+            <a:pPr>
+              <a:spcBef>
+                <a:spcPts val="1000"/>
+              </a:spcBef>
+              <a:spcAft>
+                <a:spcPts val="400"/>
+              </a:spcAft>
+              <a:defRPr sz="2000">
+                <a:solidFill>
+                  <a:srgbClr val="FFFFFF"/>
+                </a:solidFill>
+              </a:defRPr>
+            </a:pPr>
+            <a:r>
+              <a:t>     client_secret = "your-client-secret"</a:t>
+            </a:r>
+          </a:p>
+          <a:p>
+            <a:pPr>
+              <a:spcBef>
+                <a:spcPts val="1000"/>
+              </a:spcBef>
+              <a:spcAft>
+                <a:spcPts val="400"/>
+              </a:spcAft>
+              <a:defRPr sz="2000">
+                <a:solidFill>
+                  <a:srgbClr val="FFFFFF"/>
+                </a:solidFill>
+              </a:defRPr>
+            </a:pPr>
+            <a:r>
+              <a:t>     tenant_id = "your-tenant-id"</a:t>
+            </a:r>
+          </a:p>
+          <a:p>
+            <a:pPr>
+              <a:spcBef>
+                <a:spcPts val="1000"/>
+              </a:spcBef>
+              <a:spcAft>
+                <a:spcPts val="400"/>
+              </a:spcAft>
+              <a:defRPr sz="2000">
+                <a:solidFill>
+                  <a:srgbClr val="FFFFFF"/>
+                </a:solidFill>
+              </a:defRPr>
+            </a:pPr>
+            <a:r>
+              <a:t>     redirect_uri = "https://your-app.streamlit.app"</a:t>
+            </a:r>
+          </a:p>
+          <a:p>
+            <a:pPr>
+              <a:spcBef>
+                <a:spcPts val="1000"/>
+              </a:spcBef>
+              <a:spcAft>
+                <a:spcPts val="400"/>
+              </a:spcAft>
+              <a:defRPr sz="2000">
+                <a:solidFill>
+                  <a:srgbClr val="FFFFFF"/>
+                </a:solidFill>
+              </a:defRPr>
+            </a:pPr>
+          </a:p>
+          <a:p>
+            <a:pPr>
+              <a:spcBef>
+                <a:spcPts val="1000"/>
+              </a:spcBef>
+              <a:spcAft>
+                <a:spcPts val="400"/>
+              </a:spcAft>
+              <a:defRPr sz="2000">
+                <a:solidFill>
+                  <a:srgbClr val="FFFFFF"/>
+                </a:solidFill>
+              </a:defRPr>
+            </a:pPr>
+            <a:r>
+              <a:t>3.  Click Save &gt; Reboot app. That's it — SSO is live.</a:t>
             </a:r>
           </a:p>
         </p:txBody>
@@ -5441,7 +5475,7 @@
               </a:defRPr>
             </a:pPr>
             <a:r>
-              <a:t>Reminder: Follow Up with IT</a:t>
+              <a:t>What Changes After SSO</a:t>
             </a:r>
           </a:p>
         </p:txBody>
@@ -5482,163 +5516,112 @@
               </a:defRPr>
             </a:pPr>
             <a:r>
-              <a:t>If your IT team has not yet responded to the email</a:t>
-            </a:r>
-          </a:p>
-          <a:p>
-            <a:pPr>
-              <a:spcBef>
-                <a:spcPts val="1000"/>
-              </a:spcBef>
-              <a:spcAft>
-                <a:spcPts val="400"/>
-              </a:spcAft>
-              <a:defRPr sz="2000">
-                <a:solidFill>
-                  <a:srgbClr val="FFFFFF"/>
-                </a:solidFill>
-              </a:defRPr>
-            </a:pPr>
-            <a:r>
-              <a:t>you sent at the beginning of this guide:</a:t>
-            </a:r>
-          </a:p>
-          <a:p>
-            <a:pPr>
-              <a:spcBef>
-                <a:spcPts val="1000"/>
-              </a:spcBef>
-              <a:spcAft>
-                <a:spcPts val="400"/>
-              </a:spcAft>
-              <a:defRPr sz="2000">
-                <a:solidFill>
-                  <a:srgbClr val="FFFFFF"/>
-                </a:solidFill>
-              </a:defRPr>
-            </a:pPr>
-          </a:p>
-          <a:p>
-            <a:pPr>
-              <a:spcBef>
-                <a:spcPts val="1000"/>
-              </a:spcBef>
-              <a:spcAft>
-                <a:spcPts val="400"/>
-              </a:spcAft>
-              <a:defRPr sz="2000">
-                <a:solidFill>
-                  <a:srgbClr val="FFFFFF"/>
-                </a:solidFill>
-              </a:defRPr>
-            </a:pPr>
-            <a:r>
-              <a:t>  1.  Follow up and provide your Streamlit Cloud URL</a:t>
-            </a:r>
-          </a:p>
-          <a:p>
-            <a:pPr>
-              <a:spcBef>
-                <a:spcPts val="1000"/>
-              </a:spcBef>
-              <a:spcAft>
-                <a:spcPts val="400"/>
-              </a:spcAft>
-              <a:defRPr sz="2000">
-                <a:solidFill>
-                  <a:srgbClr val="FFFFFF"/>
-                </a:solidFill>
-              </a:defRPr>
-            </a:pPr>
-            <a:r>
-              <a:t>       (from Step 5) as the redirect URI</a:t>
-            </a:r>
-          </a:p>
-          <a:p>
-            <a:pPr>
-              <a:spcBef>
-                <a:spcPts val="1000"/>
-              </a:spcBef>
-              <a:spcAft>
-                <a:spcPts val="400"/>
-              </a:spcAft>
-              <a:defRPr sz="2000">
-                <a:solidFill>
-                  <a:srgbClr val="FFFFFF"/>
-                </a:solidFill>
-              </a:defRPr>
-            </a:pPr>
-            <a:r>
-              <a:t>  2.  Share the AZURE_SSO_SETUP.md file from your</a:t>
-            </a:r>
-          </a:p>
-          <a:p>
-            <a:pPr>
-              <a:spcBef>
-                <a:spcPts val="1000"/>
-              </a:spcBef>
-              <a:spcAft>
-                <a:spcPts val="400"/>
-              </a:spcAft>
-              <a:defRPr sz="2000">
-                <a:solidFill>
-                  <a:srgbClr val="FFFFFF"/>
-                </a:solidFill>
-              </a:defRPr>
-            </a:pPr>
-            <a:r>
-              <a:t>       GitHub repository for full technical details</a:t>
-            </a:r>
-          </a:p>
-          <a:p>
-            <a:pPr>
-              <a:spcBef>
-                <a:spcPts val="1000"/>
-              </a:spcBef>
-              <a:spcAft>
-                <a:spcPts val="400"/>
-              </a:spcAft>
-              <a:defRPr sz="2000">
-                <a:solidFill>
-                  <a:srgbClr val="FFFFFF"/>
-                </a:solidFill>
-              </a:defRPr>
-            </a:pPr>
-          </a:p>
-          <a:p>
-            <a:pPr>
-              <a:spcBef>
-                <a:spcPts val="1000"/>
-              </a:spcBef>
-              <a:spcAft>
-                <a:spcPts val="400"/>
-              </a:spcAft>
-              <a:defRPr sz="2000">
-                <a:solidFill>
-                  <a:srgbClr val="FFFFFF"/>
-                </a:solidFill>
-              </a:defRPr>
-            </a:pPr>
-            <a:r>
-              <a:t>Once you have the 3 values, paste them into Streamlit</a:t>
-            </a:r>
-          </a:p>
-          <a:p>
-            <a:pPr>
-              <a:spcBef>
-                <a:spcPts val="1000"/>
-              </a:spcBef>
-              <a:spcAft>
-                <a:spcPts val="400"/>
-              </a:spcAft>
-              <a:defRPr sz="2000">
-                <a:solidFill>
-                  <a:srgbClr val="FFFFFF"/>
-                </a:solidFill>
-              </a:defRPr>
-            </a:pPr>
-            <a:r>
-              <a:t>Cloud Secrets (Step 8e) and SSO goes live instantly.</a:t>
+              <a:t>BEFORE:                                    AFTER:</a:t>
+            </a:r>
+          </a:p>
+          <a:p>
+            <a:pPr>
+              <a:spcBef>
+                <a:spcPts val="1000"/>
+              </a:spcBef>
+              <a:spcAft>
+                <a:spcPts val="400"/>
+              </a:spcAft>
+              <a:defRPr sz="2000">
+                <a:solidFill>
+                  <a:srgbClr val="FFFFFF"/>
+                </a:solidFill>
+              </a:defRPr>
+            </a:pPr>
+            <a:r>
+              <a:t>  Users type email in a text box              Users click 'Sign in with Microsoft'</a:t>
+            </a:r>
+          </a:p>
+          <a:p>
+            <a:pPr>
+              <a:spcBef>
+                <a:spcPts val="1000"/>
+              </a:spcBef>
+              <a:spcAft>
+                <a:spcPts val="400"/>
+              </a:spcAft>
+              <a:defRPr sz="2000">
+                <a:solidFill>
+                  <a:srgbClr val="FFFFFF"/>
+                </a:solidFill>
+              </a:defRPr>
+            </a:pPr>
+            <a:r>
+              <a:t>  No verification at all                           Microsoft verifies their identity</a:t>
+            </a:r>
+          </a:p>
+          <a:p>
+            <a:pPr>
+              <a:spcBef>
+                <a:spcPts val="1000"/>
+              </a:spcBef>
+              <a:spcAft>
+                <a:spcPts val="400"/>
+              </a:spcAft>
+              <a:defRPr sz="2000">
+                <a:solidFill>
+                  <a:srgbClr val="FFFFFF"/>
+                </a:solidFill>
+              </a:defRPr>
+            </a:pPr>
+            <a:r>
+              <a:t>  Not safe for sensitive data                  Enterprise-grade security</a:t>
+            </a:r>
+          </a:p>
+          <a:p>
+            <a:pPr>
+              <a:spcBef>
+                <a:spcPts val="1000"/>
+              </a:spcBef>
+              <a:spcAft>
+                <a:spcPts val="400"/>
+              </a:spcAft>
+              <a:defRPr sz="2000">
+                <a:solidFill>
+                  <a:srgbClr val="FFFFFF"/>
+                </a:solidFill>
+              </a:defRPr>
+            </a:pPr>
+            <a:r>
+              <a:t>  No audit trail                                      Microsoft logs all sign-ins</a:t>
+            </a:r>
+          </a:p>
+          <a:p>
+            <a:pPr>
+              <a:spcBef>
+                <a:spcPts val="1000"/>
+              </a:spcBef>
+              <a:spcAft>
+                <a:spcPts val="400"/>
+              </a:spcAft>
+              <a:defRPr sz="2000">
+                <a:solidFill>
+                  <a:srgbClr val="FFFFFF"/>
+                </a:solidFill>
+              </a:defRPr>
+            </a:pPr>
+          </a:p>
+          <a:p>
+            <a:pPr>
+              <a:spcBef>
+                <a:spcPts val="1000"/>
+              </a:spcBef>
+              <a:spcAft>
+                <a:spcPts val="400"/>
+              </a:spcAft>
+              <a:defRPr sz="2000">
+                <a:solidFill>
+                  <a:srgbClr val="FFFFFF"/>
+                </a:solidFill>
+              </a:defRPr>
+            </a:pPr>
+            <a:r>
+              <a:t>The app switches automatically — no code changes needed.</a:t>
             </a:r>
           </a:p>
         </p:txBody>
@@ -5742,7 +5725,7 @@
               </a:defRPr>
             </a:pPr>
             <a:r>
-              <a:t>Troubleshooting</a:t>
+              <a:t>Reminder: Follow Up with IT</a:t>
             </a:r>
           </a:p>
         </p:txBody>
@@ -5783,97 +5766,163 @@
               </a:defRPr>
             </a:pPr>
             <a:r>
-              <a:t>ModuleNotFoundError  →  "Add [package] to requirements.txt and push"</a:t>
-            </a:r>
-          </a:p>
-          <a:p>
-            <a:pPr>
-              <a:spcBef>
-                <a:spcPts val="1000"/>
-              </a:spcBef>
-              <a:spcAft>
-                <a:spcPts val="400"/>
-              </a:spcAft>
-              <a:defRPr sz="2000">
-                <a:solidFill>
-                  <a:srgbClr val="FFFFFF"/>
-                </a:solidFill>
-              </a:defRPr>
-            </a:pPr>
-            <a:r>
-              <a:t>Excel file not found  →  "Copy Excel into data folder and push"</a:t>
-            </a:r>
-          </a:p>
-          <a:p>
-            <a:pPr>
-              <a:spcBef>
-                <a:spcPts val="1000"/>
-              </a:spcBef>
-              <a:spcAft>
-                <a:spcPts val="400"/>
-              </a:spcAft>
-              <a:defRPr sz="2000">
-                <a:solidFill>
-                  <a:srgbClr val="FFFFFF"/>
-                </a:solidFill>
-              </a:defRPr>
-            </a:pPr>
-            <a:r>
-              <a:t>Dashboard broken  →  Paste error, say "fix this", then push</a:t>
-            </a:r>
-          </a:p>
-          <a:p>
-            <a:pPr>
-              <a:spcBef>
-                <a:spcPts val="1000"/>
-              </a:spcBef>
-              <a:spcAft>
-                <a:spcPts val="400"/>
-              </a:spcAft>
-              <a:defRPr sz="2000">
-                <a:solidFill>
-                  <a:srgbClr val="FFFFFF"/>
-                </a:solidFill>
-              </a:defRPr>
-            </a:pPr>
-            <a:r>
-              <a:t>Wrong data  →  Check Excel for blank rows or text in number columns</a:t>
-            </a:r>
-          </a:p>
-          <a:p>
-            <a:pPr>
-              <a:spcBef>
-                <a:spcPts val="1000"/>
-              </a:spcBef>
-              <a:spcAft>
-                <a:spcPts val="400"/>
-              </a:spcAft>
-              <a:defRPr sz="2000">
-                <a:solidFill>
-                  <a:srgbClr val="FFFFFF"/>
-                </a:solidFill>
-              </a:defRPr>
-            </a:pPr>
-            <a:r>
-              <a:t>SSO redirect error  →  Verify redirect URI matches exactly in Azure</a:t>
-            </a:r>
-          </a:p>
-          <a:p>
-            <a:pPr>
-              <a:spcBef>
-                <a:spcPts val="1000"/>
-              </a:spcBef>
-              <a:spcAft>
-                <a:spcPts val="400"/>
-              </a:spcAft>
-              <a:defRPr sz="2000">
-                <a:solidFill>
-                  <a:srgbClr val="FFFFFF"/>
-                </a:solidFill>
-              </a:defRPr>
-            </a:pPr>
-            <a:r>
-              <a:t>SSO auth failed  →  Client secret may have expired; create a new one</a:t>
+              <a:t>If your IT team has not yet responded to the email</a:t>
+            </a:r>
+          </a:p>
+          <a:p>
+            <a:pPr>
+              <a:spcBef>
+                <a:spcPts val="1000"/>
+              </a:spcBef>
+              <a:spcAft>
+                <a:spcPts val="400"/>
+              </a:spcAft>
+              <a:defRPr sz="2000">
+                <a:solidFill>
+                  <a:srgbClr val="FFFFFF"/>
+                </a:solidFill>
+              </a:defRPr>
+            </a:pPr>
+            <a:r>
+              <a:t>you sent at the beginning of this guide:</a:t>
+            </a:r>
+          </a:p>
+          <a:p>
+            <a:pPr>
+              <a:spcBef>
+                <a:spcPts val="1000"/>
+              </a:spcBef>
+              <a:spcAft>
+                <a:spcPts val="400"/>
+              </a:spcAft>
+              <a:defRPr sz="2000">
+                <a:solidFill>
+                  <a:srgbClr val="FFFFFF"/>
+                </a:solidFill>
+              </a:defRPr>
+            </a:pPr>
+          </a:p>
+          <a:p>
+            <a:pPr>
+              <a:spcBef>
+                <a:spcPts val="1000"/>
+              </a:spcBef>
+              <a:spcAft>
+                <a:spcPts val="400"/>
+              </a:spcAft>
+              <a:defRPr sz="2000">
+                <a:solidFill>
+                  <a:srgbClr val="FFFFFF"/>
+                </a:solidFill>
+              </a:defRPr>
+            </a:pPr>
+            <a:r>
+              <a:t>  1.  Follow up and provide your Streamlit Cloud URL</a:t>
+            </a:r>
+          </a:p>
+          <a:p>
+            <a:pPr>
+              <a:spcBef>
+                <a:spcPts val="1000"/>
+              </a:spcBef>
+              <a:spcAft>
+                <a:spcPts val="400"/>
+              </a:spcAft>
+              <a:defRPr sz="2000">
+                <a:solidFill>
+                  <a:srgbClr val="FFFFFF"/>
+                </a:solidFill>
+              </a:defRPr>
+            </a:pPr>
+            <a:r>
+              <a:t>       (from Step 5) as the redirect URI</a:t>
+            </a:r>
+          </a:p>
+          <a:p>
+            <a:pPr>
+              <a:spcBef>
+                <a:spcPts val="1000"/>
+              </a:spcBef>
+              <a:spcAft>
+                <a:spcPts val="400"/>
+              </a:spcAft>
+              <a:defRPr sz="2000">
+                <a:solidFill>
+                  <a:srgbClr val="FFFFFF"/>
+                </a:solidFill>
+              </a:defRPr>
+            </a:pPr>
+            <a:r>
+              <a:t>  2.  Share the AZURE_SSO_SETUP.md file from your</a:t>
+            </a:r>
+          </a:p>
+          <a:p>
+            <a:pPr>
+              <a:spcBef>
+                <a:spcPts val="1000"/>
+              </a:spcBef>
+              <a:spcAft>
+                <a:spcPts val="400"/>
+              </a:spcAft>
+              <a:defRPr sz="2000">
+                <a:solidFill>
+                  <a:srgbClr val="FFFFFF"/>
+                </a:solidFill>
+              </a:defRPr>
+            </a:pPr>
+            <a:r>
+              <a:t>       GitHub repository for full technical details</a:t>
+            </a:r>
+          </a:p>
+          <a:p>
+            <a:pPr>
+              <a:spcBef>
+                <a:spcPts val="1000"/>
+              </a:spcBef>
+              <a:spcAft>
+                <a:spcPts val="400"/>
+              </a:spcAft>
+              <a:defRPr sz="2000">
+                <a:solidFill>
+                  <a:srgbClr val="FFFFFF"/>
+                </a:solidFill>
+              </a:defRPr>
+            </a:pPr>
+          </a:p>
+          <a:p>
+            <a:pPr>
+              <a:spcBef>
+                <a:spcPts val="1000"/>
+              </a:spcBef>
+              <a:spcAft>
+                <a:spcPts val="400"/>
+              </a:spcAft>
+              <a:defRPr sz="2000">
+                <a:solidFill>
+                  <a:srgbClr val="FFFFFF"/>
+                </a:solidFill>
+              </a:defRPr>
+            </a:pPr>
+            <a:r>
+              <a:t>Once you have the 3 values, paste them into Streamlit</a:t>
+            </a:r>
+          </a:p>
+          <a:p>
+            <a:pPr>
+              <a:spcBef>
+                <a:spcPts val="1000"/>
+              </a:spcBef>
+              <a:spcAft>
+                <a:spcPts val="400"/>
+              </a:spcAft>
+              <a:defRPr sz="2000">
+                <a:solidFill>
+                  <a:srgbClr val="FFFFFF"/>
+                </a:solidFill>
+              </a:defRPr>
+            </a:pPr>
+            <a:r>
+              <a:t>Cloud Secrets (Step 8e) and SSO goes live instantly.</a:t>
             </a:r>
           </a:p>
         </p:txBody>
@@ -6227,7 +6276,7 @@
               </a:defRPr>
             </a:pPr>
             <a:r>
-              <a:t>Quick Reference: What to Tell Factory.AI</a:t>
+              <a:t>Troubleshooting</a:t>
             </a:r>
           </a:p>
         </p:txBody>
@@ -6268,79 +6317,97 @@
               </a:defRPr>
             </a:pPr>
             <a:r>
-              <a:t>Build a dashboard     →  "Create a Streamlit dashboard using [file]"</a:t>
-            </a:r>
-          </a:p>
-          <a:p>
-            <a:pPr>
-              <a:spcBef>
-                <a:spcPts val="1000"/>
-              </a:spcBef>
-              <a:spcAft>
-                <a:spcPts val="400"/>
-              </a:spcAft>
-              <a:defRPr sz="2000">
-                <a:solidFill>
-                  <a:srgbClr val="FFFFFF"/>
-                </a:solidFill>
-              </a:defRPr>
-            </a:pPr>
-            <a:r>
-              <a:t>Change a chart          →  "Change the bar chart to a line chart"</a:t>
-            </a:r>
-          </a:p>
-          <a:p>
-            <a:pPr>
-              <a:spcBef>
-                <a:spcPts val="1000"/>
-              </a:spcBef>
-              <a:spcAft>
-                <a:spcPts val="400"/>
-              </a:spcAft>
-              <a:defRPr sz="2000">
-                <a:solidFill>
-                  <a:srgbClr val="FFFFFF"/>
-                </a:solidFill>
-              </a:defRPr>
-            </a:pPr>
-            <a:r>
-              <a:t>Add a filter                 →  "Add a filter for [column name]"</a:t>
-            </a:r>
-          </a:p>
-          <a:p>
-            <a:pPr>
-              <a:spcBef>
-                <a:spcPts val="1000"/>
-              </a:spcBef>
-              <a:spcAft>
-                <a:spcPts val="400"/>
-              </a:spcAft>
-              <a:defRPr sz="2000">
-                <a:solidFill>
-                  <a:srgbClr val="FFFFFF"/>
-                </a:solidFill>
-              </a:defRPr>
-            </a:pPr>
-            <a:r>
-              <a:t>Fix an error                →  Paste the error, say "fix this"</a:t>
-            </a:r>
-          </a:p>
-          <a:p>
-            <a:pPr>
-              <a:spcBef>
-                <a:spcPts val="1000"/>
-              </a:spcBef>
-              <a:spcAft>
-                <a:spcPts val="400"/>
-              </a:spcAft>
-              <a:defRPr sz="2000">
-                <a:solidFill>
-                  <a:srgbClr val="FFFFFF"/>
-                </a:solidFill>
-              </a:defRPr>
-            </a:pPr>
-            <a:r>
-              <a:t>Push to GitHub          →  "Push the changes to GitHub"</a:t>
+              <a:t>ModuleNotFoundError  →  "Add [package] to requirements.txt and push"</a:t>
+            </a:r>
+          </a:p>
+          <a:p>
+            <a:pPr>
+              <a:spcBef>
+                <a:spcPts val="1000"/>
+              </a:spcBef>
+              <a:spcAft>
+                <a:spcPts val="400"/>
+              </a:spcAft>
+              <a:defRPr sz="2000">
+                <a:solidFill>
+                  <a:srgbClr val="FFFFFF"/>
+                </a:solidFill>
+              </a:defRPr>
+            </a:pPr>
+            <a:r>
+              <a:t>Excel file not found  →  "Copy Excel into data folder and push"</a:t>
+            </a:r>
+          </a:p>
+          <a:p>
+            <a:pPr>
+              <a:spcBef>
+                <a:spcPts val="1000"/>
+              </a:spcBef>
+              <a:spcAft>
+                <a:spcPts val="400"/>
+              </a:spcAft>
+              <a:defRPr sz="2000">
+                <a:solidFill>
+                  <a:srgbClr val="FFFFFF"/>
+                </a:solidFill>
+              </a:defRPr>
+            </a:pPr>
+            <a:r>
+              <a:t>Dashboard broken  →  Paste error, say "fix this", then push</a:t>
+            </a:r>
+          </a:p>
+          <a:p>
+            <a:pPr>
+              <a:spcBef>
+                <a:spcPts val="1000"/>
+              </a:spcBef>
+              <a:spcAft>
+                <a:spcPts val="400"/>
+              </a:spcAft>
+              <a:defRPr sz="2000">
+                <a:solidFill>
+                  <a:srgbClr val="FFFFFF"/>
+                </a:solidFill>
+              </a:defRPr>
+            </a:pPr>
+            <a:r>
+              <a:t>Wrong data  →  Check Excel for blank rows or text in number columns</a:t>
+            </a:r>
+          </a:p>
+          <a:p>
+            <a:pPr>
+              <a:spcBef>
+                <a:spcPts val="1000"/>
+              </a:spcBef>
+              <a:spcAft>
+                <a:spcPts val="400"/>
+              </a:spcAft>
+              <a:defRPr sz="2000">
+                <a:solidFill>
+                  <a:srgbClr val="FFFFFF"/>
+                </a:solidFill>
+              </a:defRPr>
+            </a:pPr>
+            <a:r>
+              <a:t>SSO redirect error  →  Verify redirect URI matches exactly in Azure</a:t>
+            </a:r>
+          </a:p>
+          <a:p>
+            <a:pPr>
+              <a:spcBef>
+                <a:spcPts val="1000"/>
+              </a:spcBef>
+              <a:spcAft>
+                <a:spcPts val="400"/>
+              </a:spcAft>
+              <a:defRPr sz="2000">
+                <a:solidFill>
+                  <a:srgbClr val="FFFFFF"/>
+                </a:solidFill>
+              </a:defRPr>
+            </a:pPr>
+            <a:r>
+              <a:t>SSO auth failed  →  Client secret may have expired; create a new one</a:t>
             </a:r>
           </a:p>
         </p:txBody>
@@ -6354,6 +6421,223 @@
 </file>
 
 <file path=ppt/slides/slide21.xml><?xml version="1.0" encoding="utf-8"?>
+<p:sld xmlns:a="http://schemas.openxmlformats.org/drawingml/2006/main" xmlns:p="http://schemas.openxmlformats.org/presentationml/2006/main" xmlns:r="http://schemas.openxmlformats.org/officeDocument/2006/relationships">
+  <p:cSld>
+    <p:bg>
+      <p:bgPr>
+        <a:solidFill>
+          <a:srgbClr val="2E2E38"/>
+        </a:solidFill>
+        <a:effectLst/>
+      </p:bgPr>
+    </p:bg>
+    <p:spTree>
+      <p:nvGrpSpPr>
+        <p:cNvPr id="1" name=""/>
+        <p:cNvGrpSpPr/>
+        <p:nvPr/>
+      </p:nvGrpSpPr>
+      <p:grpSpPr/>
+      <p:sp>
+        <p:nvSpPr>
+          <p:cNvPr id="2" name="Rectangle 1"/>
+          <p:cNvSpPr/>
+          <p:nvPr/>
+        </p:nvSpPr>
+        <p:spPr>
+          <a:xfrm>
+            <a:off x="0" y="0"/>
+            <a:ext cx="12191695" cy="73152"/>
+          </a:xfrm>
+          <a:prstGeom prst="rect">
+            <a:avLst/>
+          </a:prstGeom>
+          <a:solidFill>
+            <a:srgbClr val="FFE600"/>
+          </a:solidFill>
+          <a:ln>
+            <a:noFill/>
+          </a:ln>
+        </p:spPr>
+        <p:style>
+          <a:lnRef idx="1">
+            <a:schemeClr val="accent1"/>
+          </a:lnRef>
+          <a:fillRef idx="3">
+            <a:schemeClr val="accent1"/>
+          </a:fillRef>
+          <a:effectRef idx="2">
+            <a:schemeClr val="accent1"/>
+          </a:effectRef>
+          <a:fontRef idx="minor">
+            <a:schemeClr val="lt1"/>
+          </a:fontRef>
+        </p:style>
+        <p:txBody>
+          <a:bodyPr rtlCol="0" anchor="ctr"/>
+          <a:lstStyle/>
+          <a:p>
+            <a:pPr algn="ctr"/>
+          </a:p>
+        </p:txBody>
+      </p:sp>
+      <p:sp>
+        <p:nvSpPr>
+          <p:cNvPr id="3" name="TextBox 2"/>
+          <p:cNvSpPr txBox="1"/>
+          <p:nvPr/>
+        </p:nvSpPr>
+        <p:spPr>
+          <a:xfrm>
+            <a:off x="731520" y="320040"/>
+            <a:ext cx="10728655" cy="822960"/>
+          </a:xfrm>
+          <a:prstGeom prst="rect">
+            <a:avLst/>
+          </a:prstGeom>
+          <a:noFill/>
+        </p:spPr>
+        <p:txBody>
+          <a:bodyPr wrap="square">
+            <a:spAutoFit/>
+          </a:bodyPr>
+          <a:lstStyle/>
+          <a:p>
+            <a:pPr>
+              <a:defRPr sz="3000" b="1">
+                <a:solidFill>
+                  <a:srgbClr val="FFE600"/>
+                </a:solidFill>
+              </a:defRPr>
+            </a:pPr>
+            <a:r>
+              <a:t>Quick Reference: What to Tell Factory.AI</a:t>
+            </a:r>
+          </a:p>
+        </p:txBody>
+      </p:sp>
+      <p:sp>
+        <p:nvSpPr>
+          <p:cNvPr id="4" name="TextBox 3"/>
+          <p:cNvSpPr txBox="1"/>
+          <p:nvPr/>
+        </p:nvSpPr>
+        <p:spPr>
+          <a:xfrm>
+            <a:off x="914400" y="1371600"/>
+            <a:ext cx="10362895" cy="5029200"/>
+          </a:xfrm>
+          <a:prstGeom prst="rect">
+            <a:avLst/>
+          </a:prstGeom>
+          <a:noFill/>
+        </p:spPr>
+        <p:txBody>
+          <a:bodyPr wrap="square">
+            <a:spAutoFit/>
+          </a:bodyPr>
+          <a:lstStyle/>
+          <a:p>
+            <a:pPr>
+              <a:spcBef>
+                <a:spcPts val="1000"/>
+              </a:spcBef>
+              <a:spcAft>
+                <a:spcPts val="400"/>
+              </a:spcAft>
+              <a:defRPr sz="2000">
+                <a:solidFill>
+                  <a:srgbClr val="FFFFFF"/>
+                </a:solidFill>
+              </a:defRPr>
+            </a:pPr>
+            <a:r>
+              <a:t>Build a dashboard     →  "Create a Streamlit dashboard using [file]"</a:t>
+            </a:r>
+          </a:p>
+          <a:p>
+            <a:pPr>
+              <a:spcBef>
+                <a:spcPts val="1000"/>
+              </a:spcBef>
+              <a:spcAft>
+                <a:spcPts val="400"/>
+              </a:spcAft>
+              <a:defRPr sz="2000">
+                <a:solidFill>
+                  <a:srgbClr val="FFFFFF"/>
+                </a:solidFill>
+              </a:defRPr>
+            </a:pPr>
+            <a:r>
+              <a:t>Change a chart          →  "Change the bar chart to a line chart"</a:t>
+            </a:r>
+          </a:p>
+          <a:p>
+            <a:pPr>
+              <a:spcBef>
+                <a:spcPts val="1000"/>
+              </a:spcBef>
+              <a:spcAft>
+                <a:spcPts val="400"/>
+              </a:spcAft>
+              <a:defRPr sz="2000">
+                <a:solidFill>
+                  <a:srgbClr val="FFFFFF"/>
+                </a:solidFill>
+              </a:defRPr>
+            </a:pPr>
+            <a:r>
+              <a:t>Add a filter                 →  "Add a filter for [column name]"</a:t>
+            </a:r>
+          </a:p>
+          <a:p>
+            <a:pPr>
+              <a:spcBef>
+                <a:spcPts val="1000"/>
+              </a:spcBef>
+              <a:spcAft>
+                <a:spcPts val="400"/>
+              </a:spcAft>
+              <a:defRPr sz="2000">
+                <a:solidFill>
+                  <a:srgbClr val="FFFFFF"/>
+                </a:solidFill>
+              </a:defRPr>
+            </a:pPr>
+            <a:r>
+              <a:t>Fix an error                →  Paste the error, say "fix this"</a:t>
+            </a:r>
+          </a:p>
+          <a:p>
+            <a:pPr>
+              <a:spcBef>
+                <a:spcPts val="1000"/>
+              </a:spcBef>
+              <a:spcAft>
+                <a:spcPts val="400"/>
+              </a:spcAft>
+              <a:defRPr sz="2000">
+                <a:solidFill>
+                  <a:srgbClr val="FFFFFF"/>
+                </a:solidFill>
+              </a:defRPr>
+            </a:pPr>
+            <a:r>
+              <a:t>Push to GitHub          →  "Push the changes to GitHub"</a:t>
+            </a:r>
+          </a:p>
+        </p:txBody>
+      </p:sp>
+    </p:spTree>
+  </p:cSld>
+  <p:clrMapOvr>
+    <a:masterClrMapping/>
+  </p:clrMapOvr>
+</p:sld>
+</file>
+
+<file path=ppt/slides/slide22.xml><?xml version="1.0" encoding="utf-8"?>
 <p:sld xmlns:a="http://schemas.openxmlformats.org/drawingml/2006/main" xmlns:p="http://schemas.openxmlformats.org/presentationml/2006/main" xmlns:r="http://schemas.openxmlformats.org/officeDocument/2006/relationships">
   <p:cSld>
     <p:bg>

</xml_diff>

<commit_message>
Clarify in-app admin management in prompt and guides
Co-authored-by: factory-droid[bot] <138933559+factory-droid[bot]@users.noreply.github.com>
</commit_message>
<xml_diff>
--- a/Factory_AI_Dashboard_Guide.pptx
+++ b/Factory_AI_Dashboard_Guide.pptx
@@ -7707,43 +7707,61 @@
               </a:defRPr>
             </a:pPr>
             <a:r>
-              <a:t>    Add role-based access for @ey.com emails.</a:t>
-            </a:r>
-          </a:p>
-          <a:p>
-            <a:pPr>
-              <a:spcBef>
-                <a:spcPts val="1000"/>
-              </a:spcBef>
-              <a:spcAft>
-                <a:spcPts val="400"/>
-              </a:spcAft>
-              <a:defRPr sz="2000">
-                <a:solidFill>
-                  <a:srgbClr val="FFFFFF"/>
-                </a:solidFill>
-              </a:defRPr>
-            </a:pPr>
-            <a:r>
-              <a:t>    Include Microsoft SSO using Azure AD.</a:t>
-            </a:r>
-          </a:p>
-          <a:p>
-            <a:pPr>
-              <a:spcBef>
-                <a:spcPts val="1000"/>
-              </a:spcBef>
-              <a:spcAft>
-                <a:spcPts val="400"/>
-              </a:spcAft>
-              <a:defRPr sz="2000">
-                <a:solidFill>
-                  <a:srgbClr val="FFFFFF"/>
-                </a:solidFill>
-              </a:defRPr>
-            </a:pPr>
-            <a:r>
-              <a:t>    Fall back to email input if Azure secrets are not configured."</a:t>
+              <a:t>    Anyone with an @ey.com email can view.</a:t>
+            </a:r>
+          </a:p>
+          <a:p>
+            <a:pPr>
+              <a:spcBef>
+                <a:spcPts val="1000"/>
+              </a:spcBef>
+              <a:spcAft>
+                <a:spcPts val="400"/>
+              </a:spcAft>
+              <a:defRPr sz="2000">
+                <a:solidFill>
+                  <a:srgbClr val="FFFFFF"/>
+                </a:solidFill>
+              </a:defRPr>
+            </a:pPr>
+            <a:r>
+              <a:t>    Only admins can edit. Let me add and remove admins</a:t>
+            </a:r>
+          </a:p>
+          <a:p>
+            <a:pPr>
+              <a:spcBef>
+                <a:spcPts val="1000"/>
+              </a:spcBef>
+              <a:spcAft>
+                <a:spcPts val="400"/>
+              </a:spcAft>
+              <a:defRPr sz="2000">
+                <a:solidFill>
+                  <a:srgbClr val="FFFFFF"/>
+                </a:solidFill>
+              </a:defRPr>
+            </a:pPr>
+            <a:r>
+              <a:t>    directly inside the app by entering their @ey.com email.</a:t>
+            </a:r>
+          </a:p>
+          <a:p>
+            <a:pPr>
+              <a:spcBef>
+                <a:spcPts val="1000"/>
+              </a:spcBef>
+              <a:spcAft>
+                <a:spcPts val="400"/>
+              </a:spcAft>
+              <a:defRPr sz="2000">
+                <a:solidFill>
+                  <a:srgbClr val="FFFFFF"/>
+                </a:solidFill>
+              </a:defRPr>
+            </a:pPr>
+            <a:r>
+              <a:t>    Include Microsoft SSO using Azure AD."</a:t>
             </a:r>
           </a:p>
           <a:p>

</xml_diff>

<commit_message>
Add SSO fallback line to PPT Step 2 prompt
Co-authored-by: factory-droid[bot] <138933559+factory-droid[bot]@users.noreply.github.com>
</commit_message>
<xml_diff>
--- a/Factory_AI_Dashboard_Guide.pptx
+++ b/Factory_AI_Dashboard_Guide.pptx
@@ -7761,7 +7761,25 @@
               </a:defRPr>
             </a:pPr>
             <a:r>
-              <a:t>    Include Microsoft SSO using Azure AD."</a:t>
+              <a:t>    Include Microsoft SSO using Azure AD. Fall back to</a:t>
+            </a:r>
+          </a:p>
+          <a:p>
+            <a:pPr>
+              <a:spcBef>
+                <a:spcPts val="1000"/>
+              </a:spcBef>
+              <a:spcAft>
+                <a:spcPts val="400"/>
+              </a:spcAft>
+              <a:defRPr sz="2000">
+                <a:solidFill>
+                  <a:srgbClr val="FFFFFF"/>
+                </a:solidFill>
+              </a:defRPr>
+            </a:pPr>
+            <a:r>
+              <a:t>    manual email input if Azure secrets are not yet configured."</a:t>
             </a:r>
           </a:p>
           <a:p>

</xml_diff>